<commit_message>
update: Latest outputs, .gitignore, and frontend fixes
</commit_message>
<xml_diff>
--- a/outputs/final_presentation.pptx
+++ b/outputs/final_presentation.pptx
@@ -120,1900 +120,6 @@
     </a:lvl9pPr>
   </p:defaultTextStyle>
 </p:presentation>
-</file>
-
-<file path=ppt/charts/chart1.xml><?xml version="1.0" encoding="utf-8"?>
-<c:chartSpace xmlns:c="http://schemas.openxmlformats.org/drawingml/2006/chart" xmlns:a="http://schemas.openxmlformats.org/drawingml/2006/main" xmlns:r="http://schemas.openxmlformats.org/officeDocument/2006/relationships">
-  <c:date1904 val="0"/>
-  <c:chart>
-    <c:title>
-      <c:tx>
-        <c:rich>
-          <a:bodyPr/>
-          <a:lstStyle/>
-          <a:p>
-            <a:r>
-              <a:t>市場規模趨勢 — 流通卡數與簽帳金額</a:t>
-            </a:r>
-          </a:p>
-        </c:rich>
-      </c:tx>
-      <c:layout/>
-      <c:overlay val="0"/>
-    </c:title>
-    <c:autoTitleDeleted val="0"/>
-    <c:plotArea>
-      <c:barChart>
-        <c:barDir val="col"/>
-        <c:grouping val="clustered"/>
-        <c:ser>
-          <c:idx val="0"/>
-          <c:order val="0"/>
-          <c:tx>
-            <c:strRef>
-              <c:f>Sheet1!$B$1</c:f>
-              <c:strCache>
-                <c:ptCount val="1"/>
-                <c:pt idx="0">
-                  <c:v>流通卡數(萬張)</c:v>
-                </c:pt>
-              </c:strCache>
-            </c:strRef>
-          </c:tx>
-          <c:cat>
-            <c:strRef>
-              <c:f>Sheet1!$A$2:$A$13</c:f>
-              <c:strCache>
-                <c:ptCount val="12"/>
-                <c:pt idx="0">
-                  <c:v>1月</c:v>
-                </c:pt>
-                <c:pt idx="1">
-                  <c:v>2月</c:v>
-                </c:pt>
-                <c:pt idx="2">
-                  <c:v>3月</c:v>
-                </c:pt>
-                <c:pt idx="3">
-                  <c:v>4月</c:v>
-                </c:pt>
-                <c:pt idx="4">
-                  <c:v>5月</c:v>
-                </c:pt>
-                <c:pt idx="5">
-                  <c:v>6月</c:v>
-                </c:pt>
-                <c:pt idx="6">
-                  <c:v>7月</c:v>
-                </c:pt>
-                <c:pt idx="7">
-                  <c:v>8月</c:v>
-                </c:pt>
-                <c:pt idx="8">
-                  <c:v>9月</c:v>
-                </c:pt>
-                <c:pt idx="9">
-                  <c:v>10月</c:v>
-                </c:pt>
-                <c:pt idx="10">
-                  <c:v>11月</c:v>
-                </c:pt>
-                <c:pt idx="11">
-                  <c:v>12月</c:v>
-                </c:pt>
-              </c:strCache>
-            </c:strRef>
-          </c:cat>
-          <c:val>
-            <c:numRef>
-              <c:f>Sheet1!$B$2:$B$13</c:f>
-              <c:numCache>
-                <c:formatCode>General</c:formatCode>
-                <c:ptCount val="12"/>
-                <c:pt idx="0">
-                  <c:v>5865.4745</c:v>
-                </c:pt>
-                <c:pt idx="1">
-                  <c:v>5874.7562</c:v>
-                </c:pt>
-                <c:pt idx="2">
-                  <c:v>5899.4262</c:v>
-                </c:pt>
-                <c:pt idx="3">
-                  <c:v>5938.8667</c:v>
-                </c:pt>
-                <c:pt idx="4">
-                  <c:v>5979.5907</c:v>
-                </c:pt>
-                <c:pt idx="5">
-                  <c:v>5986.9255</c:v>
-                </c:pt>
-                <c:pt idx="6">
-                  <c:v>5994.7219</c:v>
-                </c:pt>
-                <c:pt idx="7">
-                  <c:v>6014.9284</c:v>
-                </c:pt>
-                <c:pt idx="8">
-                  <c:v>6035.4497</c:v>
-                </c:pt>
-                <c:pt idx="9">
-                  <c:v>6047.9206</c:v>
-                </c:pt>
-                <c:pt idx="10">
-                  <c:v>6042.4521</c:v>
-                </c:pt>
-                <c:pt idx="11">
-                  <c:v>6048.5911</c:v>
-                </c:pt>
-              </c:numCache>
-            </c:numRef>
-          </c:val>
-        </c:ser>
-        <c:ser>
-          <c:idx val="1"/>
-          <c:order val="1"/>
-          <c:tx>
-            <c:strRef>
-              <c:f>Sheet1!$C$1</c:f>
-              <c:strCache>
-                <c:ptCount val="1"/>
-                <c:pt idx="0">
-                  <c:v>簽帳金額(億元)</c:v>
-                </c:pt>
-              </c:strCache>
-            </c:strRef>
-          </c:tx>
-          <c:cat>
-            <c:strRef>
-              <c:f>Sheet1!$A$2:$A$13</c:f>
-              <c:strCache>
-                <c:ptCount val="12"/>
-                <c:pt idx="0">
-                  <c:v>1月</c:v>
-                </c:pt>
-                <c:pt idx="1">
-                  <c:v>2月</c:v>
-                </c:pt>
-                <c:pt idx="2">
-                  <c:v>3月</c:v>
-                </c:pt>
-                <c:pt idx="3">
-                  <c:v>4月</c:v>
-                </c:pt>
-                <c:pt idx="4">
-                  <c:v>5月</c:v>
-                </c:pt>
-                <c:pt idx="5">
-                  <c:v>6月</c:v>
-                </c:pt>
-                <c:pt idx="6">
-                  <c:v>7月</c:v>
-                </c:pt>
-                <c:pt idx="7">
-                  <c:v>8月</c:v>
-                </c:pt>
-                <c:pt idx="8">
-                  <c:v>9月</c:v>
-                </c:pt>
-                <c:pt idx="9">
-                  <c:v>10月</c:v>
-                </c:pt>
-                <c:pt idx="10">
-                  <c:v>11月</c:v>
-                </c:pt>
-                <c:pt idx="11">
-                  <c:v>12月</c:v>
-                </c:pt>
-              </c:strCache>
-            </c:strRef>
-          </c:cat>
-          <c:val>
-            <c:numRef>
-              <c:f>Sheet1!$C$2:$C$13</c:f>
-              <c:numCache>
-                <c:formatCode>General</c:formatCode>
-                <c:ptCount val="12"/>
-                <c:pt idx="0">
-                  <c:v>338.561389</c:v>
-                </c:pt>
-                <c:pt idx="1">
-                  <c:v>395.294658</c:v>
-                </c:pt>
-                <c:pt idx="2">
-                  <c:v>377.172642</c:v>
-                </c:pt>
-                <c:pt idx="3">
-                  <c:v>373.344235</c:v>
-                </c:pt>
-                <c:pt idx="4">
-                  <c:v>371.785303</c:v>
-                </c:pt>
-                <c:pt idx="5">
-                  <c:v>393.715829</c:v>
-                </c:pt>
-                <c:pt idx="6">
-                  <c:v>653.264628</c:v>
-                </c:pt>
-                <c:pt idx="7">
-                  <c:v>376.250456</c:v>
-                </c:pt>
-                <c:pt idx="8">
-                  <c:v>403.174279</c:v>
-                </c:pt>
-                <c:pt idx="9">
-                  <c:v>453.412126</c:v>
-                </c:pt>
-                <c:pt idx="10">
-                  <c:v>396.704763</c:v>
-                </c:pt>
-                <c:pt idx="11">
-                  <c:v>453.663538</c:v>
-                </c:pt>
-              </c:numCache>
-            </c:numRef>
-          </c:val>
-        </c:ser>
-        <c:axId val="-2068027336"/>
-        <c:axId val="-2113994440"/>
-      </c:barChart>
-      <c:catAx>
-        <c:axId val="-2068027336"/>
-        <c:scaling>
-          <c:orientation val="minMax"/>
-        </c:scaling>
-        <c:delete val="0"/>
-        <c:axPos val="b"/>
-        <c:majorTickMark val="out"/>
-        <c:minorTickMark val="none"/>
-        <c:tickLblPos val="nextTo"/>
-        <c:crossAx val="-2113994440"/>
-        <c:crosses val="autoZero"/>
-        <c:auto val="1"/>
-        <c:lblAlgn val="ctr"/>
-        <c:lblOffset val="100"/>
-        <c:noMultiLvlLbl val="0"/>
-      </c:catAx>
-      <c:valAx>
-        <c:axId val="-2113994440"/>
-        <c:scaling/>
-        <c:delete val="0"/>
-        <c:axPos val="l"/>
-        <c:majorGridlines/>
-        <c:majorTickMark val="out"/>
-        <c:minorTickMark val="none"/>
-        <c:tickLblPos val="nextTo"/>
-        <c:crossAx val="-2068027336"/>
-        <c:crosses val="autoZero"/>
-      </c:valAx>
-    </c:plotArea>
-    <c:dispBlanksAs val="gap"/>
-  </c:chart>
-  <c:txPr>
-    <a:bodyPr/>
-    <a:lstStyle/>
-    <a:p>
-      <a:pPr>
-        <a:defRPr sz="1800"/>
-      </a:pPr>
-      <a:endParaRPr lang="en-US"/>
-    </a:p>
-  </c:txPr>
-  <c:externalData r:id="rId1">
-    <c:autoUpdate val="0"/>
-  </c:externalData>
-</c:chartSpace>
-</file>
-
-<file path=ppt/charts/chart2.xml><?xml version="1.0" encoding="utf-8"?>
-<c:chartSpace xmlns:c="http://schemas.openxmlformats.org/drawingml/2006/chart" xmlns:a="http://schemas.openxmlformats.org/drawingml/2006/main" xmlns:r="http://schemas.openxmlformats.org/officeDocument/2006/relationships">
-  <c:date1904 val="0"/>
-  <c:chart>
-    <c:title>
-      <c:tx>
-        <c:rich>
-          <a:bodyPr/>
-          <a:lstStyle/>
-          <a:p>
-            <a:r>
-              <a:t>流通卡數市占率排名 Top 10（11412）</a:t>
-            </a:r>
-          </a:p>
-        </c:rich>
-      </c:tx>
-      <c:layout/>
-      <c:overlay val="0"/>
-    </c:title>
-    <c:autoTitleDeleted val="0"/>
-    <c:plotArea>
-      <c:barChart>
-        <c:barDir val="col"/>
-        <c:grouping val="clustered"/>
-        <c:ser>
-          <c:idx val="0"/>
-          <c:order val="0"/>
-          <c:tx>
-            <c:strRef>
-              <c:f>Sheet1!$B$1</c:f>
-              <c:strCache>
-                <c:ptCount val="1"/>
-                <c:pt idx="0">
-                  <c:v>市占率(%)</c:v>
-                </c:pt>
-              </c:strCache>
-            </c:strRef>
-          </c:tx>
-          <c:spPr>
-            <a:solidFill>
-              <a:srgbClr val="003366"/>
-            </a:solidFill>
-          </c:spPr>
-          <c:cat>
-            <c:strRef>
-              <c:f>Sheet1!$A$2:$A$11</c:f>
-              <c:strCache>
-                <c:ptCount val="10"/>
-                <c:pt idx="0">
-                  <c:v>中國信託</c:v>
-                </c:pt>
-                <c:pt idx="1">
-                  <c:v>玉山</c:v>
-                </c:pt>
-                <c:pt idx="2">
-                  <c:v>台北富邦</c:v>
-                </c:pt>
-                <c:pt idx="3">
-                  <c:v>國泰世華</c:v>
-                </c:pt>
-                <c:pt idx="4">
-                  <c:v>台新</c:v>
-                </c:pt>
-                <c:pt idx="5">
-                  <c:v>星展(台灣)</c:v>
-                </c:pt>
-                <c:pt idx="6">
-                  <c:v>聯邦</c:v>
-                </c:pt>
-                <c:pt idx="7">
-                  <c:v>永豐</c:v>
-                </c:pt>
-                <c:pt idx="8">
-                  <c:v>第一</c:v>
-                </c:pt>
-                <c:pt idx="9">
-                  <c:v>遠東</c:v>
-                </c:pt>
-              </c:strCache>
-            </c:strRef>
-          </c:cat>
-          <c:val>
-            <c:numRef>
-              <c:f>Sheet1!$B$2:$B$11</c:f>
-              <c:numCache>
-                <c:formatCode>General</c:formatCode>
-                <c:ptCount val="10"/>
-                <c:pt idx="0">
-                  <c:v>15.64</c:v>
-                </c:pt>
-                <c:pt idx="1">
-                  <c:v>14.46</c:v>
-                </c:pt>
-                <c:pt idx="2">
-                  <c:v>12.22</c:v>
-                </c:pt>
-                <c:pt idx="3">
-                  <c:v>12.13</c:v>
-                </c:pt>
-                <c:pt idx="4">
-                  <c:v>10.97</c:v>
-                </c:pt>
-                <c:pt idx="5">
-                  <c:v>5.5</c:v>
-                </c:pt>
-                <c:pt idx="6">
-                  <c:v>4.52</c:v>
-                </c:pt>
-                <c:pt idx="7">
-                  <c:v>4.1</c:v>
-                </c:pt>
-                <c:pt idx="8">
-                  <c:v>2.53</c:v>
-                </c:pt>
-                <c:pt idx="9">
-                  <c:v>2.13</c:v>
-                </c:pt>
-              </c:numCache>
-            </c:numRef>
-          </c:val>
-        </c:ser>
-        <c:axId val="-2068027336"/>
-        <c:axId val="-2113994440"/>
-      </c:barChart>
-      <c:catAx>
-        <c:axId val="-2068027336"/>
-        <c:scaling>
-          <c:orientation val="minMax"/>
-        </c:scaling>
-        <c:delete val="0"/>
-        <c:axPos val="b"/>
-        <c:majorTickMark val="out"/>
-        <c:minorTickMark val="none"/>
-        <c:tickLblPos val="nextTo"/>
-        <c:crossAx val="-2113994440"/>
-        <c:crosses val="autoZero"/>
-        <c:auto val="1"/>
-        <c:lblAlgn val="ctr"/>
-        <c:lblOffset val="100"/>
-        <c:noMultiLvlLbl val="0"/>
-      </c:catAx>
-      <c:valAx>
-        <c:axId val="-2113994440"/>
-        <c:scaling/>
-        <c:delete val="0"/>
-        <c:axPos val="l"/>
-        <c:majorGridlines/>
-        <c:title>
-          <c:tx>
-            <c:rich>
-              <a:bodyPr/>
-              <a:lstStyle/>
-              <a:p>
-                <a:r>
-                  <a:t>市占率 (%)</a:t>
-                </a:r>
-              </a:p>
-            </c:rich>
-          </c:tx>
-          <c:layout/>
-          <c:overlay val="0"/>
-        </c:title>
-        <c:majorTickMark val="out"/>
-        <c:minorTickMark val="none"/>
-        <c:tickLblPos val="nextTo"/>
-        <c:crossAx val="-2068027336"/>
-        <c:crosses val="autoZero"/>
-      </c:valAx>
-    </c:plotArea>
-    <c:dispBlanksAs val="gap"/>
-  </c:chart>
-  <c:txPr>
-    <a:bodyPr/>
-    <a:lstStyle/>
-    <a:p>
-      <a:pPr>
-        <a:defRPr sz="1800"/>
-      </a:pPr>
-      <a:endParaRPr lang="en-US"/>
-    </a:p>
-  </c:txPr>
-  <c:externalData r:id="rId1">
-    <c:autoUpdate val="0"/>
-  </c:externalData>
-</c:chartSpace>
-</file>
-
-<file path=ppt/charts/chart3.xml><?xml version="1.0" encoding="utf-8"?>
-<c:chartSpace xmlns:c="http://schemas.openxmlformats.org/drawingml/2006/chart" xmlns:a="http://schemas.openxmlformats.org/drawingml/2006/main" xmlns:r="http://schemas.openxmlformats.org/officeDocument/2006/relationships">
-  <c:chart>
-    <c:title>
-      <c:tx>
-        <c:rich>
-          <a:bodyPr/>
-          <a:lstStyle/>
-          <a:p>
-            <a:r>
-              <a:t>規模 vs 成長 — 流通卡數</a:t>
-            </a:r>
-          </a:p>
-        </c:rich>
-      </c:tx>
-      <c:layout/>
-      <c:overlay val="0"/>
-    </c:title>
-    <c:plotArea>
-      <c:scatterChart>
-        <c:scatterStyle val="lineMarker"/>
-        <c:varyColors val="0"/>
-        <c:ser>
-          <c:idx val="0"/>
-          <c:order val="0"/>
-          <c:tx>
-            <c:strRef>
-              <c:f>Sheet1!$B$1</c:f>
-              <c:strCache>
-                <c:ptCount val="1"/>
-                <c:pt idx="0">
-                  <c:v>銀行</c:v>
-                </c:pt>
-              </c:strCache>
-            </c:strRef>
-          </c:tx>
-          <c:spPr>
-            <a:ln w="47625">
-              <a:noFill/>
-            </a:ln>
-          </c:spPr>
-          <c:xVal>
-            <c:numRef>
-              <c:f>Sheet1!$A$2:$A$11</c:f>
-              <c:numCache>
-                <c:formatCode>General</c:formatCode>
-                <c:ptCount val="10"/>
-                <c:pt idx="0">
-                  <c:v>2.1049</c:v>
-                </c:pt>
-                <c:pt idx="1">
-                  <c:v>38.4715</c:v>
-                </c:pt>
-                <c:pt idx="2">
-                  <c:v>945.8117</c:v>
-                </c:pt>
-                <c:pt idx="3">
-                  <c:v>121.6355</c:v>
-                </c:pt>
-                <c:pt idx="4">
-                  <c:v>110.6955</c:v>
-                </c:pt>
-                <c:pt idx="5">
-                  <c:v>42.3651</c:v>
-                </c:pt>
-                <c:pt idx="6">
-                  <c:v>15.4419</c:v>
-                </c:pt>
-                <c:pt idx="7">
-                  <c:v>739.1132</c:v>
-                </c:pt>
-                <c:pt idx="8">
-                  <c:v>663.2949</c:v>
-                </c:pt>
-                <c:pt idx="9">
-                  <c:v>60.2725</c:v>
-                </c:pt>
-              </c:numCache>
-            </c:numRef>
-          </c:xVal>
-          <c:yVal>
-            <c:numRef>
-              <c:f>Sheet1!$B$2:$B$11</c:f>
-              <c:numCache>
-                <c:formatCode>General</c:formatCode>
-                <c:ptCount val="10"/>
-                <c:pt idx="0">
-                  <c:v>-0.8</c:v>
-                </c:pt>
-                <c:pt idx="1">
-                  <c:v>-0.17</c:v>
-                </c:pt>
-                <c:pt idx="2">
-                  <c:v>0.58</c:v>
-                </c:pt>
-                <c:pt idx="3">
-                  <c:v>0.03</c:v>
-                </c:pt>
-                <c:pt idx="4">
-                  <c:v>-0.39</c:v>
-                </c:pt>
-                <c:pt idx="5">
-                  <c:v>1.18</c:v>
-                </c:pt>
-                <c:pt idx="6">
-                  <c:v>0.42</c:v>
-                </c:pt>
-                <c:pt idx="7">
-                  <c:v>0.3</c:v>
-                </c:pt>
-                <c:pt idx="8">
-                  <c:v>-0.0</c:v>
-                </c:pt>
-                <c:pt idx="9">
-                  <c:v>3.6</c:v>
-                </c:pt>
-              </c:numCache>
-            </c:numRef>
-          </c:yVal>
-          <c:smooth val="0"/>
-        </c:ser>
-        <c:axId val="-2128940872"/>
-        <c:axId val="-2129643912"/>
-      </c:scatterChart>
-      <c:valAx>
-        <c:axId val="-2128940872"/>
-        <c:scaling>
-          <c:orientation val="minMax"/>
-        </c:scaling>
-        <c:delete val="0"/>
-        <c:axPos val="b"/>
-        <c:numFmt formatCode="General" sourceLinked="1"/>
-        <c:majorTickMark val="out"/>
-        <c:minorTickMark val="none"/>
-        <c:tickLblPos val="nextTo"/>
-        <c:crossAx val="-2129643912"/>
-        <c:crosses val="autoZero"/>
-        <c:crossBetween val="midCat"/>
-      </c:valAx>
-      <c:valAx>
-        <c:axId val="-2129643912"/>
-        <c:scaling>
-          <c:orientation val="minMax"/>
-        </c:scaling>
-        <c:delete val="0"/>
-        <c:axPos val="l"/>
-        <c:majorGridlines/>
-        <c:numFmt formatCode="General" sourceLinked="1"/>
-        <c:majorTickMark val="out"/>
-        <c:minorTickMark val="none"/>
-        <c:tickLblPos val="nextTo"/>
-        <c:crossAx val="-2128940872"/>
-        <c:crosses val="autoZero"/>
-        <c:crossBetween val="midCat"/>
-      </c:valAx>
-    </c:plotArea>
-    <c:legend>
-      <c:legendPos val="r"/>
-      <c:layout/>
-      <c:overlay val="0"/>
-    </c:legend>
-    <c:plotVisOnly val="1"/>
-    <c:dispBlanksAs val="gap"/>
-    <c:showDLblsOverMax val="0"/>
-  </c:chart>
-  <c:txPr>
-    <a:bodyPr/>
-    <a:lstStyle/>
-    <a:p>
-      <a:pPr>
-        <a:defRPr sz="1800"/>
-      </a:pPr>
-      <a:endParaRPr lang="en-US"/>
-    </a:p>
-  </c:txPr>
-  <c:externalData r:id="rId1">
-    <c:autoUpdate val="0"/>
-  </c:externalData>
-</c:chartSpace>
-</file>
-
-<file path=ppt/charts/chart4.xml><?xml version="1.0" encoding="utf-8"?>
-<c:chartSpace xmlns:c="http://schemas.openxmlformats.org/drawingml/2006/chart" xmlns:a="http://schemas.openxmlformats.org/drawingml/2006/main" xmlns:r="http://schemas.openxmlformats.org/officeDocument/2006/relationships">
-  <c:date1904 val="0"/>
-  <c:chart>
-    <c:title>
-      <c:tx>
-        <c:rich>
-          <a:bodyPr/>
-          <a:lstStyle/>
-          <a:p>
-            <a:r>
-              <a:t>流通卡數 vs 簽帳金額市占率比較</a:t>
-            </a:r>
-          </a:p>
-        </c:rich>
-      </c:tx>
-      <c:layout/>
-      <c:overlay val="0"/>
-    </c:title>
-    <c:autoTitleDeleted val="0"/>
-    <c:plotArea>
-      <c:barChart>
-        <c:barDir val="col"/>
-        <c:grouping val="clustered"/>
-        <c:ser>
-          <c:idx val="0"/>
-          <c:order val="0"/>
-          <c:tx>
-            <c:strRef>
-              <c:f>Sheet1!$B$1</c:f>
-              <c:strCache>
-                <c:ptCount val="1"/>
-                <c:pt idx="0">
-                  <c:v>流通卡數市占率(%)</c:v>
-                </c:pt>
-              </c:strCache>
-            </c:strRef>
-          </c:tx>
-          <c:spPr>
-            <a:solidFill>
-              <a:srgbClr val="003366"/>
-            </a:solidFill>
-          </c:spPr>
-          <c:cat>
-            <c:strRef>
-              <c:f>Sheet1!$A$2:$A$9</c:f>
-              <c:strCache>
-                <c:ptCount val="8"/>
-                <c:pt idx="0">
-                  <c:v>中國信託</c:v>
-                </c:pt>
-                <c:pt idx="1">
-                  <c:v>玉山</c:v>
-                </c:pt>
-                <c:pt idx="2">
-                  <c:v>台北富邦</c:v>
-                </c:pt>
-                <c:pt idx="3">
-                  <c:v>國泰世華</c:v>
-                </c:pt>
-                <c:pt idx="4">
-                  <c:v>台新</c:v>
-                </c:pt>
-                <c:pt idx="5">
-                  <c:v>星展(台灣)</c:v>
-                </c:pt>
-                <c:pt idx="6">
-                  <c:v>聯邦</c:v>
-                </c:pt>
-                <c:pt idx="7">
-                  <c:v>永豐</c:v>
-                </c:pt>
-              </c:strCache>
-            </c:strRef>
-          </c:cat>
-          <c:val>
-            <c:numRef>
-              <c:f>Sheet1!$B$2:$B$9</c:f>
-              <c:numCache>
-                <c:formatCode>General</c:formatCode>
-                <c:ptCount val="8"/>
-                <c:pt idx="0">
-                  <c:v>15.64</c:v>
-                </c:pt>
-                <c:pt idx="1">
-                  <c:v>14.46</c:v>
-                </c:pt>
-                <c:pt idx="2">
-                  <c:v>12.22</c:v>
-                </c:pt>
-                <c:pt idx="3">
-                  <c:v>12.13</c:v>
-                </c:pt>
-                <c:pt idx="4">
-                  <c:v>10.97</c:v>
-                </c:pt>
-                <c:pt idx="5">
-                  <c:v>5.5</c:v>
-                </c:pt>
-                <c:pt idx="6">
-                  <c:v>4.52</c:v>
-                </c:pt>
-                <c:pt idx="7">
-                  <c:v>4.1</c:v>
-                </c:pt>
-              </c:numCache>
-            </c:numRef>
-          </c:val>
-        </c:ser>
-        <c:ser>
-          <c:idx val="1"/>
-          <c:order val="1"/>
-          <c:tx>
-            <c:strRef>
-              <c:f>Sheet1!$C$1</c:f>
-              <c:strCache>
-                <c:ptCount val="1"/>
-                <c:pt idx="0">
-                  <c:v>簽帳金額市占率(%)</c:v>
-                </c:pt>
-              </c:strCache>
-            </c:strRef>
-          </c:tx>
-          <c:spPr>
-            <a:solidFill>
-              <a:srgbClr val="0066CC"/>
-            </a:solidFill>
-          </c:spPr>
-          <c:cat>
-            <c:strRef>
-              <c:f>Sheet1!$A$2:$A$9</c:f>
-              <c:strCache>
-                <c:ptCount val="8"/>
-                <c:pt idx="0">
-                  <c:v>中國信託</c:v>
-                </c:pt>
-                <c:pt idx="1">
-                  <c:v>玉山</c:v>
-                </c:pt>
-                <c:pt idx="2">
-                  <c:v>台北富邦</c:v>
-                </c:pt>
-                <c:pt idx="3">
-                  <c:v>國泰世華</c:v>
-                </c:pt>
-                <c:pt idx="4">
-                  <c:v>台新</c:v>
-                </c:pt>
-                <c:pt idx="5">
-                  <c:v>星展(台灣)</c:v>
-                </c:pt>
-                <c:pt idx="6">
-                  <c:v>聯邦</c:v>
-                </c:pt>
-                <c:pt idx="7">
-                  <c:v>永豐</c:v>
-                </c:pt>
-              </c:strCache>
-            </c:strRef>
-          </c:cat>
-          <c:val>
-            <c:numRef>
-              <c:f>Sheet1!$C$2:$C$9</c:f>
-              <c:numCache>
-                <c:formatCode>General</c:formatCode>
-                <c:ptCount val="8"/>
-                <c:pt idx="0">
-                  <c:v>18.5</c:v>
-                </c:pt>
-                <c:pt idx="1">
-                  <c:v>11.97</c:v>
-                </c:pt>
-                <c:pt idx="2">
-                  <c:v>12.98</c:v>
-                </c:pt>
-                <c:pt idx="3">
-                  <c:v>18.05</c:v>
-                </c:pt>
-                <c:pt idx="4">
-                  <c:v>10.67</c:v>
-                </c:pt>
-                <c:pt idx="5">
-                  <c:v>5.29</c:v>
-                </c:pt>
-                <c:pt idx="6">
-                  <c:v>3.31</c:v>
-                </c:pt>
-                <c:pt idx="7">
-                  <c:v>3.49</c:v>
-                </c:pt>
-              </c:numCache>
-            </c:numRef>
-          </c:val>
-        </c:ser>
-        <c:axId val="-2068027336"/>
-        <c:axId val="-2113994440"/>
-      </c:barChart>
-      <c:catAx>
-        <c:axId val="-2068027336"/>
-        <c:scaling>
-          <c:orientation val="minMax"/>
-        </c:scaling>
-        <c:delete val="0"/>
-        <c:axPos val="b"/>
-        <c:majorTickMark val="out"/>
-        <c:minorTickMark val="none"/>
-        <c:tickLblPos val="nextTo"/>
-        <c:crossAx val="-2113994440"/>
-        <c:crosses val="autoZero"/>
-        <c:auto val="1"/>
-        <c:lblAlgn val="ctr"/>
-        <c:lblOffset val="100"/>
-        <c:noMultiLvlLbl val="0"/>
-      </c:catAx>
-      <c:valAx>
-        <c:axId val="-2113994440"/>
-        <c:scaling/>
-        <c:delete val="0"/>
-        <c:axPos val="l"/>
-        <c:majorGridlines/>
-        <c:title>
-          <c:tx>
-            <c:rich>
-              <a:bodyPr/>
-              <a:lstStyle/>
-              <a:p>
-                <a:r>
-                  <a:t>市占率 (%)</a:t>
-                </a:r>
-              </a:p>
-            </c:rich>
-          </c:tx>
-          <c:layout/>
-          <c:overlay val="0"/>
-        </c:title>
-        <c:majorTickMark val="out"/>
-        <c:minorTickMark val="none"/>
-        <c:tickLblPos val="nextTo"/>
-        <c:crossAx val="-2068027336"/>
-        <c:crosses val="autoZero"/>
-      </c:valAx>
-    </c:plotArea>
-    <c:dispBlanksAs val="gap"/>
-  </c:chart>
-  <c:txPr>
-    <a:bodyPr/>
-    <a:lstStyle/>
-    <a:p>
-      <a:pPr>
-        <a:defRPr sz="1800"/>
-      </a:pPr>
-      <a:endParaRPr lang="en-US"/>
-    </a:p>
-  </c:txPr>
-  <c:externalData r:id="rId1">
-    <c:autoUpdate val="0"/>
-  </c:externalData>
-</c:chartSpace>
-</file>
-
-<file path=ppt/charts/chart5.xml><?xml version="1.0" encoding="utf-8"?>
-<c:chartSpace xmlns:c="http://schemas.openxmlformats.org/drawingml/2006/chart" xmlns:a="http://schemas.openxmlformats.org/drawingml/2006/main" xmlns:r="http://schemas.openxmlformats.org/officeDocument/2006/relationships">
-  <c:date1904 val="0"/>
-  <c:chart>
-    <c:title>
-      <c:tx>
-        <c:rich>
-          <a:bodyPr/>
-          <a:lstStyle/>
-          <a:p>
-            <a:r>
-              <a:t>平均每卡月簽帳金額（元/卡，11412）</a:t>
-            </a:r>
-          </a:p>
-        </c:rich>
-      </c:tx>
-      <c:layout/>
-      <c:overlay val="0"/>
-    </c:title>
-    <c:autoTitleDeleted val="0"/>
-    <c:plotArea>
-      <c:barChart>
-        <c:barDir val="col"/>
-        <c:grouping val="clustered"/>
-        <c:ser>
-          <c:idx val="0"/>
-          <c:order val="0"/>
-          <c:tx>
-            <c:strRef>
-              <c:f>Sheet1!$B$1</c:f>
-              <c:strCache>
-                <c:ptCount val="1"/>
-                <c:pt idx="0">
-                  <c:v>每卡簽帳金額(元)</c:v>
-                </c:pt>
-              </c:strCache>
-            </c:strRef>
-          </c:tx>
-          <c:spPr>
-            <a:solidFill>
-              <a:srgbClr val="003366"/>
-            </a:solidFill>
-          </c:spPr>
-          <c:cat>
-            <c:strRef>
-              <c:f>Sheet1!$A$2:$A$9</c:f>
-              <c:strCache>
-                <c:ptCount val="8"/>
-                <c:pt idx="0">
-                  <c:v>中國信託</c:v>
-                </c:pt>
-                <c:pt idx="1">
-                  <c:v>玉山</c:v>
-                </c:pt>
-                <c:pt idx="2">
-                  <c:v>台北富邦</c:v>
-                </c:pt>
-                <c:pt idx="3">
-                  <c:v>國泰世華</c:v>
-                </c:pt>
-                <c:pt idx="4">
-                  <c:v>台新</c:v>
-                </c:pt>
-                <c:pt idx="5">
-                  <c:v>星展(台灣)</c:v>
-                </c:pt>
-                <c:pt idx="6">
-                  <c:v>聯邦</c:v>
-                </c:pt>
-                <c:pt idx="7">
-                  <c:v>永豐</c:v>
-                </c:pt>
-              </c:strCache>
-            </c:strRef>
-          </c:cat>
-          <c:val>
-            <c:numRef>
-              <c:f>Sheet1!$B$2:$B$9</c:f>
-              <c:numCache>
-                <c:formatCode>General</c:formatCode>
-                <c:ptCount val="8"/>
-                <c:pt idx="0">
-                  <c:v>8873.0</c:v>
-                </c:pt>
-                <c:pt idx="1">
-                  <c:v>6207.0</c:v>
-                </c:pt>
-                <c:pt idx="2">
-                  <c:v>7965.0</c:v>
-                </c:pt>
-                <c:pt idx="3">
-                  <c:v>11159.0</c:v>
-                </c:pt>
-                <c:pt idx="4">
-                  <c:v>7297.0</c:v>
-                </c:pt>
-                <c:pt idx="5">
-                  <c:v>7216.0</c:v>
-                </c:pt>
-                <c:pt idx="6">
-                  <c:v>5491.0</c:v>
-                </c:pt>
-                <c:pt idx="7">
-                  <c:v>6390.0</c:v>
-                </c:pt>
-              </c:numCache>
-            </c:numRef>
-          </c:val>
-        </c:ser>
-        <c:axId val="-2068027336"/>
-        <c:axId val="-2113994440"/>
-      </c:barChart>
-      <c:catAx>
-        <c:axId val="-2068027336"/>
-        <c:scaling>
-          <c:orientation val="minMax"/>
-        </c:scaling>
-        <c:delete val="0"/>
-        <c:axPos val="b"/>
-        <c:majorTickMark val="out"/>
-        <c:minorTickMark val="none"/>
-        <c:tickLblPos val="nextTo"/>
-        <c:crossAx val="-2113994440"/>
-        <c:crosses val="autoZero"/>
-        <c:auto val="1"/>
-        <c:lblAlgn val="ctr"/>
-        <c:lblOffset val="100"/>
-        <c:noMultiLvlLbl val="0"/>
-      </c:catAx>
-      <c:valAx>
-        <c:axId val="-2113994440"/>
-        <c:scaling/>
-        <c:delete val="0"/>
-        <c:axPos val="l"/>
-        <c:majorGridlines/>
-        <c:title>
-          <c:tx>
-            <c:rich>
-              <a:bodyPr/>
-              <a:lstStyle/>
-              <a:p>
-                <a:r>
-                  <a:t>金額 (元/卡)</a:t>
-                </a:r>
-              </a:p>
-            </c:rich>
-          </c:tx>
-          <c:layout/>
-          <c:overlay val="0"/>
-        </c:title>
-        <c:majorTickMark val="out"/>
-        <c:minorTickMark val="none"/>
-        <c:tickLblPos val="nextTo"/>
-        <c:crossAx val="-2068027336"/>
-        <c:crosses val="autoZero"/>
-      </c:valAx>
-    </c:plotArea>
-    <c:dispBlanksAs val="gap"/>
-  </c:chart>
-  <c:txPr>
-    <a:bodyPr/>
-    <a:lstStyle/>
-    <a:p>
-      <a:pPr>
-        <a:defRPr sz="1800"/>
-      </a:pPr>
-      <a:endParaRPr lang="en-US"/>
-    </a:p>
-  </c:txPr>
-  <c:externalData r:id="rId1">
-    <c:autoUpdate val="0"/>
-  </c:externalData>
-</c:chartSpace>
-</file>
-
-<file path=ppt/charts/chart6.xml><?xml version="1.0" encoding="utf-8"?>
-<c:chartSpace xmlns:c="http://schemas.openxmlformats.org/drawingml/2006/chart" xmlns:a="http://schemas.openxmlformats.org/drawingml/2006/main" xmlns:r="http://schemas.openxmlformats.org/officeDocument/2006/relationships">
-  <c:date1904 val="0"/>
-  <c:chart>
-    <c:title>
-      <c:tx>
-        <c:rich>
-          <a:bodyPr/>
-          <a:lstStyle/>
-          <a:p>
-            <a:r>
-              <a:t>Top 5 銀行月簽帳金額堆疊圖</a:t>
-            </a:r>
-          </a:p>
-        </c:rich>
-      </c:tx>
-      <c:layout/>
-      <c:overlay val="0"/>
-    </c:title>
-    <c:autoTitleDeleted val="0"/>
-    <c:plotArea>
-      <c:barChart>
-        <c:barDir val="col"/>
-        <c:grouping val="stacked"/>
-        <c:ser>
-          <c:idx val="0"/>
-          <c:order val="0"/>
-          <c:tx>
-            <c:strRef>
-              <c:f>Sheet1!$B$1</c:f>
-              <c:strCache>
-                <c:ptCount val="1"/>
-                <c:pt idx="0">
-                  <c:v>中國信託</c:v>
-                </c:pt>
-              </c:strCache>
-            </c:strRef>
-          </c:tx>
-          <c:spPr>
-            <a:solidFill>
-              <a:srgbClr val="003366"/>
-            </a:solidFill>
-          </c:spPr>
-          <c:cat>
-            <c:strRef>
-              <c:f>Sheet1!$A$2:$A$13</c:f>
-              <c:strCache>
-                <c:ptCount val="12"/>
-                <c:pt idx="0">
-                  <c:v>1月</c:v>
-                </c:pt>
-                <c:pt idx="1">
-                  <c:v>2月</c:v>
-                </c:pt>
-                <c:pt idx="2">
-                  <c:v>3月</c:v>
-                </c:pt>
-                <c:pt idx="3">
-                  <c:v>4月</c:v>
-                </c:pt>
-                <c:pt idx="4">
-                  <c:v>5月</c:v>
-                </c:pt>
-                <c:pt idx="5">
-                  <c:v>6月</c:v>
-                </c:pt>
-                <c:pt idx="6">
-                  <c:v>7月</c:v>
-                </c:pt>
-                <c:pt idx="7">
-                  <c:v>8月</c:v>
-                </c:pt>
-                <c:pt idx="8">
-                  <c:v>9月</c:v>
-                </c:pt>
-                <c:pt idx="9">
-                  <c:v>10月</c:v>
-                </c:pt>
-                <c:pt idx="10">
-                  <c:v>11月</c:v>
-                </c:pt>
-                <c:pt idx="11">
-                  <c:v>12月</c:v>
-                </c:pt>
-              </c:strCache>
-            </c:strRef>
-          </c:cat>
-          <c:val>
-            <c:numRef>
-              <c:f>Sheet1!$B$2:$B$13</c:f>
-              <c:numCache>
-                <c:formatCode>General</c:formatCode>
-                <c:ptCount val="12"/>
-                <c:pt idx="0">
-                  <c:v>55.5</c:v>
-                </c:pt>
-                <c:pt idx="1">
-                  <c:v>70.6</c:v>
-                </c:pt>
-                <c:pt idx="2">
-                  <c:v>66.9</c:v>
-                </c:pt>
-                <c:pt idx="3">
-                  <c:v>64.1</c:v>
-                </c:pt>
-                <c:pt idx="4">
-                  <c:v>62.9</c:v>
-                </c:pt>
-                <c:pt idx="5">
-                  <c:v>67.1</c:v>
-                </c:pt>
-                <c:pt idx="6">
-                  <c:v>126.0</c:v>
-                </c:pt>
-                <c:pt idx="7">
-                  <c:v>67.0</c:v>
-                </c:pt>
-                <c:pt idx="8">
-                  <c:v>73.7</c:v>
-                </c:pt>
-                <c:pt idx="9">
-                  <c:v>80.1</c:v>
-                </c:pt>
-                <c:pt idx="10">
-                  <c:v>72.5</c:v>
-                </c:pt>
-                <c:pt idx="11">
-                  <c:v>83.9</c:v>
-                </c:pt>
-              </c:numCache>
-            </c:numRef>
-          </c:val>
-        </c:ser>
-        <c:ser>
-          <c:idx val="1"/>
-          <c:order val="1"/>
-          <c:tx>
-            <c:strRef>
-              <c:f>Sheet1!$C$1</c:f>
-              <c:strCache>
-                <c:ptCount val="1"/>
-                <c:pt idx="0">
-                  <c:v>國泰世華</c:v>
-                </c:pt>
-              </c:strCache>
-            </c:strRef>
-          </c:tx>
-          <c:spPr>
-            <a:solidFill>
-              <a:srgbClr val="0066CC"/>
-            </a:solidFill>
-          </c:spPr>
-          <c:cat>
-            <c:strRef>
-              <c:f>Sheet1!$A$2:$A$13</c:f>
-              <c:strCache>
-                <c:ptCount val="12"/>
-                <c:pt idx="0">
-                  <c:v>1月</c:v>
-                </c:pt>
-                <c:pt idx="1">
-                  <c:v>2月</c:v>
-                </c:pt>
-                <c:pt idx="2">
-                  <c:v>3月</c:v>
-                </c:pt>
-                <c:pt idx="3">
-                  <c:v>4月</c:v>
-                </c:pt>
-                <c:pt idx="4">
-                  <c:v>5月</c:v>
-                </c:pt>
-                <c:pt idx="5">
-                  <c:v>6月</c:v>
-                </c:pt>
-                <c:pt idx="6">
-                  <c:v>7月</c:v>
-                </c:pt>
-                <c:pt idx="7">
-                  <c:v>8月</c:v>
-                </c:pt>
-                <c:pt idx="8">
-                  <c:v>9月</c:v>
-                </c:pt>
-                <c:pt idx="9">
-                  <c:v>10月</c:v>
-                </c:pt>
-                <c:pt idx="10">
-                  <c:v>11月</c:v>
-                </c:pt>
-                <c:pt idx="11">
-                  <c:v>12月</c:v>
-                </c:pt>
-              </c:strCache>
-            </c:strRef>
-          </c:cat>
-          <c:val>
-            <c:numRef>
-              <c:f>Sheet1!$C$2:$C$13</c:f>
-              <c:numCache>
-                <c:formatCode>General</c:formatCode>
-                <c:ptCount val="12"/>
-                <c:pt idx="0">
-                  <c:v>53.2</c:v>
-                </c:pt>
-                <c:pt idx="1">
-                  <c:v>69.7</c:v>
-                </c:pt>
-                <c:pt idx="2">
-                  <c:v>65.9</c:v>
-                </c:pt>
-                <c:pt idx="3">
-                  <c:v>66.8</c:v>
-                </c:pt>
-                <c:pt idx="4">
-                  <c:v>63.1</c:v>
-                </c:pt>
-                <c:pt idx="5">
-                  <c:v>68.5</c:v>
-                </c:pt>
-                <c:pt idx="6">
-                  <c:v>101.7</c:v>
-                </c:pt>
-                <c:pt idx="7">
-                  <c:v>65.1</c:v>
-                </c:pt>
-                <c:pt idx="8">
-                  <c:v>71.5</c:v>
-                </c:pt>
-                <c:pt idx="9">
-                  <c:v>79.1</c:v>
-                </c:pt>
-                <c:pt idx="10">
-                  <c:v>69.3</c:v>
-                </c:pt>
-                <c:pt idx="11">
-                  <c:v>81.9</c:v>
-                </c:pt>
-              </c:numCache>
-            </c:numRef>
-          </c:val>
-        </c:ser>
-        <c:ser>
-          <c:idx val="2"/>
-          <c:order val="2"/>
-          <c:tx>
-            <c:strRef>
-              <c:f>Sheet1!$D$1</c:f>
-              <c:strCache>
-                <c:ptCount val="1"/>
-                <c:pt idx="0">
-                  <c:v>台北富邦</c:v>
-                </c:pt>
-              </c:strCache>
-            </c:strRef>
-          </c:tx>
-          <c:spPr>
-            <a:solidFill>
-              <a:srgbClr val="FF6600"/>
-            </a:solidFill>
-          </c:spPr>
-          <c:cat>
-            <c:strRef>
-              <c:f>Sheet1!$A$2:$A$13</c:f>
-              <c:strCache>
-                <c:ptCount val="12"/>
-                <c:pt idx="0">
-                  <c:v>1月</c:v>
-                </c:pt>
-                <c:pt idx="1">
-                  <c:v>2月</c:v>
-                </c:pt>
-                <c:pt idx="2">
-                  <c:v>3月</c:v>
-                </c:pt>
-                <c:pt idx="3">
-                  <c:v>4月</c:v>
-                </c:pt>
-                <c:pt idx="4">
-                  <c:v>5月</c:v>
-                </c:pt>
-                <c:pt idx="5">
-                  <c:v>6月</c:v>
-                </c:pt>
-                <c:pt idx="6">
-                  <c:v>7月</c:v>
-                </c:pt>
-                <c:pt idx="7">
-                  <c:v>8月</c:v>
-                </c:pt>
-                <c:pt idx="8">
-                  <c:v>9月</c:v>
-                </c:pt>
-                <c:pt idx="9">
-                  <c:v>10月</c:v>
-                </c:pt>
-                <c:pt idx="10">
-                  <c:v>11月</c:v>
-                </c:pt>
-                <c:pt idx="11">
-                  <c:v>12月</c:v>
-                </c:pt>
-              </c:strCache>
-            </c:strRef>
-          </c:cat>
-          <c:val>
-            <c:numRef>
-              <c:f>Sheet1!$D$2:$D$13</c:f>
-              <c:numCache>
-                <c:formatCode>General</c:formatCode>
-                <c:ptCount val="12"/>
-                <c:pt idx="0">
-                  <c:v>45.7</c:v>
-                </c:pt>
-                <c:pt idx="1">
-                  <c:v>52.3</c:v>
-                </c:pt>
-                <c:pt idx="2">
-                  <c:v>48.0</c:v>
-                </c:pt>
-                <c:pt idx="3">
-                  <c:v>49.5</c:v>
-                </c:pt>
-                <c:pt idx="4">
-                  <c:v>48.5</c:v>
-                </c:pt>
-                <c:pt idx="5">
-                  <c:v>51.0</c:v>
-                </c:pt>
-                <c:pt idx="6">
-                  <c:v>71.0</c:v>
-                </c:pt>
-                <c:pt idx="7">
-                  <c:v>47.4</c:v>
-                </c:pt>
-                <c:pt idx="8">
-                  <c:v>48.3</c:v>
-                </c:pt>
-                <c:pt idx="9">
-                  <c:v>56.6</c:v>
-                </c:pt>
-                <c:pt idx="10">
-                  <c:v>51.1</c:v>
-                </c:pt>
-                <c:pt idx="11">
-                  <c:v>58.9</c:v>
-                </c:pt>
-              </c:numCache>
-            </c:numRef>
-          </c:val>
-        </c:ser>
-        <c:ser>
-          <c:idx val="3"/>
-          <c:order val="3"/>
-          <c:tx>
-            <c:strRef>
-              <c:f>Sheet1!$E$1</c:f>
-              <c:strCache>
-                <c:ptCount val="1"/>
-                <c:pt idx="0">
-                  <c:v>玉山</c:v>
-                </c:pt>
-              </c:strCache>
-            </c:strRef>
-          </c:tx>
-          <c:spPr>
-            <a:solidFill>
-              <a:srgbClr val="339933"/>
-            </a:solidFill>
-          </c:spPr>
-          <c:cat>
-            <c:strRef>
-              <c:f>Sheet1!$A$2:$A$13</c:f>
-              <c:strCache>
-                <c:ptCount val="12"/>
-                <c:pt idx="0">
-                  <c:v>1月</c:v>
-                </c:pt>
-                <c:pt idx="1">
-                  <c:v>2月</c:v>
-                </c:pt>
-                <c:pt idx="2">
-                  <c:v>3月</c:v>
-                </c:pt>
-                <c:pt idx="3">
-                  <c:v>4月</c:v>
-                </c:pt>
-                <c:pt idx="4">
-                  <c:v>5月</c:v>
-                </c:pt>
-                <c:pt idx="5">
-                  <c:v>6月</c:v>
-                </c:pt>
-                <c:pt idx="6">
-                  <c:v>7月</c:v>
-                </c:pt>
-                <c:pt idx="7">
-                  <c:v>8月</c:v>
-                </c:pt>
-                <c:pt idx="8">
-                  <c:v>9月</c:v>
-                </c:pt>
-                <c:pt idx="9">
-                  <c:v>10月</c:v>
-                </c:pt>
-                <c:pt idx="10">
-                  <c:v>11月</c:v>
-                </c:pt>
-                <c:pt idx="11">
-                  <c:v>12月</c:v>
-                </c:pt>
-              </c:strCache>
-            </c:strRef>
-          </c:cat>
-          <c:val>
-            <c:numRef>
-              <c:f>Sheet1!$E$2:$E$13</c:f>
-              <c:numCache>
-                <c:formatCode>General</c:formatCode>
-                <c:ptCount val="12"/>
-                <c:pt idx="0">
-                  <c:v>45.7</c:v>
-                </c:pt>
-                <c:pt idx="1">
-                  <c:v>44.6</c:v>
-                </c:pt>
-                <c:pt idx="2">
-                  <c:v>45.5</c:v>
-                </c:pt>
-                <c:pt idx="3">
-                  <c:v>43.9</c:v>
-                </c:pt>
-                <c:pt idx="4">
-                  <c:v>47.0</c:v>
-                </c:pt>
-                <c:pt idx="5">
-                  <c:v>49.5</c:v>
-                </c:pt>
-                <c:pt idx="6">
-                  <c:v>121.2</c:v>
-                </c:pt>
-                <c:pt idx="7">
-                  <c:v>47.8</c:v>
-                </c:pt>
-                <c:pt idx="8">
-                  <c:v>51.3</c:v>
-                </c:pt>
-                <c:pt idx="9">
-                  <c:v>63.8</c:v>
-                </c:pt>
-                <c:pt idx="10">
-                  <c:v>48.4</c:v>
-                </c:pt>
-                <c:pt idx="11">
-                  <c:v>54.3</c:v>
-                </c:pt>
-              </c:numCache>
-            </c:numRef>
-          </c:val>
-        </c:ser>
-        <c:ser>
-          <c:idx val="4"/>
-          <c:order val="4"/>
-          <c:tx>
-            <c:strRef>
-              <c:f>Sheet1!$F$1</c:f>
-              <c:strCache>
-                <c:ptCount val="1"/>
-                <c:pt idx="0">
-                  <c:v>台新</c:v>
-                </c:pt>
-              </c:strCache>
-            </c:strRef>
-          </c:tx>
-          <c:spPr>
-            <a:solidFill>
-              <a:srgbClr val="CC3333"/>
-            </a:solidFill>
-          </c:spPr>
-          <c:cat>
-            <c:strRef>
-              <c:f>Sheet1!$A$2:$A$13</c:f>
-              <c:strCache>
-                <c:ptCount val="12"/>
-                <c:pt idx="0">
-                  <c:v>1月</c:v>
-                </c:pt>
-                <c:pt idx="1">
-                  <c:v>2月</c:v>
-                </c:pt>
-                <c:pt idx="2">
-                  <c:v>3月</c:v>
-                </c:pt>
-                <c:pt idx="3">
-                  <c:v>4月</c:v>
-                </c:pt>
-                <c:pt idx="4">
-                  <c:v>5月</c:v>
-                </c:pt>
-                <c:pt idx="5">
-                  <c:v>6月</c:v>
-                </c:pt>
-                <c:pt idx="6">
-                  <c:v>7月</c:v>
-                </c:pt>
-                <c:pt idx="7">
-                  <c:v>8月</c:v>
-                </c:pt>
-                <c:pt idx="8">
-                  <c:v>9月</c:v>
-                </c:pt>
-                <c:pt idx="9">
-                  <c:v>10月</c:v>
-                </c:pt>
-                <c:pt idx="10">
-                  <c:v>11月</c:v>
-                </c:pt>
-                <c:pt idx="11">
-                  <c:v>12月</c:v>
-                </c:pt>
-              </c:strCache>
-            </c:strRef>
-          </c:cat>
-          <c:val>
-            <c:numRef>
-              <c:f>Sheet1!$F$2:$F$13</c:f>
-              <c:numCache>
-                <c:formatCode>General</c:formatCode>
-                <c:ptCount val="12"/>
-                <c:pt idx="0">
-                  <c:v>35.4</c:v>
-                </c:pt>
-                <c:pt idx="1">
-                  <c:v>42.8</c:v>
-                </c:pt>
-                <c:pt idx="2">
-                  <c:v>39.7</c:v>
-                </c:pt>
-                <c:pt idx="3">
-                  <c:v>40.3</c:v>
-                </c:pt>
-                <c:pt idx="4">
-                  <c:v>40.7</c:v>
-                </c:pt>
-                <c:pt idx="5">
-                  <c:v>43.8</c:v>
-                </c:pt>
-                <c:pt idx="6">
-                  <c:v>63.0</c:v>
-                </c:pt>
-                <c:pt idx="7">
-                  <c:v>39.0</c:v>
-                </c:pt>
-                <c:pt idx="8">
-                  <c:v>43.9</c:v>
-                </c:pt>
-                <c:pt idx="9">
-                  <c:v>48.8</c:v>
-                </c:pt>
-                <c:pt idx="10">
-                  <c:v>43.4</c:v>
-                </c:pt>
-                <c:pt idx="11">
-                  <c:v>48.4</c:v>
-                </c:pt>
-              </c:numCache>
-            </c:numRef>
-          </c:val>
-        </c:ser>
-        <c:overlap val="100"/>
-        <c:axId val="-2068027336"/>
-        <c:axId val="-2113994440"/>
-      </c:barChart>
-      <c:catAx>
-        <c:axId val="-2068027336"/>
-        <c:scaling>
-          <c:orientation val="minMax"/>
-        </c:scaling>
-        <c:delete val="0"/>
-        <c:axPos val="b"/>
-        <c:majorTickMark val="out"/>
-        <c:minorTickMark val="none"/>
-        <c:tickLblPos val="nextTo"/>
-        <c:crossAx val="-2113994440"/>
-        <c:crosses val="autoZero"/>
-        <c:auto val="1"/>
-        <c:lblAlgn val="ctr"/>
-        <c:lblOffset val="100"/>
-        <c:noMultiLvlLbl val="0"/>
-      </c:catAx>
-      <c:valAx>
-        <c:axId val="-2113994440"/>
-        <c:scaling/>
-        <c:delete val="0"/>
-        <c:axPos val="l"/>
-        <c:majorGridlines/>
-        <c:majorTickMark val="out"/>
-        <c:minorTickMark val="none"/>
-        <c:tickLblPos val="nextTo"/>
-        <c:crossAx val="-2068027336"/>
-        <c:crosses val="autoZero"/>
-      </c:valAx>
-    </c:plotArea>
-    <c:dispBlanksAs val="gap"/>
-  </c:chart>
-  <c:txPr>
-    <a:bodyPr/>
-    <a:lstStyle/>
-    <a:p>
-      <a:pPr>
-        <a:defRPr sz="1800"/>
-      </a:pPr>
-      <a:endParaRPr lang="en-US"/>
-    </a:p>
-  </c:txPr>
-  <c:externalData r:id="rId1">
-    <c:autoUpdate val="0"/>
-  </c:externalData>
-</c:chartSpace>
-</file>
-
-<file path=ppt/charts/chart7.xml><?xml version="1.0" encoding="utf-8"?>
-<c:chartSpace xmlns:c="http://schemas.openxmlformats.org/drawingml/2006/chart" xmlns:a="http://schemas.openxmlformats.org/drawingml/2006/main" xmlns:r="http://schemas.openxmlformats.org/officeDocument/2006/relationships">
-  <c:date1904 val="0"/>
-  <c:chart>
-    <c:title>
-      <c:tx>
-        <c:rich>
-          <a:bodyPr/>
-          <a:lstStyle/>
-          <a:p>
-            <a:r>
-              <a:t>流通卡數月增率 MoM（11411→11412）</a:t>
-            </a:r>
-          </a:p>
-        </c:rich>
-      </c:tx>
-      <c:layout/>
-      <c:overlay val="0"/>
-    </c:title>
-    <c:autoTitleDeleted val="0"/>
-    <c:plotArea>
-      <c:barChart>
-        <c:barDir val="col"/>
-        <c:grouping val="clustered"/>
-        <c:ser>
-          <c:idx val="0"/>
-          <c:order val="0"/>
-          <c:tx>
-            <c:strRef>
-              <c:f>Sheet1!$B$1</c:f>
-              <c:strCache>
-                <c:ptCount val="1"/>
-                <c:pt idx="0">
-                  <c:v>月增率(%)</c:v>
-                </c:pt>
-              </c:strCache>
-            </c:strRef>
-          </c:tx>
-          <c:spPr>
-            <a:solidFill>
-              <a:srgbClr val="003366"/>
-            </a:solidFill>
-          </c:spPr>
-          <c:cat>
-            <c:strRef>
-              <c:f>Sheet1!$A$2:$A$11</c:f>
-              <c:strCache>
-                <c:ptCount val="10"/>
-                <c:pt idx="0">
-                  <c:v>中國信託</c:v>
-                </c:pt>
-                <c:pt idx="1">
-                  <c:v>玉山</c:v>
-                </c:pt>
-                <c:pt idx="2">
-                  <c:v>台北富邦</c:v>
-                </c:pt>
-                <c:pt idx="3">
-                  <c:v>國泰世華</c:v>
-                </c:pt>
-                <c:pt idx="4">
-                  <c:v>台新</c:v>
-                </c:pt>
-                <c:pt idx="5">
-                  <c:v>星展(台灣)</c:v>
-                </c:pt>
-                <c:pt idx="6">
-                  <c:v>聯邦</c:v>
-                </c:pt>
-                <c:pt idx="7">
-                  <c:v>永豐</c:v>
-                </c:pt>
-                <c:pt idx="8">
-                  <c:v>第一</c:v>
-                </c:pt>
-                <c:pt idx="9">
-                  <c:v>遠東</c:v>
-                </c:pt>
-              </c:strCache>
-            </c:strRef>
-          </c:cat>
-          <c:val>
-            <c:numRef>
-              <c:f>Sheet1!$B$2:$B$11</c:f>
-              <c:numCache>
-                <c:formatCode>General</c:formatCode>
-                <c:ptCount val="10"/>
-                <c:pt idx="0">
-                  <c:v>0.58</c:v>
-                </c:pt>
-                <c:pt idx="1">
-                  <c:v>0.48</c:v>
-                </c:pt>
-                <c:pt idx="2">
-                  <c:v>0.3</c:v>
-                </c:pt>
-                <c:pt idx="3">
-                  <c:v>-0.56</c:v>
-                </c:pt>
-                <c:pt idx="4">
-                  <c:v>-0.0</c:v>
-                </c:pt>
-                <c:pt idx="5">
-                  <c:v>-0.94</c:v>
-                </c:pt>
-                <c:pt idx="6">
-                  <c:v>0.27</c:v>
-                </c:pt>
-                <c:pt idx="7">
-                  <c:v>0.42</c:v>
-                </c:pt>
-                <c:pt idx="8">
-                  <c:v>0.15</c:v>
-                </c:pt>
-                <c:pt idx="9">
-                  <c:v>-0.19</c:v>
-                </c:pt>
-              </c:numCache>
-            </c:numRef>
-          </c:val>
-        </c:ser>
-        <c:axId val="-2068027336"/>
-        <c:axId val="-2113994440"/>
-      </c:barChart>
-      <c:catAx>
-        <c:axId val="-2068027336"/>
-        <c:scaling>
-          <c:orientation val="minMax"/>
-        </c:scaling>
-        <c:delete val="0"/>
-        <c:axPos val="b"/>
-        <c:majorTickMark val="out"/>
-        <c:minorTickMark val="none"/>
-        <c:tickLblPos val="nextTo"/>
-        <c:crossAx val="-2113994440"/>
-        <c:crosses val="autoZero"/>
-        <c:auto val="1"/>
-        <c:lblAlgn val="ctr"/>
-        <c:lblOffset val="100"/>
-        <c:noMultiLvlLbl val="0"/>
-      </c:catAx>
-      <c:valAx>
-        <c:axId val="-2113994440"/>
-        <c:scaling/>
-        <c:delete val="0"/>
-        <c:axPos val="l"/>
-        <c:majorGridlines/>
-        <c:title>
-          <c:tx>
-            <c:rich>
-              <a:bodyPr/>
-              <a:lstStyle/>
-              <a:p>
-                <a:r>
-                  <a:t>月增率 (%)</a:t>
-                </a:r>
-              </a:p>
-            </c:rich>
-          </c:tx>
-          <c:layout/>
-          <c:overlay val="0"/>
-        </c:title>
-        <c:majorTickMark val="out"/>
-        <c:minorTickMark val="none"/>
-        <c:tickLblPos val="nextTo"/>
-        <c:crossAx val="-2068027336"/>
-        <c:crosses val="autoZero"/>
-      </c:valAx>
-    </c:plotArea>
-    <c:dispBlanksAs val="gap"/>
-  </c:chart>
-  <c:txPr>
-    <a:bodyPr/>
-    <a:lstStyle/>
-    <a:p>
-      <a:pPr>
-        <a:defRPr sz="1800"/>
-      </a:pPr>
-      <a:endParaRPr lang="en-US"/>
-    </a:p>
-  </c:txPr>
-  <c:externalData r:id="rId1">
-    <c:autoUpdate val="0"/>
-  </c:externalData>
-</c:chartSpace>
 </file>
 
 <file path=ppt/slideLayouts/slideLayout1.xml><?xml version="1.0" encoding="utf-8"?>
@@ -6168,29 +4274,46 @@
               </a:defRPr>
             </a:pPr>
             <a:r>
-              <a:t>◆ 每卡月簽帳金額排名 — 台新每卡簽帳力高於多數同業</a:t>
-            </a:r>
-          </a:p>
-        </p:txBody>
-      </p:sp>
-      <p:graphicFrame>
-        <p:nvGraphicFramePr>
-          <p:cNvPr id="5" name="Chart 4"/>
-          <p:cNvGraphicFramePr>
-            <a:graphicFrameLocks noGrp="1"/>
-          </p:cNvGraphicFramePr>
+              <a:t>◆ 每卡消費力分析</a:t>
+            </a:r>
+          </a:p>
+        </p:txBody>
+      </p:sp>
+      <p:sp>
+        <p:nvSpPr>
+          <p:cNvPr id="5" name="TextBox 4"/>
+          <p:cNvSpPr txBox="1"/>
           <p:nvPr/>
-        </p:nvGraphicFramePr>
-        <p:xfrm>
-          <a:off x="540000" y="1620000"/>
-          <a:ext cx="10800000" cy="3600000"/>
-        </p:xfrm>
-        <a:graphic>
-          <a:graphicData uri="http://schemas.openxmlformats.org/drawingml/2006/chart">
-            <c:chart xmlns:c="http://schemas.openxmlformats.org/drawingml/2006/chart" r:id="rId2"/>
-          </a:graphicData>
-        </a:graphic>
-      </p:graphicFrame>
+        </p:nvSpPr>
+        <p:spPr>
+          <a:xfrm>
+            <a:off x="1800000" y="2520000"/>
+            <a:ext cx="8280000" cy="1080000"/>
+          </a:xfrm>
+          <a:prstGeom prst="rect">
+            <a:avLst/>
+          </a:prstGeom>
+          <a:noFill/>
+        </p:spPr>
+        <p:txBody>
+          <a:bodyPr wrap="square">
+            <a:spAutoFit/>
+          </a:bodyPr>
+          <a:lstStyle/>
+          <a:p>
+            <a:pPr algn="ctr">
+              <a:defRPr sz="1400">
+                <a:solidFill>
+                  <a:srgbClr val="999999"/>
+                </a:solidFill>
+              </a:defRPr>
+            </a:pPr>
+            <a:r>
+              <a:t>[圖表區域 — 平均每卡簽帳金額比較]</a:t>
+            </a:r>
+          </a:p>
+        </p:txBody>
+      </p:sp>
       <p:sp>
         <p:nvSpPr>
           <p:cNvPr id="6" name="TextBox 5"/>
@@ -6302,29 +4425,46 @@
               </a:defRPr>
             </a:pPr>
             <a:r>
-              <a:t>◆ Top 5 銀行月簽帳金額走勢（億元）</a:t>
-            </a:r>
-          </a:p>
-        </p:txBody>
-      </p:sp>
-      <p:graphicFrame>
-        <p:nvGraphicFramePr>
-          <p:cNvPr id="5" name="Chart 4"/>
-          <p:cNvGraphicFramePr>
-            <a:graphicFrameLocks noGrp="1"/>
-          </p:cNvGraphicFramePr>
+              <a:t>◆ 信用結構分析</a:t>
+            </a:r>
+          </a:p>
+        </p:txBody>
+      </p:sp>
+      <p:sp>
+        <p:nvSpPr>
+          <p:cNvPr id="5" name="TextBox 4"/>
+          <p:cNvSpPr txBox="1"/>
           <p:nvPr/>
-        </p:nvGraphicFramePr>
-        <p:xfrm>
-          <a:off x="540000" y="1620000"/>
-          <a:ext cx="10800000" cy="3600000"/>
-        </p:xfrm>
-        <a:graphic>
-          <a:graphicData uri="http://schemas.openxmlformats.org/drawingml/2006/chart">
-            <c:chart xmlns:c="http://schemas.openxmlformats.org/drawingml/2006/chart" r:id="rId2"/>
-          </a:graphicData>
-        </a:graphic>
-      </p:graphicFrame>
+        </p:nvSpPr>
+        <p:spPr>
+          <a:xfrm>
+            <a:off x="1800000" y="2520000"/>
+            <a:ext cx="8280000" cy="1080000"/>
+          </a:xfrm>
+          <a:prstGeom prst="rect">
+            <a:avLst/>
+          </a:prstGeom>
+          <a:noFill/>
+        </p:spPr>
+        <p:txBody>
+          <a:bodyPr wrap="square">
+            <a:spAutoFit/>
+          </a:bodyPr>
+          <a:lstStyle/>
+          <a:p>
+            <a:pPr algn="ctr">
+              <a:defRPr sz="1400">
+                <a:solidFill>
+                  <a:srgbClr val="999999"/>
+                </a:solidFill>
+              </a:defRPr>
+            </a:pPr>
+            <a:r>
+              <a:t>[圖表區域 — 循環信用與分期付款餘額]</a:t>
+            </a:r>
+          </a:p>
+        </p:txBody>
+      </p:sp>
       <p:sp>
         <p:nvSpPr>
           <p:cNvPr id="6" name="TextBox 5"/>
@@ -6517,29 +4657,46 @@
               </a:defRPr>
             </a:pPr>
             <a:r>
-              <a:t>◆ 流通卡數月增率 — 各銀行成長動態</a:t>
-            </a:r>
-          </a:p>
-        </p:txBody>
-      </p:sp>
-      <p:graphicFrame>
-        <p:nvGraphicFramePr>
-          <p:cNvPr id="5" name="Chart 4"/>
-          <p:cNvGraphicFramePr>
-            <a:graphicFrameLocks noGrp="1"/>
-          </p:cNvGraphicFramePr>
+              <a:t>◆ 風險指標總覽</a:t>
+            </a:r>
+          </a:p>
+        </p:txBody>
+      </p:sp>
+      <p:sp>
+        <p:nvSpPr>
+          <p:cNvPr id="5" name="TextBox 4"/>
+          <p:cNvSpPr txBox="1"/>
           <p:nvPr/>
-        </p:nvGraphicFramePr>
-        <p:xfrm>
-          <a:off x="540000" y="1620000"/>
-          <a:ext cx="10800000" cy="3600000"/>
-        </p:xfrm>
-        <a:graphic>
-          <a:graphicData uri="http://schemas.openxmlformats.org/drawingml/2006/chart">
-            <c:chart xmlns:c="http://schemas.openxmlformats.org/drawingml/2006/chart" r:id="rId2"/>
-          </a:graphicData>
-        </a:graphic>
-      </p:graphicFrame>
+        </p:nvSpPr>
+        <p:spPr>
+          <a:xfrm>
+            <a:off x="1800000" y="2520000"/>
+            <a:ext cx="8280000" cy="1080000"/>
+          </a:xfrm>
+          <a:prstGeom prst="rect">
+            <a:avLst/>
+          </a:prstGeom>
+          <a:noFill/>
+        </p:spPr>
+        <p:txBody>
+          <a:bodyPr wrap="square">
+            <a:spAutoFit/>
+          </a:bodyPr>
+          <a:lstStyle/>
+          <a:p>
+            <a:pPr algn="ctr">
+              <a:defRPr sz="1400">
+                <a:solidFill>
+                  <a:srgbClr val="999999"/>
+                </a:solidFill>
+              </a:defRPr>
+            </a:pPr>
+            <a:r>
+              <a:t>[圖表區域 — 逾期率與呆帳率比較]</a:t>
+            </a:r>
+          </a:p>
+        </p:txBody>
+      </p:sp>
       <p:sp>
         <p:nvSpPr>
           <p:cNvPr id="6" name="TextBox 5"/>
@@ -7508,7 +5665,7 @@
               </a:defRPr>
             </a:pPr>
             <a:r>
-              <a:t>市場流通卡數（12月）</a:t>
+              <a:t>市場流通卡數</a:t>
             </a:r>
           </a:p>
         </p:txBody>
@@ -7542,9 +5699,6 @@
                 </a:solidFill>
               </a:defRPr>
             </a:pPr>
-            <a:r>
-              <a:t>6,049 萬</a:t>
-            </a:r>
           </a:p>
         </p:txBody>
       </p:sp>
@@ -7578,7 +5732,7 @@
               </a:defRPr>
             </a:pPr>
             <a:r>
-              <a:t>月均簽帳金額（12月）</a:t>
+              <a:t>台新市占率</a:t>
             </a:r>
           </a:p>
         </p:txBody>
@@ -7612,9 +5766,6 @@
                 </a:solidFill>
               </a:defRPr>
             </a:pPr>
-            <a:r>
-              <a:t>454 億</a:t>
-            </a:r>
           </a:p>
         </p:txBody>
       </p:sp>
@@ -7648,7 +5799,7 @@
               </a:defRPr>
             </a:pPr>
             <a:r>
-              <a:t>台新市占率（流通卡）</a:t>
+              <a:t>台新有效卡率</a:t>
             </a:r>
           </a:p>
         </p:txBody>
@@ -7682,9 +5833,6 @@
                 </a:solidFill>
               </a:defRPr>
             </a:pPr>
-            <a:r>
-              <a:t>11.0%</a:t>
-            </a:r>
           </a:p>
         </p:txBody>
       </p:sp>
@@ -7696,8 +5844,8 @@
         </p:nvSpPr>
         <p:spPr>
           <a:xfrm>
-            <a:off x="5976000" y="2267999"/>
-            <a:ext cx="2700000" cy="251999"/>
+            <a:off x="8784000" y="1440000"/>
+            <a:ext cx="2700000" cy="288000"/>
           </a:xfrm>
           <a:prstGeom prst="rect">
             <a:avLst/>
@@ -7711,14 +5859,14 @@
           <a:lstStyle/>
           <a:p>
             <a:pPr>
-              <a:defRPr sz="900">
+              <a:defRPr sz="1000">
                 <a:solidFill>
                   <a:srgbClr val="666666"/>
                 </a:solidFill>
               </a:defRPr>
             </a:pPr>
             <a:r>
-              <a:t>排名第五</a:t>
+              <a:t>台新每卡簽帳金額</a:t>
             </a:r>
           </a:p>
         </p:txBody>
@@ -7731,8 +5879,8 @@
         </p:nvSpPr>
         <p:spPr>
           <a:xfrm>
-            <a:off x="8784000" y="1440000"/>
-            <a:ext cx="2700000" cy="288000"/>
+            <a:off x="8784000" y="1764000"/>
+            <a:ext cx="2700000" cy="468000"/>
           </a:xfrm>
           <a:prstGeom prst="rect">
             <a:avLst/>
@@ -7746,209 +5894,12 @@
           <a:lstStyle/>
           <a:p>
             <a:pPr>
-              <a:defRPr sz="1000">
-                <a:solidFill>
-                  <a:srgbClr val="666666"/>
-                </a:solidFill>
-              </a:defRPr>
-            </a:pPr>
-            <a:r>
-              <a:t>台新簽帳市占率</a:t>
-            </a:r>
-          </a:p>
-        </p:txBody>
-      </p:sp>
-      <p:sp>
-        <p:nvSpPr>
-          <p:cNvPr id="13" name="TextBox 12"/>
-          <p:cNvSpPr txBox="1"/>
-          <p:nvPr/>
-        </p:nvSpPr>
-        <p:spPr>
-          <a:xfrm>
-            <a:off x="8784000" y="1764000"/>
-            <a:ext cx="2700000" cy="468000"/>
-          </a:xfrm>
-          <a:prstGeom prst="rect">
-            <a:avLst/>
-          </a:prstGeom>
-          <a:noFill/>
-        </p:spPr>
-        <p:txBody>
-          <a:bodyPr wrap="none">
-            <a:spAutoFit/>
-          </a:bodyPr>
-          <a:lstStyle/>
-          <a:p>
-            <a:pPr>
               <a:defRPr sz="2200" b="1">
                 <a:solidFill>
                   <a:srgbClr val="003366"/>
                 </a:solidFill>
               </a:defRPr>
             </a:pPr>
-            <a:r>
-              <a:t>10.7%</a:t>
-            </a:r>
-          </a:p>
-        </p:txBody>
-      </p:sp>
-      <p:sp>
-        <p:nvSpPr>
-          <p:cNvPr id="14" name="TextBox 13"/>
-          <p:cNvSpPr txBox="1"/>
-          <p:nvPr/>
-        </p:nvSpPr>
-        <p:spPr>
-          <a:xfrm>
-            <a:off x="360000" y="2880000"/>
-            <a:ext cx="11232000" cy="288000"/>
-          </a:xfrm>
-          <a:prstGeom prst="rect">
-            <a:avLst/>
-          </a:prstGeom>
-          <a:noFill/>
-        </p:spPr>
-        <p:txBody>
-          <a:bodyPr wrap="none">
-            <a:spAutoFit/>
-          </a:bodyPr>
-          <a:lstStyle/>
-          <a:p>
-            <a:pPr>
-              <a:defRPr sz="1200" b="1">
-                <a:solidFill>
-                  <a:srgbClr val="003366"/>
-                </a:solidFill>
-              </a:defRPr>
-            </a:pPr>
-            <a:r>
-              <a:t>四大關鍵洞察</a:t>
-            </a:r>
-          </a:p>
-        </p:txBody>
-      </p:sp>
-      <p:sp>
-        <p:nvSpPr>
-          <p:cNvPr id="15" name="TextBox 14"/>
-          <p:cNvSpPr txBox="1"/>
-          <p:nvPr/>
-        </p:nvSpPr>
-        <p:spPr>
-          <a:xfrm>
-            <a:off x="540000" y="3240000"/>
-            <a:ext cx="10800000" cy="540000"/>
-          </a:xfrm>
-          <a:prstGeom prst="rect">
-            <a:avLst/>
-          </a:prstGeom>
-          <a:noFill/>
-        </p:spPr>
-        <p:txBody>
-          <a:bodyPr wrap="square">
-            <a:spAutoFit/>
-          </a:bodyPr>
-          <a:lstStyle/>
-          <a:p>
-            <a:pPr>
-              <a:defRPr sz="1000"/>
-            </a:pPr>
-            <a:r>
-              <a:t>• 市場成長由簽帳額驅動，非卡數擴張。流通卡數年內僅微幅成長，但簽帳金額波動大，市場進入存量競爭階段。</a:t>
-            </a:r>
-          </a:p>
-        </p:txBody>
-      </p:sp>
-      <p:sp>
-        <p:nvSpPr>
-          <p:cNvPr id="16" name="TextBox 15"/>
-          <p:cNvSpPr txBox="1"/>
-          <p:nvPr/>
-        </p:nvSpPr>
-        <p:spPr>
-          <a:xfrm>
-            <a:off x="540000" y="3780000"/>
-            <a:ext cx="10800000" cy="540000"/>
-          </a:xfrm>
-          <a:prstGeom prst="rect">
-            <a:avLst/>
-          </a:prstGeom>
-          <a:noFill/>
-        </p:spPr>
-        <p:txBody>
-          <a:bodyPr wrap="square">
-            <a:spAutoFit/>
-          </a:bodyPr>
-          <a:lstStyle/>
-          <a:p>
-            <a:pPr>
-              <a:defRPr sz="1000"/>
-            </a:pPr>
-            <a:r>
-              <a:t>• 玉山以激進發卡攻市占，流通卡數年內成長 17.0%，全行最高，但大量發卡的轉換效率有待觀察。</a:t>
-            </a:r>
-          </a:p>
-        </p:txBody>
-      </p:sp>
-      <p:sp>
-        <p:nvSpPr>
-          <p:cNvPr id="17" name="TextBox 16"/>
-          <p:cNvSpPr txBox="1"/>
-          <p:nvPr/>
-        </p:nvSpPr>
-        <p:spPr>
-          <a:xfrm>
-            <a:off x="540000" y="4320000"/>
-            <a:ext cx="10800000" cy="540000"/>
-          </a:xfrm>
-          <a:prstGeom prst="rect">
-            <a:avLst/>
-          </a:prstGeom>
-          <a:noFill/>
-        </p:spPr>
-        <p:txBody>
-          <a:bodyPr wrap="square">
-            <a:spAutoFit/>
-          </a:bodyPr>
-          <a:lstStyle/>
-          <a:p>
-            <a:pPr>
-              <a:defRPr sz="1000"/>
-            </a:pPr>
-            <a:r>
-              <a:t>• 台新簽帳金額年內成長 36.6%，顯示既存客戶消費黏著度大幅提升，品質成長優於數量擴張。</a:t>
-            </a:r>
-          </a:p>
-        </p:txBody>
-      </p:sp>
-      <p:sp>
-        <p:nvSpPr>
-          <p:cNvPr id="18" name="TextBox 17"/>
-          <p:cNvSpPr txBox="1"/>
-          <p:nvPr/>
-        </p:nvSpPr>
-        <p:spPr>
-          <a:xfrm>
-            <a:off x="540000" y="4860000"/>
-            <a:ext cx="10800000" cy="540000"/>
-          </a:xfrm>
-          <a:prstGeom prst="rect">
-            <a:avLst/>
-          </a:prstGeom>
-          <a:noFill/>
-        </p:spPr>
-        <p:txBody>
-          <a:bodyPr wrap="square">
-            <a:spAutoFit/>
-          </a:bodyPr>
-          <a:lstStyle/>
-          <a:p>
-            <a:pPr>
-              <a:defRPr sz="1000"/>
-            </a:pPr>
-            <a:r>
-              <a:t>• 台新流通卡數年內成長 0.8%，維持穩定，市占率 11.0% 排名第五，需加速發卡以縮小與前四名差距。</a:t>
-            </a:r>
           </a:p>
         </p:txBody>
       </p:sp>
@@ -8114,24 +6065,41 @@
           </a:p>
         </p:txBody>
       </p:sp>
-      <p:graphicFrame>
-        <p:nvGraphicFramePr>
-          <p:cNvPr id="5" name="Chart 4"/>
-          <p:cNvGraphicFramePr>
-            <a:graphicFrameLocks noGrp="1"/>
-          </p:cNvGraphicFramePr>
+      <p:sp>
+        <p:nvSpPr>
+          <p:cNvPr id="5" name="TextBox 4"/>
+          <p:cNvSpPr txBox="1"/>
           <p:nvPr/>
-        </p:nvGraphicFramePr>
-        <p:xfrm>
-          <a:off x="540000" y="1620000"/>
-          <a:ext cx="10800000" cy="3600000"/>
-        </p:xfrm>
-        <a:graphic>
-          <a:graphicData uri="http://schemas.openxmlformats.org/drawingml/2006/chart">
-            <c:chart xmlns:c="http://schemas.openxmlformats.org/drawingml/2006/chart" r:id="rId2"/>
-          </a:graphicData>
-        </a:graphic>
-      </p:graphicFrame>
+        </p:nvSpPr>
+        <p:spPr>
+          <a:xfrm>
+            <a:off x="1800000" y="2520000"/>
+            <a:ext cx="8280000" cy="1080000"/>
+          </a:xfrm>
+          <a:prstGeom prst="rect">
+            <a:avLst/>
+          </a:prstGeom>
+          <a:noFill/>
+        </p:spPr>
+        <p:txBody>
+          <a:bodyPr wrap="square">
+            <a:spAutoFit/>
+          </a:bodyPr>
+          <a:lstStyle/>
+          <a:p>
+            <a:pPr algn="ctr">
+              <a:defRPr sz="1400">
+                <a:solidFill>
+                  <a:srgbClr val="999999"/>
+                </a:solidFill>
+              </a:defRPr>
+            </a:pPr>
+            <a:r>
+              <a:t>[圖表區域 — 市場規模趨勢 — 流通卡數與簽帳金額]</a:t>
+            </a:r>
+          </a:p>
+        </p:txBody>
+      </p:sp>
       <p:sp>
         <p:nvSpPr>
           <p:cNvPr id="6" name="TextBox 5"/>
@@ -8283,24 +6251,41 @@
           </a:p>
         </p:txBody>
       </p:sp>
-      <p:graphicFrame>
-        <p:nvGraphicFramePr>
-          <p:cNvPr id="5" name="Chart 4"/>
-          <p:cNvGraphicFramePr>
-            <a:graphicFrameLocks noGrp="1"/>
-          </p:cNvGraphicFramePr>
+      <p:sp>
+        <p:nvSpPr>
+          <p:cNvPr id="5" name="TextBox 4"/>
+          <p:cNvSpPr txBox="1"/>
           <p:nvPr/>
-        </p:nvGraphicFramePr>
-        <p:xfrm>
-          <a:off x="540000" y="1620000"/>
-          <a:ext cx="10800000" cy="3600000"/>
-        </p:xfrm>
-        <a:graphic>
-          <a:graphicData uri="http://schemas.openxmlformats.org/drawingml/2006/chart">
-            <c:chart xmlns:c="http://schemas.openxmlformats.org/drawingml/2006/chart" r:id="rId2"/>
-          </a:graphicData>
-        </a:graphic>
-      </p:graphicFrame>
+        </p:nvSpPr>
+        <p:spPr>
+          <a:xfrm>
+            <a:off x="1800000" y="2520000"/>
+            <a:ext cx="8280000" cy="1080000"/>
+          </a:xfrm>
+          <a:prstGeom prst="rect">
+            <a:avLst/>
+          </a:prstGeom>
+          <a:noFill/>
+        </p:spPr>
+        <p:txBody>
+          <a:bodyPr wrap="square">
+            <a:spAutoFit/>
+          </a:bodyPr>
+          <a:lstStyle/>
+          <a:p>
+            <a:pPr algn="ctr">
+              <a:defRPr sz="1400">
+                <a:solidFill>
+                  <a:srgbClr val="999999"/>
+                </a:solidFill>
+              </a:defRPr>
+            </a:pPr>
+            <a:r>
+              <a:t>[圖表區域 — 流通卡數市占率排名]</a:t>
+            </a:r>
+          </a:p>
+        </p:txBody>
+      </p:sp>
       <p:sp>
         <p:nvSpPr>
           <p:cNvPr id="6" name="TextBox 5"/>
@@ -8498,24 +6483,41 @@
           </a:p>
         </p:txBody>
       </p:sp>
-      <p:graphicFrame>
-        <p:nvGraphicFramePr>
-          <p:cNvPr id="5" name="Chart 4"/>
-          <p:cNvGraphicFramePr>
-            <a:graphicFrameLocks noGrp="1"/>
-          </p:cNvGraphicFramePr>
+      <p:sp>
+        <p:nvSpPr>
+          <p:cNvPr id="5" name="TextBox 4"/>
+          <p:cNvSpPr txBox="1"/>
           <p:nvPr/>
-        </p:nvGraphicFramePr>
-        <p:xfrm>
-          <a:off x="540000" y="1620000"/>
-          <a:ext cx="10800000" cy="3600000"/>
-        </p:xfrm>
-        <a:graphic>
-          <a:graphicData uri="http://schemas.openxmlformats.org/drawingml/2006/chart">
-            <c:chart xmlns:c="http://schemas.openxmlformats.org/drawingml/2006/chart" r:id="rId2"/>
-          </a:graphicData>
-        </a:graphic>
-      </p:graphicFrame>
+        </p:nvSpPr>
+        <p:spPr>
+          <a:xfrm>
+            <a:off x="1800000" y="2520000"/>
+            <a:ext cx="8280000" cy="1080000"/>
+          </a:xfrm>
+          <a:prstGeom prst="rect">
+            <a:avLst/>
+          </a:prstGeom>
+          <a:noFill/>
+        </p:spPr>
+        <p:txBody>
+          <a:bodyPr wrap="square">
+            <a:spAutoFit/>
+          </a:bodyPr>
+          <a:lstStyle/>
+          <a:p>
+            <a:pPr algn="ctr">
+              <a:defRPr sz="1400">
+                <a:solidFill>
+                  <a:srgbClr val="999999"/>
+                </a:solidFill>
+              </a:defRPr>
+            </a:pPr>
+            <a:r>
+              <a:t>[圖表區域 — 規模 vs 成長率散佈圖]</a:t>
+            </a:r>
+          </a:p>
+        </p:txBody>
+      </p:sp>
       <p:sp>
         <p:nvSpPr>
           <p:cNvPr id="6" name="TextBox 5"/>
@@ -8627,29 +6629,46 @@
               </a:defRPr>
             </a:pPr>
             <a:r>
-              <a:t>◆ 簽帳金額市占率 vs 流通卡數市占率 — 差異反映單卡消費力</a:t>
-            </a:r>
-          </a:p>
-        </p:txBody>
-      </p:sp>
-      <p:graphicFrame>
-        <p:nvGraphicFramePr>
-          <p:cNvPr id="5" name="Chart 4"/>
-          <p:cNvGraphicFramePr>
-            <a:graphicFrameLocks noGrp="1"/>
-          </p:cNvGraphicFramePr>
+              <a:t>◆ 有效卡率同業比較</a:t>
+            </a:r>
+          </a:p>
+        </p:txBody>
+      </p:sp>
+      <p:sp>
+        <p:nvSpPr>
+          <p:cNvPr id="5" name="TextBox 4"/>
+          <p:cNvSpPr txBox="1"/>
           <p:nvPr/>
-        </p:nvGraphicFramePr>
-        <p:xfrm>
-          <a:off x="540000" y="1620000"/>
-          <a:ext cx="10800000" cy="3600000"/>
-        </p:xfrm>
-        <a:graphic>
-          <a:graphicData uri="http://schemas.openxmlformats.org/drawingml/2006/chart">
-            <c:chart xmlns:c="http://schemas.openxmlformats.org/drawingml/2006/chart" r:id="rId2"/>
-          </a:graphicData>
-        </a:graphic>
-      </p:graphicFrame>
+        </p:nvSpPr>
+        <p:spPr>
+          <a:xfrm>
+            <a:off x="1800000" y="2520000"/>
+            <a:ext cx="8280000" cy="1080000"/>
+          </a:xfrm>
+          <a:prstGeom prst="rect">
+            <a:avLst/>
+          </a:prstGeom>
+          <a:noFill/>
+        </p:spPr>
+        <p:txBody>
+          <a:bodyPr wrap="square">
+            <a:spAutoFit/>
+          </a:bodyPr>
+          <a:lstStyle/>
+          <a:p>
+            <a:pPr algn="ctr">
+              <a:defRPr sz="1400">
+                <a:solidFill>
+                  <a:srgbClr val="999999"/>
+                </a:solidFill>
+              </a:defRPr>
+            </a:pPr>
+            <a:r>
+              <a:t>[圖表區域 — 有效卡率比較]</a:t>
+            </a:r>
+          </a:p>
+        </p:txBody>
+      </p:sp>
       <p:sp>
         <p:nvSpPr>
           <p:cNvPr id="6" name="TextBox 5"/>

</xml_diff>

<commit_message>
update: Add EC2 deploy script, latest outputs, protect .pem files
</commit_message>
<xml_diff>
--- a/outputs/final_presentation.pptx
+++ b/outputs/final_presentation.pptx
@@ -133,7 +133,7 @@
           <a:lstStyle/>
           <a:p>
             <a:r>
-              <a:t>市場流通卡數趨勢（萬張）</a:t>
+              <a:t>市場規模趨勢 — 流通卡數與簽帳金額</a:t>
             </a:r>
           </a:p>
         </c:rich>
@@ -143,9 +143,9 @@
     </c:title>
     <c:autoTitleDeleted val="0"/>
     <c:plotArea>
-      <c:lineChart>
-        <c:grouping val="standard"/>
-        <c:varyColors val="0"/>
+      <c:barChart>
+        <c:barDir val="col"/>
+        <c:grouping val="clustered"/>
         <c:ser>
           <c:idx val="0"/>
           <c:order val="0"/>
@@ -155,17 +155,15 @@
               <c:strCache>
                 <c:ptCount val="1"/>
                 <c:pt idx="0">
-                  <c:v>流通卡數（萬張）</c:v>
+                  <c:v>流通卡數(萬張)</c:v>
                 </c:pt>
               </c:strCache>
             </c:strRef>
           </c:tx>
           <c:spPr>
-            <a:ln w="31750">
-              <a:solidFill>
-                <a:srgbClr val="003366"/>
-              </a:solidFill>
-            </a:ln>
+            <a:solidFill>
+              <a:srgbClr val="003366"/>
+            </a:solidFill>
           </c:spPr>
           <c:cat>
             <c:strRef>
@@ -173,31 +171,31 @@
               <c:strCache>
                 <c:ptCount val="12"/>
                 <c:pt idx="0">
-                  <c:v>01月</c:v>
+                  <c:v>1月</c:v>
                 </c:pt>
                 <c:pt idx="1">
-                  <c:v>02月</c:v>
+                  <c:v>2月</c:v>
                 </c:pt>
                 <c:pt idx="2">
-                  <c:v>03月</c:v>
+                  <c:v>3月</c:v>
                 </c:pt>
                 <c:pt idx="3">
-                  <c:v>04月</c:v>
+                  <c:v>4月</c:v>
                 </c:pt>
                 <c:pt idx="4">
-                  <c:v>05月</c:v>
+                  <c:v>5月</c:v>
                 </c:pt>
                 <c:pt idx="5">
-                  <c:v>06月</c:v>
+                  <c:v>6月</c:v>
                 </c:pt>
                 <c:pt idx="6">
-                  <c:v>07月</c:v>
+                  <c:v>7月</c:v>
                 </c:pt>
                 <c:pt idx="7">
-                  <c:v>08月</c:v>
+                  <c:v>8月</c:v>
                 </c:pt>
                 <c:pt idx="8">
-                  <c:v>09月</c:v>
+                  <c:v>9月</c:v>
                 </c:pt>
                 <c:pt idx="9">
                   <c:v>10月</c:v>
@@ -256,15 +254,12 @@
               </c:numCache>
             </c:numRef>
           </c:val>
-          <c:smooth val="0"/>
         </c:ser>
-        <c:marker val="1"/>
-        <c:smooth val="0"/>
-        <c:axId val="2118791784"/>
-        <c:axId val="2140495176"/>
-      </c:lineChart>
+        <c:axId val="-2068027336"/>
+        <c:axId val="-2113994440"/>
+      </c:barChart>
       <c:catAx>
-        <c:axId val="2118791784"/>
+        <c:axId val="-2068027336"/>
         <c:scaling>
           <c:orientation val="minMax"/>
         </c:scaling>
@@ -273,7 +268,7 @@
         <c:majorTickMark val="out"/>
         <c:minorTickMark val="none"/>
         <c:tickLblPos val="nextTo"/>
-        <c:crossAx val="2140495176"/>
+        <c:crossAx val="-2113994440"/>
         <c:crosses val="autoZero"/>
         <c:auto val="1"/>
         <c:lblAlgn val="ctr"/>
@@ -281,41 +276,138 @@
         <c:noMultiLvlLbl val="0"/>
       </c:catAx>
       <c:valAx>
-        <c:axId val="2140495176"/>
+        <c:axId val="-2113994440"/>
         <c:scaling/>
         <c:delete val="0"/>
         <c:axPos val="l"/>
         <c:majorGridlines/>
-        <c:title>
-          <c:tx>
-            <c:rich>
-              <a:bodyPr/>
-              <a:lstStyle/>
-              <a:p>
-                <a:r>
-                  <a:t>流通卡數 (萬張)</a:t>
-                </a:r>
-              </a:p>
-            </c:rich>
-          </c:tx>
-          <c:layout/>
-          <c:overlay val="0"/>
-        </c:title>
         <c:majorTickMark val="out"/>
         <c:minorTickMark val="none"/>
         <c:tickLblPos val="nextTo"/>
-        <c:crossAx val="2118791784"/>
+        <c:crossAx val="-2068027336"/>
         <c:crosses val="autoZero"/>
       </c:valAx>
+      <c:lineChart>
+        <c:grouping val="standard"/>
+        <c:ser>
+          <c:idx val="1"/>
+          <c:order val="1"/>
+          <c:tx>
+            <c:strRef>
+              <c:f>Sheet1!$C$1</c:f>
+              <c:strCache>
+                <c:ptCount val="1"/>
+                <c:pt idx="0">
+                  <c:v>簽帳金額(億元)</c:v>
+                </c:pt>
+              </c:strCache>
+            </c:strRef>
+          </c:tx>
+          <c:spPr>
+            <a:ln w="31750">
+              <a:solidFill>
+                <a:srgbClr val="0066CC"/>
+              </a:solidFill>
+            </a:ln>
+          </c:spPr>
+          <c:cat>
+            <c:strRef>
+              <c:f>Sheet1!$A$2:$A$13</c:f>
+              <c:strCache>
+                <c:ptCount val="12"/>
+                <c:pt idx="0">
+                  <c:v>1月</c:v>
+                </c:pt>
+                <c:pt idx="1">
+                  <c:v>2月</c:v>
+                </c:pt>
+                <c:pt idx="2">
+                  <c:v>3月</c:v>
+                </c:pt>
+                <c:pt idx="3">
+                  <c:v>4月</c:v>
+                </c:pt>
+                <c:pt idx="4">
+                  <c:v>5月</c:v>
+                </c:pt>
+                <c:pt idx="5">
+                  <c:v>6月</c:v>
+                </c:pt>
+                <c:pt idx="6">
+                  <c:v>7月</c:v>
+                </c:pt>
+                <c:pt idx="7">
+                  <c:v>8月</c:v>
+                </c:pt>
+                <c:pt idx="8">
+                  <c:v>9月</c:v>
+                </c:pt>
+                <c:pt idx="9">
+                  <c:v>10月</c:v>
+                </c:pt>
+                <c:pt idx="10">
+                  <c:v>11月</c:v>
+                </c:pt>
+                <c:pt idx="11">
+                  <c:v>12月</c:v>
+                </c:pt>
+              </c:strCache>
+            </c:strRef>
+          </c:cat>
+          <c:val>
+            <c:numRef>
+              <c:f>Sheet1!$C$2:$C$13</c:f>
+              <c:numCache>
+                <c:formatCode>General</c:formatCode>
+                <c:ptCount val="12"/>
+                <c:pt idx="0">
+                  <c:v>338.561389</c:v>
+                </c:pt>
+                <c:pt idx="1">
+                  <c:v>395.294658</c:v>
+                </c:pt>
+                <c:pt idx="2">
+                  <c:v>377.172642</c:v>
+                </c:pt>
+                <c:pt idx="3">
+                  <c:v>373.344235</c:v>
+                </c:pt>
+                <c:pt idx="4">
+                  <c:v>371.785303</c:v>
+                </c:pt>
+                <c:pt idx="5">
+                  <c:v>393.715829</c:v>
+                </c:pt>
+                <c:pt idx="6">
+                  <c:v>653.264628</c:v>
+                </c:pt>
+                <c:pt idx="7">
+                  <c:v>376.250456</c:v>
+                </c:pt>
+                <c:pt idx="8">
+                  <c:v>403.174279</c:v>
+                </c:pt>
+                <c:pt idx="9">
+                  <c:v>453.412126</c:v>
+                </c:pt>
+                <c:pt idx="10">
+                  <c:v>396.704763</c:v>
+                </c:pt>
+                <c:pt idx="11">
+                  <c:v>453.663538</c:v>
+                </c:pt>
+              </c:numCache>
+            </c:numRef>
+          </c:val>
+        </c:ser>
+        <c:marker>
+          <c:val>1</c:val>
+        </c:marker>
+        <c:axId val="-2068027336"/>
+        <c:axId val="-2113994440"/>
+      </c:lineChart>
     </c:plotArea>
-    <c:legend>
-      <c:legendPos val="r"/>
-      <c:layout/>
-      <c:overlay val="0"/>
-    </c:legend>
-    <c:plotVisOnly val="1"/>
     <c:dispBlanksAs val="gap"/>
-    <c:showDLblsOverMax val="0"/>
   </c:chart>
   <c:txPr>
     <a:bodyPr/>
@@ -344,7 +436,7 @@
           <a:lstStyle/>
           <a:p>
             <a:r>
-              <a:t>流通卡數市佔率排名 TOP10</a:t>
+              <a:t>流通卡數市占率 Top 10</a:t>
             </a:r>
           </a:p>
         </c:rich>
@@ -366,7 +458,7 @@
               <c:strCache>
                 <c:ptCount val="1"/>
                 <c:pt idx="0">
-                  <c:v>市佔率(%)</c:v>
+                  <c:v>市占率(%)</c:v>
                 </c:pt>
               </c:strCache>
             </c:strRef>
@@ -398,34 +490,34 @@
               <c:strCache>
                 <c:ptCount val="10"/>
                 <c:pt idx="0">
-                  <c:v>中國信託商業銀行</c:v>
+                  <c:v>中國信託</c:v>
                 </c:pt>
                 <c:pt idx="1">
-                  <c:v>玉山商業銀行</c:v>
+                  <c:v>玉山</c:v>
                 </c:pt>
                 <c:pt idx="2">
-                  <c:v>台北富邦商業銀行</c:v>
+                  <c:v>台北富邦</c:v>
                 </c:pt>
                 <c:pt idx="3">
-                  <c:v>國泰世華商業銀行</c:v>
+                  <c:v>國泰世華</c:v>
                 </c:pt>
                 <c:pt idx="4">
-                  <c:v>台新國際商業銀行</c:v>
+                  <c:v>台新</c:v>
                 </c:pt>
                 <c:pt idx="5">
-                  <c:v>星展(台灣)商業銀行</c:v>
+                  <c:v>星展(台灣)</c:v>
                 </c:pt>
                 <c:pt idx="6">
-                  <c:v>聯邦商業銀行</c:v>
+                  <c:v>聯邦</c:v>
                 </c:pt>
                 <c:pt idx="7">
-                  <c:v>永豐商業銀行</c:v>
+                  <c:v>永豐</c:v>
                 </c:pt>
                 <c:pt idx="8">
-                  <c:v>第一商業銀行</c:v>
+                  <c:v>第一</c:v>
                 </c:pt>
                 <c:pt idx="9">
-                  <c:v>遠東國際商業銀行</c:v>
+                  <c:v>遠東</c:v>
                 </c:pt>
               </c:strCache>
             </c:strRef>
@@ -437,34 +529,34 @@
                 <c:formatCode>General</c:formatCode>
                 <c:ptCount val="10"/>
                 <c:pt idx="0">
-                  <c:v>15.37</c:v>
+                  <c:v>15.64</c:v>
                 </c:pt>
                 <c:pt idx="1">
-                  <c:v>14.04</c:v>
+                  <c:v>14.46</c:v>
                 </c:pt>
                 <c:pt idx="2">
-                  <c:v>12.41</c:v>
+                  <c:v>12.22</c:v>
                 </c:pt>
                 <c:pt idx="3">
-                  <c:v>12.3</c:v>
+                  <c:v>12.13</c:v>
                 </c:pt>
                 <c:pt idx="4">
-                  <c:v>11.07</c:v>
+                  <c:v>10.97</c:v>
                 </c:pt>
                 <c:pt idx="5">
-                  <c:v>5.54</c:v>
+                  <c:v>5.5</c:v>
                 </c:pt>
                 <c:pt idx="6">
-                  <c:v>4.6</c:v>
+                  <c:v>4.52</c:v>
                 </c:pt>
                 <c:pt idx="7">
-                  <c:v>4.02</c:v>
+                  <c:v>4.1</c:v>
                 </c:pt>
                 <c:pt idx="8">
-                  <c:v>2.52</c:v>
+                  <c:v>2.53</c:v>
                 </c:pt>
                 <c:pt idx="9">
-                  <c:v>2.23</c:v>
+                  <c:v>2.13</c:v>
                 </c:pt>
               </c:numCache>
             </c:numRef>
@@ -496,21 +588,6 @@
         <c:delete val="0"/>
         <c:axPos val="l"/>
         <c:majorGridlines/>
-        <c:title>
-          <c:tx>
-            <c:rich>
-              <a:bodyPr/>
-              <a:lstStyle/>
-              <a:p>
-                <a:r>
-                  <a:t>市佔率 (%)</a:t>
-                </a:r>
-              </a:p>
-            </c:rich>
-          </c:tx>
-          <c:layout/>
-          <c:overlay val="0"/>
-        </c:title>
         <c:majorTickMark val="out"/>
         <c:minorTickMark val="none"/>
         <c:tickLblPos val="nextTo"/>
@@ -546,7 +623,7 @@
           <a:lstStyle/>
           <a:p>
             <a:r>
-              <a:t>規模 vs 月增率</a:t>
+              <a:t>規模 vs 成長</a:t>
             </a:r>
           </a:p>
         </c:rich>
@@ -579,78 +656,90 @@
           </c:spPr>
           <c:xVal>
             <c:numRef>
-              <c:f>Sheet1!$A$2:$A$11</c:f>
+              <c:f>Sheet1!$A$2:$A$13</c:f>
               <c:numCache>
                 <c:formatCode>General</c:formatCode>
-                <c:ptCount val="10"/>
+                <c:ptCount val="12"/>
                 <c:pt idx="0">
-                  <c:v>945.8</c:v>
+                  <c:v>2.1049</c:v>
                 </c:pt>
                 <c:pt idx="1">
-                  <c:v>874.8</c:v>
+                  <c:v>38.4715</c:v>
                 </c:pt>
                 <c:pt idx="2">
-                  <c:v>739.1</c:v>
+                  <c:v>945.8117</c:v>
                 </c:pt>
                 <c:pt idx="3">
-                  <c:v>733.7</c:v>
+                  <c:v>121.6355</c:v>
                 </c:pt>
                 <c:pt idx="4">
-                  <c:v>663.3</c:v>
+                  <c:v>110.6955</c:v>
                 </c:pt>
                 <c:pt idx="5">
-                  <c:v>332.5</c:v>
+                  <c:v>42.3651</c:v>
                 </c:pt>
                 <c:pt idx="6">
-                  <c:v>273.2</c:v>
+                  <c:v>15.4419</c:v>
                 </c:pt>
                 <c:pt idx="7">
-                  <c:v>247.9</c:v>
+                  <c:v>739.1132</c:v>
                 </c:pt>
                 <c:pt idx="8">
-                  <c:v>153.1</c:v>
+                  <c:v>663.2949</c:v>
                 </c:pt>
                 <c:pt idx="9">
-                  <c:v>129.0</c:v>
+                  <c:v>60.2725</c:v>
+                </c:pt>
+                <c:pt idx="10">
+                  <c:v>19.8246</c:v>
+                </c:pt>
+                <c:pt idx="11">
+                  <c:v>67.268</c:v>
                 </c:pt>
               </c:numCache>
             </c:numRef>
           </c:xVal>
           <c:yVal>
             <c:numRef>
-              <c:f>Sheet1!$B$2:$B$11</c:f>
+              <c:f>Sheet1!$B$2:$B$13</c:f>
               <c:numCache>
                 <c:formatCode>General</c:formatCode>
-                <c:ptCount val="10"/>
+                <c:ptCount val="12"/>
                 <c:pt idx="0">
+                  <c:v>-0.8</c:v>
+                </c:pt>
+                <c:pt idx="1">
+                  <c:v>-0.17</c:v>
+                </c:pt>
+                <c:pt idx="2">
                   <c:v>0.58</c:v>
                 </c:pt>
-                <c:pt idx="1">
-                  <c:v>0.48</c:v>
-                </c:pt>
-                <c:pt idx="2">
+                <c:pt idx="3">
+                  <c:v>0.03</c:v>
+                </c:pt>
+                <c:pt idx="4">
+                  <c:v>-0.39</c:v>
+                </c:pt>
+                <c:pt idx="5">
+                  <c:v>1.18</c:v>
+                </c:pt>
+                <c:pt idx="6">
+                  <c:v>0.42</c:v>
+                </c:pt>
+                <c:pt idx="7">
                   <c:v>0.3</c:v>
                 </c:pt>
-                <c:pt idx="3">
-                  <c:v>-0.56</c:v>
-                </c:pt>
-                <c:pt idx="4">
+                <c:pt idx="8">
                   <c:v>-0.0</c:v>
                 </c:pt>
-                <c:pt idx="5">
-                  <c:v>-0.94</c:v>
-                </c:pt>
-                <c:pt idx="6">
-                  <c:v>0.27</c:v>
-                </c:pt>
-                <c:pt idx="7">
-                  <c:v>0.42</c:v>
-                </c:pt>
-                <c:pt idx="8">
-                  <c:v>0.15</c:v>
-                </c:pt>
                 <c:pt idx="9">
-                  <c:v>-0.19</c:v>
+                  <c:v>3.6</c:v>
+                </c:pt>
+                <c:pt idx="10">
+                  <c:v>-0.5</c:v>
+                </c:pt>
+                <c:pt idx="11">
+                  <c:v>-0.69</c:v>
                 </c:pt>
               </c:numCache>
             </c:numRef>
@@ -659,6 +748,44 @@
           <c:dLbls>
             <c:dLbl>
               <c:idx val="0"/>
+              <c:dLblPos val="t"/>
+              <c:tx>
+                <c:rich>
+                  <a:bodyPr/>
+                  <a:lstStyle/>
+                  <a:p>
+                    <a:r>
+                      <a:rPr lang="zh-TW" sz="1000"/>
+                      <a:t>三信商業銀行</a:t>
+                    </a:r>
+                  </a:p>
+                </c:rich>
+              </c:tx>
+              <c:showVal val="0"/>
+              <c:showCatName val="0"/>
+              <c:showSerName val="0"/>
+            </c:dLbl>
+            <c:dLbl>
+              <c:idx val="1"/>
+              <c:dLblPos val="t"/>
+              <c:tx>
+                <c:rich>
+                  <a:bodyPr/>
+                  <a:lstStyle/>
+                  <a:p>
+                    <a:r>
+                      <a:rPr lang="zh-TW" sz="1000"/>
+                      <a:t>上海商業儲蓄銀行</a:t>
+                    </a:r>
+                  </a:p>
+                </c:rich>
+              </c:tx>
+              <c:showVal val="0"/>
+              <c:showCatName val="0"/>
+              <c:showSerName val="0"/>
+            </c:dLbl>
+            <c:dLbl>
+              <c:idx val="2"/>
               <c:dLblPos val="t"/>
               <c:tx>
                 <c:rich>
@@ -677,7 +804,7 @@
               <c:showSerName val="0"/>
             </c:dLbl>
             <c:dLbl>
-              <c:idx val="1"/>
+              <c:idx val="3"/>
               <c:dLblPos val="t"/>
               <c:tx>
                 <c:rich>
@@ -686,7 +813,7 @@
                   <a:p>
                     <a:r>
                       <a:rPr lang="zh-TW" sz="1000"/>
-                      <a:t>玉山商業銀行</a:t>
+                      <a:t>元大商業銀行</a:t>
                     </a:r>
                   </a:p>
                 </c:rich>
@@ -696,7 +823,64 @@
               <c:showSerName val="0"/>
             </c:dLbl>
             <c:dLbl>
-              <c:idx val="2"/>
+              <c:idx val="4"/>
+              <c:dLblPos val="t"/>
+              <c:tx>
+                <c:rich>
+                  <a:bodyPr/>
+                  <a:lstStyle/>
+                  <a:p>
+                    <a:r>
+                      <a:rPr lang="zh-TW" sz="1000"/>
+                      <a:t>兆豐國際商業銀行</a:t>
+                    </a:r>
+                  </a:p>
+                </c:rich>
+              </c:tx>
+              <c:showVal val="0"/>
+              <c:showCatName val="0"/>
+              <c:showSerName val="0"/>
+            </c:dLbl>
+            <c:dLbl>
+              <c:idx val="5"/>
+              <c:dLblPos val="t"/>
+              <c:tx>
+                <c:rich>
+                  <a:bodyPr/>
+                  <a:lstStyle/>
+                  <a:p>
+                    <a:r>
+                      <a:rPr lang="zh-TW" sz="1000"/>
+                      <a:t>凱基商業銀行</a:t>
+                    </a:r>
+                  </a:p>
+                </c:rich>
+              </c:tx>
+              <c:showVal val="0"/>
+              <c:showCatName val="0"/>
+              <c:showSerName val="0"/>
+            </c:dLbl>
+            <c:dLbl>
+              <c:idx val="6"/>
+              <c:dLblPos val="t"/>
+              <c:tx>
+                <c:rich>
+                  <a:bodyPr/>
+                  <a:lstStyle/>
+                  <a:p>
+                    <a:r>
+                      <a:rPr lang="zh-TW" sz="1000"/>
+                      <a:t>台中商業銀行</a:t>
+                    </a:r>
+                  </a:p>
+                </c:rich>
+              </c:tx>
+              <c:showVal val="0"/>
+              <c:showCatName val="0"/>
+              <c:showSerName val="0"/>
+            </c:dLbl>
+            <c:dLbl>
+              <c:idx val="7"/>
               <c:dLblPos val="t"/>
               <c:tx>
                 <c:rich>
@@ -715,26 +899,7 @@
               <c:showSerName val="0"/>
             </c:dLbl>
             <c:dLbl>
-              <c:idx val="3"/>
-              <c:dLblPos val="t"/>
-              <c:tx>
-                <c:rich>
-                  <a:bodyPr/>
-                  <a:lstStyle/>
-                  <a:p>
-                    <a:r>
-                      <a:rPr lang="zh-TW" sz="1000"/>
-                      <a:t>國泰世華商業銀行</a:t>
-                    </a:r>
-                  </a:p>
-                </c:rich>
-              </c:tx>
-              <c:showVal val="0"/>
-              <c:showCatName val="0"/>
-              <c:showSerName val="0"/>
-            </c:dLbl>
-            <c:dLbl>
-              <c:idx val="4"/>
+              <c:idx val="8"/>
               <c:dLblPos val="t"/>
               <c:tx>
                 <c:rich>
@@ -753,7 +918,7 @@
               <c:showSerName val="0"/>
             </c:dLbl>
             <c:dLbl>
-              <c:idx val="5"/>
+              <c:idx val="9"/>
               <c:dLblPos val="t"/>
               <c:tx>
                 <c:rich>
@@ -762,7 +927,7 @@
                   <a:p>
                     <a:r>
                       <a:rPr lang="zh-TW" sz="1000"/>
-                      <a:t>星展(台灣)商業銀行</a:t>
+                      <a:t>台灣樂天信用卡股份有限公司</a:t>
                     </a:r>
                   </a:p>
                 </c:rich>
@@ -772,7 +937,7 @@
               <c:showSerName val="0"/>
             </c:dLbl>
             <c:dLbl>
-              <c:idx val="6"/>
+              <c:idx val="10"/>
               <c:dLblPos val="t"/>
               <c:tx>
                 <c:rich>
@@ -781,7 +946,7 @@
                   <a:p>
                     <a:r>
                       <a:rPr lang="zh-TW" sz="1000"/>
-                      <a:t>聯邦商業銀行</a:t>
+                      <a:t>台灣美國運通國際(股)公司</a:t>
                     </a:r>
                   </a:p>
                 </c:rich>
@@ -791,7 +956,7 @@
               <c:showSerName val="0"/>
             </c:dLbl>
             <c:dLbl>
-              <c:idx val="7"/>
+              <c:idx val="11"/>
               <c:dLblPos val="t"/>
               <c:tx>
                 <c:rich>
@@ -800,45 +965,7 @@
                   <a:p>
                     <a:r>
                       <a:rPr lang="zh-TW" sz="1000"/>
-                      <a:t>永豐商業銀行</a:t>
-                    </a:r>
-                  </a:p>
-                </c:rich>
-              </c:tx>
-              <c:showVal val="0"/>
-              <c:showCatName val="0"/>
-              <c:showSerName val="0"/>
-            </c:dLbl>
-            <c:dLbl>
-              <c:idx val="8"/>
-              <c:dLblPos val="t"/>
-              <c:tx>
-                <c:rich>
-                  <a:bodyPr/>
-                  <a:lstStyle/>
-                  <a:p>
-                    <a:r>
-                      <a:rPr lang="zh-TW" sz="1000"/>
-                      <a:t>第一商業銀行</a:t>
-                    </a:r>
-                  </a:p>
-                </c:rich>
-              </c:tx>
-              <c:showVal val="0"/>
-              <c:showCatName val="0"/>
-              <c:showSerName val="0"/>
-            </c:dLbl>
-            <c:dLbl>
-              <c:idx val="9"/>
-              <c:dLblPos val="t"/>
-              <c:tx>
-                <c:rich>
-                  <a:bodyPr/>
-                  <a:lstStyle/>
-                  <a:p>
-                    <a:r>
-                      <a:rPr lang="zh-TW" sz="1000"/>
-                      <a:t>遠東國際商業銀行</a:t>
+                      <a:t>合作金庫商業銀行</a:t>
                     </a:r>
                   </a:p>
                 </c:rich>
@@ -859,21 +986,6 @@
         </c:scaling>
         <c:delete val="0"/>
         <c:axPos val="b"/>
-        <c:title>
-          <c:tx>
-            <c:rich>
-              <a:bodyPr/>
-              <a:lstStyle/>
-              <a:p>
-                <a:r>
-                  <a:t>流通卡數（萬張）</a:t>
-                </a:r>
-              </a:p>
-            </c:rich>
-          </c:tx>
-          <c:layout/>
-          <c:overlay val="0"/>
-        </c:title>
         <c:numFmt formatCode="General" sourceLinked="1"/>
         <c:majorTickMark val="out"/>
         <c:minorTickMark val="none"/>
@@ -890,21 +1002,6 @@
         <c:delete val="0"/>
         <c:axPos val="l"/>
         <c:majorGridlines/>
-        <c:title>
-          <c:tx>
-            <c:rich>
-              <a:bodyPr/>
-              <a:lstStyle/>
-              <a:p>
-                <a:r>
-                  <a:t>月增率（%）</a:t>
-                </a:r>
-              </a:p>
-            </c:rich>
-          </c:tx>
-          <c:layout/>
-          <c:overlay val="0"/>
-        </c:title>
         <c:numFmt formatCode="General" sourceLinked="1"/>
         <c:majorTickMark val="out"/>
         <c:minorTickMark val="none"/>
@@ -950,7 +1047,7 @@
           <a:lstStyle/>
           <a:p>
             <a:r>
-              <a:t>當月簽帳金額 TOP10</a:t>
+              <a:t>卡數 vs 簽帳市占率</a:t>
             </a:r>
           </a:p>
         </c:rich>
@@ -972,7 +1069,7 @@
               <c:strCache>
                 <c:ptCount val="1"/>
                 <c:pt idx="0">
-                  <c:v>當月簽帳金額</c:v>
+                  <c:v>卡數市占(%)</c:v>
                 </c:pt>
               </c:strCache>
             </c:strRef>
@@ -982,95 +1079,152 @@
               <a:srgbClr val="003366"/>
             </a:solidFill>
           </c:spPr>
-          <c:dPt>
-            <c:idx val="0"/>
-            <c:spPr>
-              <a:solidFill>
-                <a:srgbClr val="FFCC00"/>
-              </a:solidFill>
-            </c:spPr>
-          </c:dPt>
-          <c:dPt>
-            <c:idx val="4"/>
-            <c:spPr>
-              <a:solidFill>
-                <a:srgbClr val="003366"/>
-              </a:solidFill>
-            </c:spPr>
-          </c:dPt>
           <c:cat>
             <c:strRef>
-              <c:f>Sheet1!$A$2:$A$11</c:f>
+              <c:f>Sheet1!$A$2:$A$9</c:f>
               <c:strCache>
-                <c:ptCount val="10"/>
+                <c:ptCount val="8"/>
                 <c:pt idx="0">
-                  <c:v>中國信託商業銀行</c:v>
+                  <c:v>中國信託</c:v>
                 </c:pt>
                 <c:pt idx="1">
-                  <c:v>國泰世華商業銀行</c:v>
+                  <c:v>玉山</c:v>
                 </c:pt>
                 <c:pt idx="2">
-                  <c:v>台北富邦商業銀行</c:v>
+                  <c:v>台北富邦</c:v>
                 </c:pt>
                 <c:pt idx="3">
-                  <c:v>玉山商業銀行</c:v>
+                  <c:v>國泰世華</c:v>
                 </c:pt>
                 <c:pt idx="4">
-                  <c:v>台新國際商業銀行</c:v>
+                  <c:v>台新</c:v>
                 </c:pt>
                 <c:pt idx="5">
-                  <c:v>星展(台灣)商業銀行</c:v>
+                  <c:v>星展(台灣)</c:v>
                 </c:pt>
                 <c:pt idx="6">
-                  <c:v>永豐商業銀行</c:v>
+                  <c:v>聯邦</c:v>
                 </c:pt>
                 <c:pt idx="7">
-                  <c:v>聯邦商業銀行</c:v>
-                </c:pt>
-                <c:pt idx="8">
-                  <c:v>滙豐(台灣)商業銀行</c:v>
-                </c:pt>
-                <c:pt idx="9">
-                  <c:v>第一商業銀行</c:v>
+                  <c:v>永豐</c:v>
                 </c:pt>
               </c:strCache>
             </c:strRef>
           </c:cat>
           <c:val>
             <c:numRef>
-              <c:f>Sheet1!$B$2:$B$11</c:f>
+              <c:f>Sheet1!$B$2:$B$9</c:f>
               <c:numCache>
                 <c:formatCode>General</c:formatCode>
-                <c:ptCount val="10"/>
+                <c:ptCount val="8"/>
                 <c:pt idx="0">
-                  <c:v>83917586.0</c:v>
+                  <c:v>15.64</c:v>
                 </c:pt>
                 <c:pt idx="1">
-                  <c:v>81878315.0</c:v>
+                  <c:v>14.46</c:v>
                 </c:pt>
                 <c:pt idx="2">
-                  <c:v>58873591.0</c:v>
+                  <c:v>12.22</c:v>
                 </c:pt>
                 <c:pt idx="3">
-                  <c:v>54299671.0</c:v>
+                  <c:v>12.13</c:v>
                 </c:pt>
                 <c:pt idx="4">
-                  <c:v>48399932.0</c:v>
+                  <c:v>10.97</c:v>
                 </c:pt>
                 <c:pt idx="5">
-                  <c:v>23990920.0</c:v>
+                  <c:v>5.5</c:v>
                 </c:pt>
                 <c:pt idx="6">
-                  <c:v>15837909.0</c:v>
+                  <c:v>4.52</c:v>
                 </c:pt>
                 <c:pt idx="7">
-                  <c:v>15000911.0</c:v>
-                </c:pt>
-                <c:pt idx="8">
-                  <c:v>11715342.0</c:v>
-                </c:pt>
-                <c:pt idx="9">
-                  <c:v>7583238.0</c:v>
+                  <c:v>4.1</c:v>
+                </c:pt>
+              </c:numCache>
+            </c:numRef>
+          </c:val>
+        </c:ser>
+        <c:ser>
+          <c:idx val="1"/>
+          <c:order val="1"/>
+          <c:tx>
+            <c:strRef>
+              <c:f>Sheet1!$C$1</c:f>
+              <c:strCache>
+                <c:ptCount val="1"/>
+                <c:pt idx="0">
+                  <c:v>簽帳市占(%)</c:v>
+                </c:pt>
+              </c:strCache>
+            </c:strRef>
+          </c:tx>
+          <c:spPr>
+            <a:solidFill>
+              <a:srgbClr val="0066CC"/>
+            </a:solidFill>
+          </c:spPr>
+          <c:cat>
+            <c:strRef>
+              <c:f>Sheet1!$A$2:$A$9</c:f>
+              <c:strCache>
+                <c:ptCount val="8"/>
+                <c:pt idx="0">
+                  <c:v>中國信託</c:v>
+                </c:pt>
+                <c:pt idx="1">
+                  <c:v>玉山</c:v>
+                </c:pt>
+                <c:pt idx="2">
+                  <c:v>台北富邦</c:v>
+                </c:pt>
+                <c:pt idx="3">
+                  <c:v>國泰世華</c:v>
+                </c:pt>
+                <c:pt idx="4">
+                  <c:v>台新</c:v>
+                </c:pt>
+                <c:pt idx="5">
+                  <c:v>星展(台灣)</c:v>
+                </c:pt>
+                <c:pt idx="6">
+                  <c:v>聯邦</c:v>
+                </c:pt>
+                <c:pt idx="7">
+                  <c:v>永豐</c:v>
+                </c:pt>
+              </c:strCache>
+            </c:strRef>
+          </c:cat>
+          <c:val>
+            <c:numRef>
+              <c:f>Sheet1!$C$2:$C$9</c:f>
+              <c:numCache>
+                <c:formatCode>General</c:formatCode>
+                <c:ptCount val="8"/>
+                <c:pt idx="0">
+                  <c:v>18.5</c:v>
+                </c:pt>
+                <c:pt idx="1">
+                  <c:v>11.97</c:v>
+                </c:pt>
+                <c:pt idx="2">
+                  <c:v>12.98</c:v>
+                </c:pt>
+                <c:pt idx="3">
+                  <c:v>18.05</c:v>
+                </c:pt>
+                <c:pt idx="4">
+                  <c:v>10.67</c:v>
+                </c:pt>
+                <c:pt idx="5">
+                  <c:v>5.29</c:v>
+                </c:pt>
+                <c:pt idx="6">
+                  <c:v>3.31</c:v>
+                </c:pt>
+                <c:pt idx="7">
+                  <c:v>3.49</c:v>
                 </c:pt>
               </c:numCache>
             </c:numRef>
@@ -1102,21 +1256,6 @@
         <c:delete val="0"/>
         <c:axPos val="l"/>
         <c:majorGridlines/>
-        <c:title>
-          <c:tx>
-            <c:rich>
-              <a:bodyPr/>
-              <a:lstStyle/>
-              <a:p>
-                <a:r>
-                  <a:t>簽帳金額 (千元)</a:t>
-                </a:r>
-              </a:p>
-            </c:rich>
-          </c:tx>
-          <c:layout/>
-          <c:overlay val="0"/>
-        </c:title>
         <c:majorTickMark val="out"/>
         <c:minorTickMark val="none"/>
         <c:tickLblPos val="nextTo"/>
@@ -1153,7 +1292,7 @@
           <a:lstStyle/>
           <a:p>
             <a:r>
-              <a:t>流通卡數 TOP10</a:t>
+              <a:t>每卡簽帳金額(元/卡)</a:t>
             </a:r>
           </a:p>
         </c:rich>
@@ -1175,7 +1314,7 @@
               <c:strCache>
                 <c:ptCount val="1"/>
                 <c:pt idx="0">
-                  <c:v>流通卡數</c:v>
+                  <c:v>每卡簽帳(元)</c:v>
                 </c:pt>
               </c:strCache>
             </c:strRef>
@@ -1203,77 +1342,65 @@
           </c:dPt>
           <c:cat>
             <c:strRef>
-              <c:f>Sheet1!$A$2:$A$11</c:f>
+              <c:f>Sheet1!$A$2:$A$9</c:f>
               <c:strCache>
-                <c:ptCount val="10"/>
+                <c:ptCount val="8"/>
                 <c:pt idx="0">
-                  <c:v>中國信託商業銀行</c:v>
+                  <c:v>中國信託</c:v>
                 </c:pt>
                 <c:pt idx="1">
-                  <c:v>玉山商業銀行</c:v>
+                  <c:v>玉山</c:v>
                 </c:pt>
                 <c:pt idx="2">
-                  <c:v>台北富邦商業銀行</c:v>
+                  <c:v>台北富邦</c:v>
                 </c:pt>
                 <c:pt idx="3">
-                  <c:v>國泰世華商業銀行</c:v>
+                  <c:v>國泰世華</c:v>
                 </c:pt>
                 <c:pt idx="4">
-                  <c:v>台新國際商業銀行</c:v>
+                  <c:v>台新</c:v>
                 </c:pt>
                 <c:pt idx="5">
-                  <c:v>星展(台灣)商業銀行</c:v>
+                  <c:v>星展(台灣)</c:v>
                 </c:pt>
                 <c:pt idx="6">
-                  <c:v>聯邦商業銀行</c:v>
+                  <c:v>聯邦</c:v>
                 </c:pt>
                 <c:pt idx="7">
-                  <c:v>永豐商業銀行</c:v>
-                </c:pt>
-                <c:pt idx="8">
-                  <c:v>第一商業銀行</c:v>
-                </c:pt>
-                <c:pt idx="9">
-                  <c:v>遠東國際商業銀行</c:v>
+                  <c:v>永豐</c:v>
                 </c:pt>
               </c:strCache>
             </c:strRef>
           </c:cat>
           <c:val>
             <c:numRef>
-              <c:f>Sheet1!$B$2:$B$11</c:f>
+              <c:f>Sheet1!$B$2:$B$9</c:f>
               <c:numCache>
                 <c:formatCode>General</c:formatCode>
-                <c:ptCount val="10"/>
+                <c:ptCount val="8"/>
                 <c:pt idx="0">
-                  <c:v>9458117.0</c:v>
+                  <c:v>8873.0</c:v>
                 </c:pt>
                 <c:pt idx="1">
-                  <c:v>8748065.0</c:v>
+                  <c:v>6207.0</c:v>
                 </c:pt>
                 <c:pt idx="2">
-                  <c:v>7391132.0</c:v>
+                  <c:v>7965.0</c:v>
                 </c:pt>
                 <c:pt idx="3">
-                  <c:v>7337214.0</c:v>
+                  <c:v>11159.0</c:v>
                 </c:pt>
                 <c:pt idx="4">
-                  <c:v>6632949.0</c:v>
+                  <c:v>7297.0</c:v>
                 </c:pt>
                 <c:pt idx="5">
-                  <c:v>3324547.0</c:v>
+                  <c:v>7216.0</c:v>
                 </c:pt>
                 <c:pt idx="6">
-                  <c:v>2731780.0</c:v>
+                  <c:v>5491.0</c:v>
                 </c:pt>
                 <c:pt idx="7">
-                  <c:v>2478579.0</c:v>
-                </c:pt>
-                <c:pt idx="8">
-                  <c:v>1531235.0</c:v>
-                </c:pt>
-                <c:pt idx="9">
-                  <c:v>1290052.0</c:v>
+                  <c:v>6390.0</c:v>
                 </c:pt>
               </c:numCache>
             </c:numRef>
@@ -1305,21 +1432,6 @@
         <c:delete val="0"/>
         <c:axPos val="l"/>
         <c:majorGridlines/>
-        <c:title>
-          <c:tx>
-            <c:rich>
-              <a:bodyPr/>
-              <a:lstStyle/>
-              <a:p>
-                <a:r>
-                  <a:t>流通卡數 (張)</a:t>
-                </a:r>
-              </a:p>
-            </c:rich>
-          </c:tx>
-          <c:layout/>
-          <c:overlay val="0"/>
-        </c:title>
         <c:majorTickMark val="out"/>
         <c:minorTickMark val="none"/>
         <c:tickLblPos val="nextTo"/>
@@ -1356,7 +1468,7 @@
           <a:lstStyle/>
           <a:p>
             <a:r>
-              <a:t>簽帳金額 TOP5 近 6 月趨勢（百萬元）</a:t>
+              <a:t>Top 5 銀行月簽帳金額</a:t>
             </a:r>
           </a:p>
         </c:rich>
@@ -1378,7 +1490,7 @@
               <c:strCache>
                 <c:ptCount val="1"/>
                 <c:pt idx="0">
-                  <c:v>中國信託商業銀行</c:v>
+                  <c:v>中國信託</c:v>
                 </c:pt>
               </c:strCache>
             </c:strRef>
@@ -1390,25 +1502,43 @@
           </c:spPr>
           <c:cat>
             <c:strRef>
-              <c:f>Sheet1!$A$2:$A$7</c:f>
+              <c:f>Sheet1!$A$2:$A$13</c:f>
               <c:strCache>
-                <c:ptCount val="6"/>
+                <c:ptCount val="12"/>
                 <c:pt idx="0">
-                  <c:v>07月</c:v>
+                  <c:v>1月</c:v>
                 </c:pt>
                 <c:pt idx="1">
-                  <c:v>08月</c:v>
+                  <c:v>2月</c:v>
                 </c:pt>
                 <c:pt idx="2">
-                  <c:v>09月</c:v>
+                  <c:v>3月</c:v>
                 </c:pt>
                 <c:pt idx="3">
+                  <c:v>4月</c:v>
+                </c:pt>
+                <c:pt idx="4">
+                  <c:v>5月</c:v>
+                </c:pt>
+                <c:pt idx="5">
+                  <c:v>6月</c:v>
+                </c:pt>
+                <c:pt idx="6">
+                  <c:v>7月</c:v>
+                </c:pt>
+                <c:pt idx="7">
+                  <c:v>8月</c:v>
+                </c:pt>
+                <c:pt idx="8">
+                  <c:v>9月</c:v>
+                </c:pt>
+                <c:pt idx="9">
                   <c:v>10月</c:v>
                 </c:pt>
-                <c:pt idx="4">
+                <c:pt idx="10">
                   <c:v>11月</c:v>
                 </c:pt>
-                <c:pt idx="5">
+                <c:pt idx="11">
                   <c:v>12月</c:v>
                 </c:pt>
               </c:strCache>
@@ -1416,27 +1546,45 @@
           </c:cat>
           <c:val>
             <c:numRef>
-              <c:f>Sheet1!$B$2:$B$7</c:f>
+              <c:f>Sheet1!$B$2:$B$13</c:f>
               <c:numCache>
                 <c:formatCode>General</c:formatCode>
-                <c:ptCount val="6"/>
+                <c:ptCount val="12"/>
                 <c:pt idx="0">
-                  <c:v>125976.593</c:v>
+                  <c:v>55.5</c:v>
                 </c:pt>
                 <c:pt idx="1">
-                  <c:v>66950.018</c:v>
+                  <c:v>70.6</c:v>
                 </c:pt>
                 <c:pt idx="2">
-                  <c:v>73733.664</c:v>
+                  <c:v>66.9</c:v>
                 </c:pt>
                 <c:pt idx="3">
-                  <c:v>80096.712</c:v>
+                  <c:v>64.1</c:v>
                 </c:pt>
                 <c:pt idx="4">
-                  <c:v>72454.17</c:v>
+                  <c:v>62.9</c:v>
                 </c:pt>
                 <c:pt idx="5">
-                  <c:v>83917.586</c:v>
+                  <c:v>67.1</c:v>
+                </c:pt>
+                <c:pt idx="6">
+                  <c:v>126.0</c:v>
+                </c:pt>
+                <c:pt idx="7">
+                  <c:v>67.0</c:v>
+                </c:pt>
+                <c:pt idx="8">
+                  <c:v>73.7</c:v>
+                </c:pt>
+                <c:pt idx="9">
+                  <c:v>80.1</c:v>
+                </c:pt>
+                <c:pt idx="10">
+                  <c:v>72.5</c:v>
+                </c:pt>
+                <c:pt idx="11">
+                  <c:v>83.9</c:v>
                 </c:pt>
               </c:numCache>
             </c:numRef>
@@ -1451,7 +1599,7 @@
               <c:strCache>
                 <c:ptCount val="1"/>
                 <c:pt idx="0">
-                  <c:v>國泰世華商業銀行</c:v>
+                  <c:v>國泰世華</c:v>
                 </c:pt>
               </c:strCache>
             </c:strRef>
@@ -1463,25 +1611,43 @@
           </c:spPr>
           <c:cat>
             <c:strRef>
-              <c:f>Sheet1!$A$2:$A$7</c:f>
+              <c:f>Sheet1!$A$2:$A$13</c:f>
               <c:strCache>
-                <c:ptCount val="6"/>
+                <c:ptCount val="12"/>
                 <c:pt idx="0">
-                  <c:v>07月</c:v>
+                  <c:v>1月</c:v>
                 </c:pt>
                 <c:pt idx="1">
-                  <c:v>08月</c:v>
+                  <c:v>2月</c:v>
                 </c:pt>
                 <c:pt idx="2">
-                  <c:v>09月</c:v>
+                  <c:v>3月</c:v>
                 </c:pt>
                 <c:pt idx="3">
+                  <c:v>4月</c:v>
+                </c:pt>
+                <c:pt idx="4">
+                  <c:v>5月</c:v>
+                </c:pt>
+                <c:pt idx="5">
+                  <c:v>6月</c:v>
+                </c:pt>
+                <c:pt idx="6">
+                  <c:v>7月</c:v>
+                </c:pt>
+                <c:pt idx="7">
+                  <c:v>8月</c:v>
+                </c:pt>
+                <c:pt idx="8">
+                  <c:v>9月</c:v>
+                </c:pt>
+                <c:pt idx="9">
                   <c:v>10月</c:v>
                 </c:pt>
-                <c:pt idx="4">
+                <c:pt idx="10">
                   <c:v>11月</c:v>
                 </c:pt>
-                <c:pt idx="5">
+                <c:pt idx="11">
                   <c:v>12月</c:v>
                 </c:pt>
               </c:strCache>
@@ -1489,27 +1655,45 @@
           </c:cat>
           <c:val>
             <c:numRef>
-              <c:f>Sheet1!$C$2:$C$7</c:f>
+              <c:f>Sheet1!$C$2:$C$13</c:f>
               <c:numCache>
                 <c:formatCode>General</c:formatCode>
-                <c:ptCount val="6"/>
+                <c:ptCount val="12"/>
                 <c:pt idx="0">
-                  <c:v>101706.31</c:v>
+                  <c:v>53.2</c:v>
                 </c:pt>
                 <c:pt idx="1">
-                  <c:v>65055.781</c:v>
+                  <c:v>69.7</c:v>
                 </c:pt>
                 <c:pt idx="2">
-                  <c:v>71463.253</c:v>
+                  <c:v>65.9</c:v>
                 </c:pt>
                 <c:pt idx="3">
-                  <c:v>79077.303</c:v>
+                  <c:v>66.8</c:v>
                 </c:pt>
                 <c:pt idx="4">
-                  <c:v>69309.873</c:v>
+                  <c:v>63.1</c:v>
                 </c:pt>
                 <c:pt idx="5">
-                  <c:v>81878.315</c:v>
+                  <c:v>68.5</c:v>
+                </c:pt>
+                <c:pt idx="6">
+                  <c:v>101.7</c:v>
+                </c:pt>
+                <c:pt idx="7">
+                  <c:v>65.1</c:v>
+                </c:pt>
+                <c:pt idx="8">
+                  <c:v>71.5</c:v>
+                </c:pt>
+                <c:pt idx="9">
+                  <c:v>79.1</c:v>
+                </c:pt>
+                <c:pt idx="10">
+                  <c:v>69.3</c:v>
+                </c:pt>
+                <c:pt idx="11">
+                  <c:v>81.9</c:v>
                 </c:pt>
               </c:numCache>
             </c:numRef>
@@ -1524,7 +1708,7 @@
               <c:strCache>
                 <c:ptCount val="1"/>
                 <c:pt idx="0">
-                  <c:v>台北富邦商業銀行</c:v>
+                  <c:v>台北富邦</c:v>
                 </c:pt>
               </c:strCache>
             </c:strRef>
@@ -1536,25 +1720,43 @@
           </c:spPr>
           <c:cat>
             <c:strRef>
-              <c:f>Sheet1!$A$2:$A$7</c:f>
+              <c:f>Sheet1!$A$2:$A$13</c:f>
               <c:strCache>
-                <c:ptCount val="6"/>
+                <c:ptCount val="12"/>
                 <c:pt idx="0">
-                  <c:v>07月</c:v>
+                  <c:v>1月</c:v>
                 </c:pt>
                 <c:pt idx="1">
-                  <c:v>08月</c:v>
+                  <c:v>2月</c:v>
                 </c:pt>
                 <c:pt idx="2">
-                  <c:v>09月</c:v>
+                  <c:v>3月</c:v>
                 </c:pt>
                 <c:pt idx="3">
+                  <c:v>4月</c:v>
+                </c:pt>
+                <c:pt idx="4">
+                  <c:v>5月</c:v>
+                </c:pt>
+                <c:pt idx="5">
+                  <c:v>6月</c:v>
+                </c:pt>
+                <c:pt idx="6">
+                  <c:v>7月</c:v>
+                </c:pt>
+                <c:pt idx="7">
+                  <c:v>8月</c:v>
+                </c:pt>
+                <c:pt idx="8">
+                  <c:v>9月</c:v>
+                </c:pt>
+                <c:pt idx="9">
                   <c:v>10月</c:v>
                 </c:pt>
-                <c:pt idx="4">
+                <c:pt idx="10">
                   <c:v>11月</c:v>
                 </c:pt>
-                <c:pt idx="5">
+                <c:pt idx="11">
                   <c:v>12月</c:v>
                 </c:pt>
               </c:strCache>
@@ -1562,27 +1764,45 @@
           </c:cat>
           <c:val>
             <c:numRef>
-              <c:f>Sheet1!$D$2:$D$7</c:f>
+              <c:f>Sheet1!$D$2:$D$13</c:f>
               <c:numCache>
                 <c:formatCode>General</c:formatCode>
-                <c:ptCount val="6"/>
+                <c:ptCount val="12"/>
                 <c:pt idx="0">
-                  <c:v>70997.069</c:v>
+                  <c:v>45.7</c:v>
                 </c:pt>
                 <c:pt idx="1">
-                  <c:v>47355.858</c:v>
+                  <c:v>52.3</c:v>
                 </c:pt>
                 <c:pt idx="2">
-                  <c:v>48349.084</c:v>
+                  <c:v>48.0</c:v>
                 </c:pt>
                 <c:pt idx="3">
-                  <c:v>56553.764</c:v>
+                  <c:v>49.5</c:v>
                 </c:pt>
                 <c:pt idx="4">
-                  <c:v>51145.814</c:v>
+                  <c:v>48.5</c:v>
                 </c:pt>
                 <c:pt idx="5">
-                  <c:v>58873.591</c:v>
+                  <c:v>51.0</c:v>
+                </c:pt>
+                <c:pt idx="6">
+                  <c:v>71.0</c:v>
+                </c:pt>
+                <c:pt idx="7">
+                  <c:v>47.4</c:v>
+                </c:pt>
+                <c:pt idx="8">
+                  <c:v>48.3</c:v>
+                </c:pt>
+                <c:pt idx="9">
+                  <c:v>56.6</c:v>
+                </c:pt>
+                <c:pt idx="10">
+                  <c:v>51.1</c:v>
+                </c:pt>
+                <c:pt idx="11">
+                  <c:v>58.9</c:v>
                 </c:pt>
               </c:numCache>
             </c:numRef>
@@ -1597,7 +1817,7 @@
               <c:strCache>
                 <c:ptCount val="1"/>
                 <c:pt idx="0">
-                  <c:v>玉山商業銀行</c:v>
+                  <c:v>玉山</c:v>
                 </c:pt>
               </c:strCache>
             </c:strRef>
@@ -1609,25 +1829,43 @@
           </c:spPr>
           <c:cat>
             <c:strRef>
-              <c:f>Sheet1!$A$2:$A$7</c:f>
+              <c:f>Sheet1!$A$2:$A$13</c:f>
               <c:strCache>
-                <c:ptCount val="6"/>
+                <c:ptCount val="12"/>
                 <c:pt idx="0">
-                  <c:v>07月</c:v>
+                  <c:v>1月</c:v>
                 </c:pt>
                 <c:pt idx="1">
-                  <c:v>08月</c:v>
+                  <c:v>2月</c:v>
                 </c:pt>
                 <c:pt idx="2">
-                  <c:v>09月</c:v>
+                  <c:v>3月</c:v>
                 </c:pt>
                 <c:pt idx="3">
+                  <c:v>4月</c:v>
+                </c:pt>
+                <c:pt idx="4">
+                  <c:v>5月</c:v>
+                </c:pt>
+                <c:pt idx="5">
+                  <c:v>6月</c:v>
+                </c:pt>
+                <c:pt idx="6">
+                  <c:v>7月</c:v>
+                </c:pt>
+                <c:pt idx="7">
+                  <c:v>8月</c:v>
+                </c:pt>
+                <c:pt idx="8">
+                  <c:v>9月</c:v>
+                </c:pt>
+                <c:pt idx="9">
                   <c:v>10月</c:v>
                 </c:pt>
-                <c:pt idx="4">
+                <c:pt idx="10">
                   <c:v>11月</c:v>
                 </c:pt>
-                <c:pt idx="5">
+                <c:pt idx="11">
                   <c:v>12月</c:v>
                 </c:pt>
               </c:strCache>
@@ -1635,27 +1873,45 @@
           </c:cat>
           <c:val>
             <c:numRef>
-              <c:f>Sheet1!$E$2:$E$7</c:f>
+              <c:f>Sheet1!$E$2:$E$13</c:f>
               <c:numCache>
                 <c:formatCode>General</c:formatCode>
-                <c:ptCount val="6"/>
+                <c:ptCount val="12"/>
                 <c:pt idx="0">
-                  <c:v>121150.605</c:v>
+                  <c:v>45.7</c:v>
                 </c:pt>
                 <c:pt idx="1">
-                  <c:v>47848.33</c:v>
+                  <c:v>44.6</c:v>
                 </c:pt>
                 <c:pt idx="2">
-                  <c:v>51251.681</c:v>
+                  <c:v>45.5</c:v>
                 </c:pt>
                 <c:pt idx="3">
-                  <c:v>63826.907</c:v>
+                  <c:v>43.9</c:v>
                 </c:pt>
                 <c:pt idx="4">
-                  <c:v>48431.125</c:v>
+                  <c:v>47.0</c:v>
                 </c:pt>
                 <c:pt idx="5">
-                  <c:v>54299.671</c:v>
+                  <c:v>49.5</c:v>
+                </c:pt>
+                <c:pt idx="6">
+                  <c:v>121.2</c:v>
+                </c:pt>
+                <c:pt idx="7">
+                  <c:v>47.8</c:v>
+                </c:pt>
+                <c:pt idx="8">
+                  <c:v>51.3</c:v>
+                </c:pt>
+                <c:pt idx="9">
+                  <c:v>63.8</c:v>
+                </c:pt>
+                <c:pt idx="10">
+                  <c:v>48.4</c:v>
+                </c:pt>
+                <c:pt idx="11">
+                  <c:v>54.3</c:v>
                 </c:pt>
               </c:numCache>
             </c:numRef>
@@ -1670,7 +1926,7 @@
               <c:strCache>
                 <c:ptCount val="1"/>
                 <c:pt idx="0">
-                  <c:v>台新國際商業銀行</c:v>
+                  <c:v>台新</c:v>
                 </c:pt>
               </c:strCache>
             </c:strRef>
@@ -1682,25 +1938,43 @@
           </c:spPr>
           <c:cat>
             <c:strRef>
-              <c:f>Sheet1!$A$2:$A$7</c:f>
+              <c:f>Sheet1!$A$2:$A$13</c:f>
               <c:strCache>
-                <c:ptCount val="6"/>
+                <c:ptCount val="12"/>
                 <c:pt idx="0">
-                  <c:v>07月</c:v>
+                  <c:v>1月</c:v>
                 </c:pt>
                 <c:pt idx="1">
-                  <c:v>08月</c:v>
+                  <c:v>2月</c:v>
                 </c:pt>
                 <c:pt idx="2">
-                  <c:v>09月</c:v>
+                  <c:v>3月</c:v>
                 </c:pt>
                 <c:pt idx="3">
+                  <c:v>4月</c:v>
+                </c:pt>
+                <c:pt idx="4">
+                  <c:v>5月</c:v>
+                </c:pt>
+                <c:pt idx="5">
+                  <c:v>6月</c:v>
+                </c:pt>
+                <c:pt idx="6">
+                  <c:v>7月</c:v>
+                </c:pt>
+                <c:pt idx="7">
+                  <c:v>8月</c:v>
+                </c:pt>
+                <c:pt idx="8">
+                  <c:v>9月</c:v>
+                </c:pt>
+                <c:pt idx="9">
                   <c:v>10月</c:v>
                 </c:pt>
-                <c:pt idx="4">
+                <c:pt idx="10">
                   <c:v>11月</c:v>
                 </c:pt>
-                <c:pt idx="5">
+                <c:pt idx="11">
                   <c:v>12月</c:v>
                 </c:pt>
               </c:strCache>
@@ -1708,27 +1982,45 @@
           </c:cat>
           <c:val>
             <c:numRef>
-              <c:f>Sheet1!$F$2:$F$7</c:f>
+              <c:f>Sheet1!$F$2:$F$13</c:f>
               <c:numCache>
                 <c:formatCode>General</c:formatCode>
-                <c:ptCount val="6"/>
+                <c:ptCount val="12"/>
                 <c:pt idx="0">
-                  <c:v>63003.868</c:v>
+                  <c:v>35.4</c:v>
                 </c:pt>
                 <c:pt idx="1">
-                  <c:v>39021.829</c:v>
+                  <c:v>42.8</c:v>
                 </c:pt>
                 <c:pt idx="2">
-                  <c:v>43935.514</c:v>
+                  <c:v>39.7</c:v>
                 </c:pt>
                 <c:pt idx="3">
-                  <c:v>48769.248</c:v>
+                  <c:v>40.3</c:v>
                 </c:pt>
                 <c:pt idx="4">
-                  <c:v>43360.054</c:v>
+                  <c:v>40.7</c:v>
                 </c:pt>
                 <c:pt idx="5">
-                  <c:v>48399.932</c:v>
+                  <c:v>43.8</c:v>
+                </c:pt>
+                <c:pt idx="6">
+                  <c:v>63.0</c:v>
+                </c:pt>
+                <c:pt idx="7">
+                  <c:v>39.0</c:v>
+                </c:pt>
+                <c:pt idx="8">
+                  <c:v>43.9</c:v>
+                </c:pt>
+                <c:pt idx="9">
+                  <c:v>48.8</c:v>
+                </c:pt>
+                <c:pt idx="10">
+                  <c:v>43.4</c:v>
+                </c:pt>
+                <c:pt idx="11">
+                  <c:v>48.4</c:v>
                 </c:pt>
               </c:numCache>
             </c:numRef>
@@ -1761,21 +2053,194 @@
         <c:delete val="0"/>
         <c:axPos val="l"/>
         <c:majorGridlines/>
-        <c:title>
+        <c:majorTickMark val="out"/>
+        <c:minorTickMark val="none"/>
+        <c:tickLblPos val="nextTo"/>
+        <c:crossAx val="-2068027336"/>
+        <c:crosses val="autoZero"/>
+      </c:valAx>
+    </c:plotArea>
+    <c:dispBlanksAs val="gap"/>
+  </c:chart>
+  <c:txPr>
+    <a:bodyPr/>
+    <a:lstStyle/>
+    <a:p>
+      <a:pPr>
+        <a:defRPr sz="1800"/>
+      </a:pPr>
+      <a:endParaRPr lang="en-US"/>
+    </a:p>
+  </c:txPr>
+  <c:externalData r:id="rId1">
+    <c:autoUpdate val="0"/>
+  </c:externalData>
+</c:chartSpace>
+</file>
+
+<file path=ppt/charts/chart7.xml><?xml version="1.0" encoding="utf-8"?>
+<c:chartSpace xmlns:c="http://schemas.openxmlformats.org/drawingml/2006/chart" xmlns:a="http://schemas.openxmlformats.org/drawingml/2006/main" xmlns:r="http://schemas.openxmlformats.org/officeDocument/2006/relationships">
+  <c:date1904 val="0"/>
+  <c:chart>
+    <c:title>
+      <c:tx>
+        <c:rich>
+          <a:bodyPr/>
+          <a:lstStyle/>
+          <a:p>
+            <a:r>
+              <a:t>流通卡數 Top 10</a:t>
+            </a:r>
+          </a:p>
+        </c:rich>
+      </c:tx>
+      <c:layout/>
+      <c:overlay val="0"/>
+    </c:title>
+    <c:autoTitleDeleted val="0"/>
+    <c:plotArea>
+      <c:barChart>
+        <c:barDir val="col"/>
+        <c:grouping val="clustered"/>
+        <c:ser>
+          <c:idx val="0"/>
+          <c:order val="0"/>
           <c:tx>
-            <c:rich>
-              <a:bodyPr/>
-              <a:lstStyle/>
-              <a:p>
-                <a:r>
-                  <a:t>簽帳金額 (百萬元)</a:t>
-                </a:r>
-              </a:p>
-            </c:rich>
+            <c:strRef>
+              <c:f>Sheet1!$B$1</c:f>
+              <c:strCache>
+                <c:ptCount val="1"/>
+                <c:pt idx="0">
+                  <c:v>萬張</c:v>
+                </c:pt>
+              </c:strCache>
+            </c:strRef>
           </c:tx>
-          <c:layout/>
-          <c:overlay val="0"/>
-        </c:title>
+          <c:spPr>
+            <a:solidFill>
+              <a:srgbClr val="003366"/>
+            </a:solidFill>
+          </c:spPr>
+          <c:dPt>
+            <c:idx val="0"/>
+            <c:spPr>
+              <a:solidFill>
+                <a:srgbClr val="FFCC00"/>
+              </a:solidFill>
+            </c:spPr>
+          </c:dPt>
+          <c:dPt>
+            <c:idx val="4"/>
+            <c:spPr>
+              <a:solidFill>
+                <a:srgbClr val="003366"/>
+              </a:solidFill>
+            </c:spPr>
+          </c:dPt>
+          <c:cat>
+            <c:strRef>
+              <c:f>Sheet1!$A$2:$A$11</c:f>
+              <c:strCache>
+                <c:ptCount val="10"/>
+                <c:pt idx="0">
+                  <c:v>中國信託</c:v>
+                </c:pt>
+                <c:pt idx="1">
+                  <c:v>玉山</c:v>
+                </c:pt>
+                <c:pt idx="2">
+                  <c:v>台北富邦</c:v>
+                </c:pt>
+                <c:pt idx="3">
+                  <c:v>國泰世華</c:v>
+                </c:pt>
+                <c:pt idx="4">
+                  <c:v>台新國際</c:v>
+                </c:pt>
+                <c:pt idx="5">
+                  <c:v>星展(台灣)</c:v>
+                </c:pt>
+                <c:pt idx="6">
+                  <c:v>聯邦</c:v>
+                </c:pt>
+                <c:pt idx="7">
+                  <c:v>永豐</c:v>
+                </c:pt>
+                <c:pt idx="8">
+                  <c:v>第一</c:v>
+                </c:pt>
+                <c:pt idx="9">
+                  <c:v>遠東國際</c:v>
+                </c:pt>
+              </c:strCache>
+            </c:strRef>
+          </c:cat>
+          <c:val>
+            <c:numRef>
+              <c:f>Sheet1!$B$2:$B$11</c:f>
+              <c:numCache>
+                <c:formatCode>General</c:formatCode>
+                <c:ptCount val="10"/>
+                <c:pt idx="0">
+                  <c:v>945.8</c:v>
+                </c:pt>
+                <c:pt idx="1">
+                  <c:v>874.8</c:v>
+                </c:pt>
+                <c:pt idx="2">
+                  <c:v>739.1</c:v>
+                </c:pt>
+                <c:pt idx="3">
+                  <c:v>733.7</c:v>
+                </c:pt>
+                <c:pt idx="4">
+                  <c:v>663.3</c:v>
+                </c:pt>
+                <c:pt idx="5">
+                  <c:v>332.5</c:v>
+                </c:pt>
+                <c:pt idx="6">
+                  <c:v>273.2</c:v>
+                </c:pt>
+                <c:pt idx="7">
+                  <c:v>247.9</c:v>
+                </c:pt>
+                <c:pt idx="8">
+                  <c:v>153.1</c:v>
+                </c:pt>
+                <c:pt idx="9">
+                  <c:v>129.0</c:v>
+                </c:pt>
+              </c:numCache>
+            </c:numRef>
+          </c:val>
+        </c:ser>
+        <c:axId val="-2068027336"/>
+        <c:axId val="-2113994440"/>
+      </c:barChart>
+      <c:catAx>
+        <c:axId val="-2068027336"/>
+        <c:scaling>
+          <c:orientation val="minMax"/>
+        </c:scaling>
+        <c:delete val="0"/>
+        <c:axPos val="b"/>
+        <c:majorTickMark val="out"/>
+        <c:minorTickMark val="none"/>
+        <c:tickLblPos val="nextTo"/>
+        <c:crossAx val="-2113994440"/>
+        <c:crosses val="autoZero"/>
+        <c:auto val="1"/>
+        <c:lblAlgn val="ctr"/>
+        <c:lblOffset val="100"/>
+        <c:noMultiLvlLbl val="0"/>
+      </c:catAx>
+      <c:valAx>
+        <c:axId val="-2113994440"/>
+        <c:scaling/>
+        <c:delete val="0"/>
+        <c:axPos val="l"/>
+        <c:majorGridlines/>
         <c:majorTickMark val="out"/>
         <c:minorTickMark val="none"/>
         <c:tickLblPos val="nextTo"/>
@@ -2202,22 +2667,22 @@
           </a:p>
           <a:p>
             <a:r>
-              <a:t>  • 市場流通卡數: 6049 萬張 (metric_id: market_total_cards)</a:t>
+              <a:t>  • 市場流通卡數: 6,049 萬 (metric_id: market_cards)</a:t>
             </a:r>
           </a:p>
           <a:p>
             <a:r>
-              <a:t>  • 台新流通卡數: 663 萬張 (metric_id: taishin_cards)</a:t>
+              <a:t>  • 市場簽帳金額(月): 454 億 (metric_id: market_amount)</a:t>
             </a:r>
           </a:p>
           <a:p>
             <a:r>
-              <a:t>  • 台新市佔率: 11.1% (metric_id: taishin_share)</a:t>
+              <a:t>  • 三信商業銀行市占率: 0.0% (metric_id: ts_share)</a:t>
             </a:r>
           </a:p>
           <a:p>
             <a:r>
-              <a:t>  • 台新當月簽帳金額: 48400 百萬元 (metric_id: taishin_spend)</a:t>
+              <a:t>  • 三信商業銀行簽帳市占: 0.0% (metric_id: ts_amount_share)</a:t>
             </a:r>
           </a:p>
         </p:txBody>
@@ -2288,7 +2753,7 @@
           <a:p/>
           <a:p>
             <a:r>
-              <a:t>【圖表】市場流通卡數趨勢（萬張）</a:t>
+              <a:t>【圖表】市場規模趨勢 — 流通卡數與簽帳金額</a:t>
             </a:r>
           </a:p>
         </p:txBody>
@@ -2359,7 +2824,7 @@
           <a:p/>
           <a:p>
             <a:r>
-              <a:t>【圖表】流通卡數市佔率排名 TOP10</a:t>
+              <a:t>【圖表】流通卡數市占率 Top 10</a:t>
             </a:r>
           </a:p>
         </p:txBody>
@@ -2430,7 +2895,7 @@
           <a:p/>
           <a:p>
             <a:r>
-              <a:t>【圖表】規模 vs 月增率</a:t>
+              <a:t>【圖表】規模 vs 成長</a:t>
             </a:r>
           </a:p>
         </p:txBody>
@@ -2501,7 +2966,7 @@
           <a:p/>
           <a:p>
             <a:r>
-              <a:t>【圖表】當月簽帳金額 TOP10</a:t>
+              <a:t>【圖表】卡數 vs 簽帳市占率</a:t>
             </a:r>
           </a:p>
         </p:txBody>
@@ -2572,7 +3037,7 @@
           <a:p/>
           <a:p>
             <a:r>
-              <a:t>【圖表】流通卡數 TOP10</a:t>
+              <a:t>【圖表】每卡簽帳金額(元/卡)</a:t>
             </a:r>
           </a:p>
         </p:txBody>
@@ -2643,7 +3108,7 @@
           <a:p/>
           <a:p>
             <a:r>
-              <a:t>【圖表】簽帳金額 TOP5 近 6 月趨勢（百萬元）</a:t>
+              <a:t>【圖表】Top 5 銀行月簽帳金額</a:t>
             </a:r>
           </a:p>
         </p:txBody>
@@ -2714,7 +3179,7 @@
           <a:p/>
           <a:p>
             <a:r>
-              <a:t>【表格】4 欄 × 10 行</a:t>
+              <a:t>【圖表】流通卡數 Top 10</a:t>
             </a:r>
           </a:p>
         </p:txBody>
@@ -6926,7 +7391,7 @@
               </a:defRPr>
             </a:pPr>
             <a:r>
-              <a:t>◆ 各銀行流通卡數比較</a:t>
+              <a:t>◆ 資料缺失：無法進行每卡簽帳金額分析</a:t>
             </a:r>
           </a:p>
         </p:txBody>
@@ -6949,6 +7414,76 @@
           </a:graphicData>
         </a:graphic>
       </p:graphicFrame>
+      <p:sp>
+        <p:nvSpPr>
+          <p:cNvPr id="7" name="TextBox 6"/>
+          <p:cNvSpPr txBox="1"/>
+          <p:nvPr/>
+        </p:nvSpPr>
+        <p:spPr>
+          <a:xfrm>
+            <a:off x="540000" y="5400000"/>
+            <a:ext cx="10800000" cy="432000"/>
+          </a:xfrm>
+          <a:prstGeom prst="rect">
+            <a:avLst/>
+          </a:prstGeom>
+          <a:noFill/>
+        </p:spPr>
+        <p:txBody>
+          <a:bodyPr wrap="square">
+            <a:spAutoFit/>
+          </a:bodyPr>
+          <a:lstStyle/>
+          <a:p>
+            <a:pPr>
+              <a:defRPr sz="1100">
+                <a:solidFill>
+                  <a:srgbClr val="333333"/>
+                </a:solidFill>
+              </a:defRPr>
+            </a:pPr>
+            <a:r>
+              <a:t>◆ 計算引擎未提供任何每卡簽帳金額數據，無法進行銀行間比較分析。這可能反映資料來源尚未整合此指標，或該指標需要額外的資料欄位支援（如總簽帳金額與流通卡數）。建議確認原始資料是否包含「總簽帳金額」與「流通卡數」兩項指標，若有則需重新執行計算引擎以產生每卡簽帳金額；若無則需從資料源頭補充此資訊。</a:t>
+            </a:r>
+          </a:p>
+        </p:txBody>
+      </p:sp>
+      <p:sp>
+        <p:nvSpPr>
+          <p:cNvPr id="8" name="TextBox 7"/>
+          <p:cNvSpPr txBox="1"/>
+          <p:nvPr/>
+        </p:nvSpPr>
+        <p:spPr>
+          <a:xfrm>
+            <a:off x="540000" y="5868000"/>
+            <a:ext cx="10800000" cy="432000"/>
+          </a:xfrm>
+          <a:prstGeom prst="rect">
+            <a:avLst/>
+          </a:prstGeom>
+          <a:noFill/>
+        </p:spPr>
+        <p:txBody>
+          <a:bodyPr wrap="square">
+            <a:spAutoFit/>
+          </a:bodyPr>
+          <a:lstStyle/>
+          <a:p>
+            <a:pPr>
+              <a:defRPr sz="1100">
+                <a:solidFill>
+                  <a:srgbClr val="333333"/>
+                </a:solidFill>
+              </a:defRPr>
+            </a:pPr>
+            <a:r>
+              <a:t>◆ 每卡簽帳金額是衡量信用卡業務品質的關鍵指標，反映單一持卡人的消費力與卡片活躍度。缺少此指標將無法評估各銀行在「深度經營」面向的表現差異——即使發卡量相同，每卡簽帳金額高的銀行代表客群價值更高、卡片使用率更佳。建議將此指標列為必要分析項目，並建立持續追蹤機制。</a:t>
+            </a:r>
+          </a:p>
+        </p:txBody>
+      </p:sp>
     </p:spTree>
   </p:cSld>
   <p:clrMapOvr>
@@ -6990,7 +7525,7 @@
               </a:defRPr>
             </a:pPr>
             <a:r>
-              <a:t>循環信用與分期</a:t>
+              <a:t>Top 5 銀行簽帳金額趨勢</a:t>
             </a:r>
           </a:p>
         </p:txBody>
@@ -7060,7 +7595,7 @@
               </a:defRPr>
             </a:pPr>
             <a:r>
-              <a:t>◆ 簽帳金額逐月變化</a:t>
+              <a:t>◆ 無法產生洞察：缺少計算引擎數據支持</a:t>
             </a:r>
           </a:p>
         </p:txBody>
@@ -7083,6 +7618,41 @@
           </a:graphicData>
         </a:graphic>
       </p:graphicFrame>
+      <p:sp>
+        <p:nvSpPr>
+          <p:cNvPr id="7" name="TextBox 6"/>
+          <p:cNvSpPr txBox="1"/>
+          <p:nvPr/>
+        </p:nvSpPr>
+        <p:spPr>
+          <a:xfrm>
+            <a:off x="540000" y="5400000"/>
+            <a:ext cx="10800000" cy="432000"/>
+          </a:xfrm>
+          <a:prstGeom prst="rect">
+            <a:avLst/>
+          </a:prstGeom>
+          <a:noFill/>
+        </p:spPr>
+        <p:txBody>
+          <a:bodyPr wrap="square">
+            <a:spAutoFit/>
+          </a:bodyPr>
+          <a:lstStyle/>
+          <a:p>
+            <a:pPr>
+              <a:defRPr sz="1100">
+                <a:solidFill>
+                  <a:srgbClr val="333333"/>
+                </a:solidFill>
+              </a:defRPr>
+            </a:pPr>
+            <a:r>
+              <a:t>◆ 本頁面規劃為「Top 5 銀行簽帳金額趨勢」分析，但計算引擎未提供任何 metric_id 或數值結果。根據系統設計原則，AI 不得自行計算、推測或虛構數據。建議檢查：(1) 原始資料是否包含各銀行的月度簽帳金額；(2) 計算引擎是否成功執行 Top 5 篩選與時間序列彙總；(3) metric_id 映射是否正確傳遞至本階段。在數據補齊前，此頁面無法產出有效的策略洞察。</a:t>
+            </a:r>
+          </a:p>
+        </p:txBody>
+      </p:sp>
     </p:spTree>
   </p:cSld>
   <p:clrMapOvr>
@@ -7205,7 +7775,7 @@
               </a:defRPr>
             </a:pPr>
             <a:r>
-              <a:t>風險指標比較</a:t>
+              <a:t>流通卡數月增率</a:t>
             </a:r>
           </a:p>
         </p:txBody>
@@ -7275,14 +7845,14 @@
               </a:defRPr>
             </a:pPr>
             <a:r>
-              <a:t>◆ 風險指標總覽</a:t>
+              <a:t>◆ 無法產生洞察：計算引擎未提供任何數據</a:t>
             </a:r>
           </a:p>
         </p:txBody>
       </p:sp>
       <p:graphicFrame>
         <p:nvGraphicFramePr>
-          <p:cNvPr id="6" name="Table 5"/>
+          <p:cNvPr id="6" name="Chart 5"/>
           <p:cNvGraphicFramePr>
             <a:graphicFrameLocks noGrp="1"/>
           </p:cNvGraphicFramePr>
@@ -7290,1938 +7860,49 @@
         </p:nvGraphicFramePr>
         <p:xfrm>
           <a:off x="540000" y="1620000"/>
-          <a:ext cx="10800000" cy="3960000"/>
+          <a:ext cx="10800000" cy="3600000"/>
         </p:xfrm>
         <a:graphic>
-          <a:graphicData uri="http://schemas.openxmlformats.org/drawingml/2006/table">
-            <a:tbl>
-              <a:tblPr firstRow="1" bandRow="1">
-                <a:tableStyleId>{5C22544A-7EE6-4342-B048-85BDC9FD1C3A}</a:tableStyleId>
-              </a:tblPr>
-              <a:tblGrid>
-                <a:gridCol w="2700000"/>
-                <a:gridCol w="2700000"/>
-                <a:gridCol w="2700000"/>
-                <a:gridCol w="2700000"/>
-              </a:tblGrid>
-              <a:tr h="360000">
-                <a:tc>
-                  <a:txBody>
-                    <a:bodyPr/>
-                    <a:lstStyle/>
-                    <a:p>
-                      <a:pPr algn="ctr">
-                        <a:defRPr b="1" sz="1100">
-                          <a:solidFill>
-                            <a:srgbClr val="FFFFFF"/>
-                          </a:solidFill>
-                        </a:defRPr>
-                      </a:pPr>
-                      <a:r>
-                        <a:t>銀行</a:t>
-                      </a:r>
-                    </a:p>
-                  </a:txBody>
-                  <a:tcPr anchor="ctr">
-                    <a:solidFill>
-                      <a:srgbClr val="003366"/>
-                    </a:solidFill>
-                    <a:lnL w="6350">
-                      <a:solidFill>
-                        <a:srgbClr val="FFFFFF"/>
-                      </a:solidFill>
-                    </a:lnL>
-                    <a:lnR w="6350">
-                      <a:solidFill>
-                        <a:srgbClr val="FFFFFF"/>
-                      </a:solidFill>
-                    </a:lnR>
-                    <a:lnT w="6350">
-                      <a:solidFill>
-                        <a:srgbClr val="FFFFFF"/>
-                      </a:solidFill>
-                    </a:lnT>
-                    <a:lnB w="6350">
-                      <a:solidFill>
-                        <a:srgbClr val="FFFFFF"/>
-                      </a:solidFill>
-                    </a:lnB>
-                  </a:tcPr>
-                </a:tc>
-                <a:tc>
-                  <a:txBody>
-                    <a:bodyPr/>
-                    <a:lstStyle/>
-                    <a:p>
-                      <a:pPr algn="ctr">
-                        <a:defRPr b="1" sz="1100">
-                          <a:solidFill>
-                            <a:srgbClr val="FFFFFF"/>
-                          </a:solidFill>
-                        </a:defRPr>
-                      </a:pPr>
-                      <a:r>
-                        <a:t>流通卡數(萬張)</a:t>
-                      </a:r>
-                    </a:p>
-                  </a:txBody>
-                  <a:tcPr anchor="ctr">
-                    <a:solidFill>
-                      <a:srgbClr val="003366"/>
-                    </a:solidFill>
-                    <a:lnL w="6350">
-                      <a:solidFill>
-                        <a:srgbClr val="FFFFFF"/>
-                      </a:solidFill>
-                    </a:lnL>
-                    <a:lnR w="6350">
-                      <a:solidFill>
-                        <a:srgbClr val="FFFFFF"/>
-                      </a:solidFill>
-                    </a:lnR>
-                    <a:lnT w="6350">
-                      <a:solidFill>
-                        <a:srgbClr val="FFFFFF"/>
-                      </a:solidFill>
-                    </a:lnT>
-                    <a:lnB w="6350">
-                      <a:solidFill>
-                        <a:srgbClr val="FFFFFF"/>
-                      </a:solidFill>
-                    </a:lnB>
-                  </a:tcPr>
-                </a:tc>
-                <a:tc>
-                  <a:txBody>
-                    <a:bodyPr/>
-                    <a:lstStyle/>
-                    <a:p>
-                      <a:pPr algn="ctr">
-                        <a:defRPr b="1" sz="1100">
-                          <a:solidFill>
-                            <a:srgbClr val="FFFFFF"/>
-                          </a:solidFill>
-                        </a:defRPr>
-                      </a:pPr>
-                      <a:r>
-                        <a:t>簽帳金額(百萬元)</a:t>
-                      </a:r>
-                    </a:p>
-                  </a:txBody>
-                  <a:tcPr anchor="ctr">
-                    <a:solidFill>
-                      <a:srgbClr val="003366"/>
-                    </a:solidFill>
-                    <a:lnL w="6350">
-                      <a:solidFill>
-                        <a:srgbClr val="FFFFFF"/>
-                      </a:solidFill>
-                    </a:lnL>
-                    <a:lnR w="6350">
-                      <a:solidFill>
-                        <a:srgbClr val="FFFFFF"/>
-                      </a:solidFill>
-                    </a:lnR>
-                    <a:lnT w="6350">
-                      <a:solidFill>
-                        <a:srgbClr val="FFFFFF"/>
-                      </a:solidFill>
-                    </a:lnT>
-                    <a:lnB w="6350">
-                      <a:solidFill>
-                        <a:srgbClr val="FFFFFF"/>
-                      </a:solidFill>
-                    </a:lnB>
-                  </a:tcPr>
-                </a:tc>
-                <a:tc>
-                  <a:txBody>
-                    <a:bodyPr/>
-                    <a:lstStyle/>
-                    <a:p>
-                      <a:pPr algn="ctr">
-                        <a:defRPr b="1" sz="1100">
-                          <a:solidFill>
-                            <a:srgbClr val="FFFFFF"/>
-                          </a:solidFill>
-                        </a:defRPr>
-                      </a:pPr>
-                      <a:r>
-                        <a:t>市佔率(%)</a:t>
-                      </a:r>
-                    </a:p>
-                  </a:txBody>
-                  <a:tcPr anchor="ctr">
-                    <a:solidFill>
-                      <a:srgbClr val="003366"/>
-                    </a:solidFill>
-                    <a:lnL w="6350">
-                      <a:solidFill>
-                        <a:srgbClr val="FFFFFF"/>
-                      </a:solidFill>
-                    </a:lnL>
-                    <a:lnR w="6350">
-                      <a:solidFill>
-                        <a:srgbClr val="FFFFFF"/>
-                      </a:solidFill>
-                    </a:lnR>
-                    <a:lnT w="6350">
-                      <a:solidFill>
-                        <a:srgbClr val="FFFFFF"/>
-                      </a:solidFill>
-                    </a:lnT>
-                    <a:lnB w="6350">
-                      <a:solidFill>
-                        <a:srgbClr val="FFFFFF"/>
-                      </a:solidFill>
-                    </a:lnB>
-                  </a:tcPr>
-                </a:tc>
-              </a:tr>
-              <a:tr h="360000">
-                <a:tc>
-                  <a:txBody>
-                    <a:bodyPr/>
-                    <a:lstStyle/>
-                    <a:p>
-                      <a:pPr>
-                        <a:defRPr sz="1000">
-                          <a:solidFill>
-                            <a:srgbClr val="333333"/>
-                          </a:solidFill>
-                        </a:defRPr>
-                      </a:pPr>
-                      <a:r>
-                        <a:t>中國信託商業銀行</a:t>
-                      </a:r>
-                    </a:p>
-                  </a:txBody>
-                  <a:tcPr anchor="ctr">
-                    <a:solidFill>
-                      <a:srgbClr val="E8F0F8"/>
-                    </a:solidFill>
-                    <a:lnL w="6350">
-                      <a:solidFill>
-                        <a:srgbClr val="CCCCCC"/>
-                      </a:solidFill>
-                    </a:lnL>
-                    <a:lnR w="6350">
-                      <a:solidFill>
-                        <a:srgbClr val="CCCCCC"/>
-                      </a:solidFill>
-                    </a:lnR>
-                    <a:lnT w="6350">
-                      <a:solidFill>
-                        <a:srgbClr val="CCCCCC"/>
-                      </a:solidFill>
-                    </a:lnT>
-                    <a:lnB w="6350">
-                      <a:solidFill>
-                        <a:srgbClr val="CCCCCC"/>
-                      </a:solidFill>
-                    </a:lnB>
-                  </a:tcPr>
-                </a:tc>
-                <a:tc>
-                  <a:txBody>
-                    <a:bodyPr/>
-                    <a:lstStyle/>
-                    <a:p>
-                      <a:pPr>
-                        <a:defRPr sz="1000">
-                          <a:solidFill>
-                            <a:srgbClr val="333333"/>
-                          </a:solidFill>
-                        </a:defRPr>
-                      </a:pPr>
-                      <a:r>
-                        <a:t>945.8</a:t>
-                      </a:r>
-                    </a:p>
-                  </a:txBody>
-                  <a:tcPr anchor="ctr">
-                    <a:solidFill>
-                      <a:srgbClr val="E8F0F8"/>
-                    </a:solidFill>
-                    <a:lnL w="6350">
-                      <a:solidFill>
-                        <a:srgbClr val="CCCCCC"/>
-                      </a:solidFill>
-                    </a:lnL>
-                    <a:lnR w="6350">
-                      <a:solidFill>
-                        <a:srgbClr val="CCCCCC"/>
-                      </a:solidFill>
-                    </a:lnR>
-                    <a:lnT w="6350">
-                      <a:solidFill>
-                        <a:srgbClr val="CCCCCC"/>
-                      </a:solidFill>
-                    </a:lnT>
-                    <a:lnB w="6350">
-                      <a:solidFill>
-                        <a:srgbClr val="CCCCCC"/>
-                      </a:solidFill>
-                    </a:lnB>
-                  </a:tcPr>
-                </a:tc>
-                <a:tc>
-                  <a:txBody>
-                    <a:bodyPr/>
-                    <a:lstStyle/>
-                    <a:p>
-                      <a:pPr>
-                        <a:defRPr sz="1000">
-                          <a:solidFill>
-                            <a:srgbClr val="333333"/>
-                          </a:solidFill>
-                        </a:defRPr>
-                      </a:pPr>
-                      <a:r>
-                        <a:t>83918</a:t>
-                      </a:r>
-                    </a:p>
-                  </a:txBody>
-                  <a:tcPr anchor="ctr">
-                    <a:solidFill>
-                      <a:srgbClr val="E8F0F8"/>
-                    </a:solidFill>
-                    <a:lnL w="6350">
-                      <a:solidFill>
-                        <a:srgbClr val="CCCCCC"/>
-                      </a:solidFill>
-                    </a:lnL>
-                    <a:lnR w="6350">
-                      <a:solidFill>
-                        <a:srgbClr val="CCCCCC"/>
-                      </a:solidFill>
-                    </a:lnR>
-                    <a:lnT w="6350">
-                      <a:solidFill>
-                        <a:srgbClr val="CCCCCC"/>
-                      </a:solidFill>
-                    </a:lnT>
-                    <a:lnB w="6350">
-                      <a:solidFill>
-                        <a:srgbClr val="CCCCCC"/>
-                      </a:solidFill>
-                    </a:lnB>
-                  </a:tcPr>
-                </a:tc>
-                <a:tc>
-                  <a:txBody>
-                    <a:bodyPr/>
-                    <a:lstStyle/>
-                    <a:p>
-                      <a:pPr>
-                        <a:defRPr sz="1000">
-                          <a:solidFill>
-                            <a:srgbClr val="333333"/>
-                          </a:solidFill>
-                        </a:defRPr>
-                      </a:pPr>
-                      <a:r>
-                        <a:t>15.37</a:t>
-                      </a:r>
-                    </a:p>
-                  </a:txBody>
-                  <a:tcPr anchor="ctr">
-                    <a:solidFill>
-                      <a:srgbClr val="E8F0F8"/>
-                    </a:solidFill>
-                    <a:lnL w="6350">
-                      <a:solidFill>
-                        <a:srgbClr val="CCCCCC"/>
-                      </a:solidFill>
-                    </a:lnL>
-                    <a:lnR w="6350">
-                      <a:solidFill>
-                        <a:srgbClr val="CCCCCC"/>
-                      </a:solidFill>
-                    </a:lnR>
-                    <a:lnT w="6350">
-                      <a:solidFill>
-                        <a:srgbClr val="CCCCCC"/>
-                      </a:solidFill>
-                    </a:lnT>
-                    <a:lnB w="6350">
-                      <a:solidFill>
-                        <a:srgbClr val="CCCCCC"/>
-                      </a:solidFill>
-                    </a:lnB>
-                  </a:tcPr>
-                </a:tc>
-              </a:tr>
-              <a:tr h="360000">
-                <a:tc>
-                  <a:txBody>
-                    <a:bodyPr/>
-                    <a:lstStyle/>
-                    <a:p>
-                      <a:pPr>
-                        <a:defRPr sz="1000">
-                          <a:solidFill>
-                            <a:srgbClr val="333333"/>
-                          </a:solidFill>
-                        </a:defRPr>
-                      </a:pPr>
-                      <a:r>
-                        <a:t>玉山商業銀行</a:t>
-                      </a:r>
-                    </a:p>
-                  </a:txBody>
-                  <a:tcPr anchor="ctr">
-                    <a:solidFill>
-                      <a:srgbClr val="FFFFFF"/>
-                    </a:solidFill>
-                    <a:lnL w="6350">
-                      <a:solidFill>
-                        <a:srgbClr val="CCCCCC"/>
-                      </a:solidFill>
-                    </a:lnL>
-                    <a:lnR w="6350">
-                      <a:solidFill>
-                        <a:srgbClr val="CCCCCC"/>
-                      </a:solidFill>
-                    </a:lnR>
-                    <a:lnT w="6350">
-                      <a:solidFill>
-                        <a:srgbClr val="CCCCCC"/>
-                      </a:solidFill>
-                    </a:lnT>
-                    <a:lnB w="6350">
-                      <a:solidFill>
-                        <a:srgbClr val="CCCCCC"/>
-                      </a:solidFill>
-                    </a:lnB>
-                  </a:tcPr>
-                </a:tc>
-                <a:tc>
-                  <a:txBody>
-                    <a:bodyPr/>
-                    <a:lstStyle/>
-                    <a:p>
-                      <a:pPr>
-                        <a:defRPr sz="1000">
-                          <a:solidFill>
-                            <a:srgbClr val="333333"/>
-                          </a:solidFill>
-                        </a:defRPr>
-                      </a:pPr>
-                      <a:r>
-                        <a:t>874.8</a:t>
-                      </a:r>
-                    </a:p>
-                  </a:txBody>
-                  <a:tcPr anchor="ctr">
-                    <a:solidFill>
-                      <a:srgbClr val="FFFFFF"/>
-                    </a:solidFill>
-                    <a:lnL w="6350">
-                      <a:solidFill>
-                        <a:srgbClr val="CCCCCC"/>
-                      </a:solidFill>
-                    </a:lnL>
-                    <a:lnR w="6350">
-                      <a:solidFill>
-                        <a:srgbClr val="CCCCCC"/>
-                      </a:solidFill>
-                    </a:lnR>
-                    <a:lnT w="6350">
-                      <a:solidFill>
-                        <a:srgbClr val="CCCCCC"/>
-                      </a:solidFill>
-                    </a:lnT>
-                    <a:lnB w="6350">
-                      <a:solidFill>
-                        <a:srgbClr val="CCCCCC"/>
-                      </a:solidFill>
-                    </a:lnB>
-                  </a:tcPr>
-                </a:tc>
-                <a:tc>
-                  <a:txBody>
-                    <a:bodyPr/>
-                    <a:lstStyle/>
-                    <a:p>
-                      <a:pPr>
-                        <a:defRPr sz="1000">
-                          <a:solidFill>
-                            <a:srgbClr val="333333"/>
-                          </a:solidFill>
-                        </a:defRPr>
-                      </a:pPr>
-                      <a:r>
-                        <a:t>54300</a:t>
-                      </a:r>
-                    </a:p>
-                  </a:txBody>
-                  <a:tcPr anchor="ctr">
-                    <a:solidFill>
-                      <a:srgbClr val="FFFFFF"/>
-                    </a:solidFill>
-                    <a:lnL w="6350">
-                      <a:solidFill>
-                        <a:srgbClr val="CCCCCC"/>
-                      </a:solidFill>
-                    </a:lnL>
-                    <a:lnR w="6350">
-                      <a:solidFill>
-                        <a:srgbClr val="CCCCCC"/>
-                      </a:solidFill>
-                    </a:lnR>
-                    <a:lnT w="6350">
-                      <a:solidFill>
-                        <a:srgbClr val="CCCCCC"/>
-                      </a:solidFill>
-                    </a:lnT>
-                    <a:lnB w="6350">
-                      <a:solidFill>
-                        <a:srgbClr val="CCCCCC"/>
-                      </a:solidFill>
-                    </a:lnB>
-                  </a:tcPr>
-                </a:tc>
-                <a:tc>
-                  <a:txBody>
-                    <a:bodyPr/>
-                    <a:lstStyle/>
-                    <a:p>
-                      <a:pPr>
-                        <a:defRPr sz="1000">
-                          <a:solidFill>
-                            <a:srgbClr val="333333"/>
-                          </a:solidFill>
-                        </a:defRPr>
-                      </a:pPr>
-                      <a:r>
-                        <a:t>14.04</a:t>
-                      </a:r>
-                    </a:p>
-                  </a:txBody>
-                  <a:tcPr anchor="ctr">
-                    <a:solidFill>
-                      <a:srgbClr val="FFFFFF"/>
-                    </a:solidFill>
-                    <a:lnL w="6350">
-                      <a:solidFill>
-                        <a:srgbClr val="CCCCCC"/>
-                      </a:solidFill>
-                    </a:lnL>
-                    <a:lnR w="6350">
-                      <a:solidFill>
-                        <a:srgbClr val="CCCCCC"/>
-                      </a:solidFill>
-                    </a:lnR>
-                    <a:lnT w="6350">
-                      <a:solidFill>
-                        <a:srgbClr val="CCCCCC"/>
-                      </a:solidFill>
-                    </a:lnT>
-                    <a:lnB w="6350">
-                      <a:solidFill>
-                        <a:srgbClr val="CCCCCC"/>
-                      </a:solidFill>
-                    </a:lnB>
-                  </a:tcPr>
-                </a:tc>
-              </a:tr>
-              <a:tr h="360000">
-                <a:tc>
-                  <a:txBody>
-                    <a:bodyPr/>
-                    <a:lstStyle/>
-                    <a:p>
-                      <a:pPr>
-                        <a:defRPr sz="1000">
-                          <a:solidFill>
-                            <a:srgbClr val="333333"/>
-                          </a:solidFill>
-                        </a:defRPr>
-                      </a:pPr>
-                      <a:r>
-                        <a:t>台北富邦商業銀行</a:t>
-                      </a:r>
-                    </a:p>
-                  </a:txBody>
-                  <a:tcPr anchor="ctr">
-                    <a:solidFill>
-                      <a:srgbClr val="E8F0F8"/>
-                    </a:solidFill>
-                    <a:lnL w="6350">
-                      <a:solidFill>
-                        <a:srgbClr val="CCCCCC"/>
-                      </a:solidFill>
-                    </a:lnL>
-                    <a:lnR w="6350">
-                      <a:solidFill>
-                        <a:srgbClr val="CCCCCC"/>
-                      </a:solidFill>
-                    </a:lnR>
-                    <a:lnT w="6350">
-                      <a:solidFill>
-                        <a:srgbClr val="CCCCCC"/>
-                      </a:solidFill>
-                    </a:lnT>
-                    <a:lnB w="6350">
-                      <a:solidFill>
-                        <a:srgbClr val="CCCCCC"/>
-                      </a:solidFill>
-                    </a:lnB>
-                  </a:tcPr>
-                </a:tc>
-                <a:tc>
-                  <a:txBody>
-                    <a:bodyPr/>
-                    <a:lstStyle/>
-                    <a:p>
-                      <a:pPr>
-                        <a:defRPr sz="1000">
-                          <a:solidFill>
-                            <a:srgbClr val="333333"/>
-                          </a:solidFill>
-                        </a:defRPr>
-                      </a:pPr>
-                      <a:r>
-                        <a:t>739.1</a:t>
-                      </a:r>
-                    </a:p>
-                  </a:txBody>
-                  <a:tcPr anchor="ctr">
-                    <a:solidFill>
-                      <a:srgbClr val="E8F0F8"/>
-                    </a:solidFill>
-                    <a:lnL w="6350">
-                      <a:solidFill>
-                        <a:srgbClr val="CCCCCC"/>
-                      </a:solidFill>
-                    </a:lnL>
-                    <a:lnR w="6350">
-                      <a:solidFill>
-                        <a:srgbClr val="CCCCCC"/>
-                      </a:solidFill>
-                    </a:lnR>
-                    <a:lnT w="6350">
-                      <a:solidFill>
-                        <a:srgbClr val="CCCCCC"/>
-                      </a:solidFill>
-                    </a:lnT>
-                    <a:lnB w="6350">
-                      <a:solidFill>
-                        <a:srgbClr val="CCCCCC"/>
-                      </a:solidFill>
-                    </a:lnB>
-                  </a:tcPr>
-                </a:tc>
-                <a:tc>
-                  <a:txBody>
-                    <a:bodyPr/>
-                    <a:lstStyle/>
-                    <a:p>
-                      <a:pPr>
-                        <a:defRPr sz="1000">
-                          <a:solidFill>
-                            <a:srgbClr val="333333"/>
-                          </a:solidFill>
-                        </a:defRPr>
-                      </a:pPr>
-                      <a:r>
-                        <a:t>58874</a:t>
-                      </a:r>
-                    </a:p>
-                  </a:txBody>
-                  <a:tcPr anchor="ctr">
-                    <a:solidFill>
-                      <a:srgbClr val="E8F0F8"/>
-                    </a:solidFill>
-                    <a:lnL w="6350">
-                      <a:solidFill>
-                        <a:srgbClr val="CCCCCC"/>
-                      </a:solidFill>
-                    </a:lnL>
-                    <a:lnR w="6350">
-                      <a:solidFill>
-                        <a:srgbClr val="CCCCCC"/>
-                      </a:solidFill>
-                    </a:lnR>
-                    <a:lnT w="6350">
-                      <a:solidFill>
-                        <a:srgbClr val="CCCCCC"/>
-                      </a:solidFill>
-                    </a:lnT>
-                    <a:lnB w="6350">
-                      <a:solidFill>
-                        <a:srgbClr val="CCCCCC"/>
-                      </a:solidFill>
-                    </a:lnB>
-                  </a:tcPr>
-                </a:tc>
-                <a:tc>
-                  <a:txBody>
-                    <a:bodyPr/>
-                    <a:lstStyle/>
-                    <a:p>
-                      <a:pPr>
-                        <a:defRPr sz="1000">
-                          <a:solidFill>
-                            <a:srgbClr val="333333"/>
-                          </a:solidFill>
-                        </a:defRPr>
-                      </a:pPr>
-                      <a:r>
-                        <a:t>12.41</a:t>
-                      </a:r>
-                    </a:p>
-                  </a:txBody>
-                  <a:tcPr anchor="ctr">
-                    <a:solidFill>
-                      <a:srgbClr val="E8F0F8"/>
-                    </a:solidFill>
-                    <a:lnL w="6350">
-                      <a:solidFill>
-                        <a:srgbClr val="CCCCCC"/>
-                      </a:solidFill>
-                    </a:lnL>
-                    <a:lnR w="6350">
-                      <a:solidFill>
-                        <a:srgbClr val="CCCCCC"/>
-                      </a:solidFill>
-                    </a:lnR>
-                    <a:lnT w="6350">
-                      <a:solidFill>
-                        <a:srgbClr val="CCCCCC"/>
-                      </a:solidFill>
-                    </a:lnT>
-                    <a:lnB w="6350">
-                      <a:solidFill>
-                        <a:srgbClr val="CCCCCC"/>
-                      </a:solidFill>
-                    </a:lnB>
-                  </a:tcPr>
-                </a:tc>
-              </a:tr>
-              <a:tr h="360000">
-                <a:tc>
-                  <a:txBody>
-                    <a:bodyPr/>
-                    <a:lstStyle/>
-                    <a:p>
-                      <a:pPr>
-                        <a:defRPr sz="1000">
-                          <a:solidFill>
-                            <a:srgbClr val="333333"/>
-                          </a:solidFill>
-                        </a:defRPr>
-                      </a:pPr>
-                      <a:r>
-                        <a:t>國泰世華商業銀行</a:t>
-                      </a:r>
-                    </a:p>
-                  </a:txBody>
-                  <a:tcPr anchor="ctr">
-                    <a:solidFill>
-                      <a:srgbClr val="FFFFFF"/>
-                    </a:solidFill>
-                    <a:lnL w="6350">
-                      <a:solidFill>
-                        <a:srgbClr val="CCCCCC"/>
-                      </a:solidFill>
-                    </a:lnL>
-                    <a:lnR w="6350">
-                      <a:solidFill>
-                        <a:srgbClr val="CCCCCC"/>
-                      </a:solidFill>
-                    </a:lnR>
-                    <a:lnT w="6350">
-                      <a:solidFill>
-                        <a:srgbClr val="CCCCCC"/>
-                      </a:solidFill>
-                    </a:lnT>
-                    <a:lnB w="6350">
-                      <a:solidFill>
-                        <a:srgbClr val="CCCCCC"/>
-                      </a:solidFill>
-                    </a:lnB>
-                  </a:tcPr>
-                </a:tc>
-                <a:tc>
-                  <a:txBody>
-                    <a:bodyPr/>
-                    <a:lstStyle/>
-                    <a:p>
-                      <a:pPr>
-                        <a:defRPr sz="1000">
-                          <a:solidFill>
-                            <a:srgbClr val="333333"/>
-                          </a:solidFill>
-                        </a:defRPr>
-                      </a:pPr>
-                      <a:r>
-                        <a:t>733.7</a:t>
-                      </a:r>
-                    </a:p>
-                  </a:txBody>
-                  <a:tcPr anchor="ctr">
-                    <a:solidFill>
-                      <a:srgbClr val="FFFFFF"/>
-                    </a:solidFill>
-                    <a:lnL w="6350">
-                      <a:solidFill>
-                        <a:srgbClr val="CCCCCC"/>
-                      </a:solidFill>
-                    </a:lnL>
-                    <a:lnR w="6350">
-                      <a:solidFill>
-                        <a:srgbClr val="CCCCCC"/>
-                      </a:solidFill>
-                    </a:lnR>
-                    <a:lnT w="6350">
-                      <a:solidFill>
-                        <a:srgbClr val="CCCCCC"/>
-                      </a:solidFill>
-                    </a:lnT>
-                    <a:lnB w="6350">
-                      <a:solidFill>
-                        <a:srgbClr val="CCCCCC"/>
-                      </a:solidFill>
-                    </a:lnB>
-                  </a:tcPr>
-                </a:tc>
-                <a:tc>
-                  <a:txBody>
-                    <a:bodyPr/>
-                    <a:lstStyle/>
-                    <a:p>
-                      <a:pPr>
-                        <a:defRPr sz="1000">
-                          <a:solidFill>
-                            <a:srgbClr val="333333"/>
-                          </a:solidFill>
-                        </a:defRPr>
-                      </a:pPr>
-                      <a:r>
-                        <a:t>81878</a:t>
-                      </a:r>
-                    </a:p>
-                  </a:txBody>
-                  <a:tcPr anchor="ctr">
-                    <a:solidFill>
-                      <a:srgbClr val="FFFFFF"/>
-                    </a:solidFill>
-                    <a:lnL w="6350">
-                      <a:solidFill>
-                        <a:srgbClr val="CCCCCC"/>
-                      </a:solidFill>
-                    </a:lnL>
-                    <a:lnR w="6350">
-                      <a:solidFill>
-                        <a:srgbClr val="CCCCCC"/>
-                      </a:solidFill>
-                    </a:lnR>
-                    <a:lnT w="6350">
-                      <a:solidFill>
-                        <a:srgbClr val="CCCCCC"/>
-                      </a:solidFill>
-                    </a:lnT>
-                    <a:lnB w="6350">
-                      <a:solidFill>
-                        <a:srgbClr val="CCCCCC"/>
-                      </a:solidFill>
-                    </a:lnB>
-                  </a:tcPr>
-                </a:tc>
-                <a:tc>
-                  <a:txBody>
-                    <a:bodyPr/>
-                    <a:lstStyle/>
-                    <a:p>
-                      <a:pPr>
-                        <a:defRPr sz="1000">
-                          <a:solidFill>
-                            <a:srgbClr val="333333"/>
-                          </a:solidFill>
-                        </a:defRPr>
-                      </a:pPr>
-                      <a:r>
-                        <a:t>12.30</a:t>
-                      </a:r>
-                    </a:p>
-                  </a:txBody>
-                  <a:tcPr anchor="ctr">
-                    <a:solidFill>
-                      <a:srgbClr val="FFFFFF"/>
-                    </a:solidFill>
-                    <a:lnL w="6350">
-                      <a:solidFill>
-                        <a:srgbClr val="CCCCCC"/>
-                      </a:solidFill>
-                    </a:lnL>
-                    <a:lnR w="6350">
-                      <a:solidFill>
-                        <a:srgbClr val="CCCCCC"/>
-                      </a:solidFill>
-                    </a:lnR>
-                    <a:lnT w="6350">
-                      <a:solidFill>
-                        <a:srgbClr val="CCCCCC"/>
-                      </a:solidFill>
-                    </a:lnT>
-                    <a:lnB w="6350">
-                      <a:solidFill>
-                        <a:srgbClr val="CCCCCC"/>
-                      </a:solidFill>
-                    </a:lnB>
-                  </a:tcPr>
-                </a:tc>
-              </a:tr>
-              <a:tr h="360000">
-                <a:tc>
-                  <a:txBody>
-                    <a:bodyPr/>
-                    <a:lstStyle/>
-                    <a:p>
-                      <a:pPr>
-                        <a:defRPr sz="1000">
-                          <a:solidFill>
-                            <a:srgbClr val="333333"/>
-                          </a:solidFill>
-                        </a:defRPr>
-                      </a:pPr>
-                      <a:r>
-                        <a:t>台新國際商業銀行</a:t>
-                      </a:r>
-                    </a:p>
-                  </a:txBody>
-                  <a:tcPr anchor="ctr">
-                    <a:solidFill>
-                      <a:srgbClr val="E8F0F8"/>
-                    </a:solidFill>
-                    <a:lnL w="6350">
-                      <a:solidFill>
-                        <a:srgbClr val="CCCCCC"/>
-                      </a:solidFill>
-                    </a:lnL>
-                    <a:lnR w="6350">
-                      <a:solidFill>
-                        <a:srgbClr val="CCCCCC"/>
-                      </a:solidFill>
-                    </a:lnR>
-                    <a:lnT w="6350">
-                      <a:solidFill>
-                        <a:srgbClr val="CCCCCC"/>
-                      </a:solidFill>
-                    </a:lnT>
-                    <a:lnB w="6350">
-                      <a:solidFill>
-                        <a:srgbClr val="CCCCCC"/>
-                      </a:solidFill>
-                    </a:lnB>
-                  </a:tcPr>
-                </a:tc>
-                <a:tc>
-                  <a:txBody>
-                    <a:bodyPr/>
-                    <a:lstStyle/>
-                    <a:p>
-                      <a:pPr>
-                        <a:defRPr sz="1000">
-                          <a:solidFill>
-                            <a:srgbClr val="333333"/>
-                          </a:solidFill>
-                        </a:defRPr>
-                      </a:pPr>
-                      <a:r>
-                        <a:t>663.3</a:t>
-                      </a:r>
-                    </a:p>
-                  </a:txBody>
-                  <a:tcPr anchor="ctr">
-                    <a:solidFill>
-                      <a:srgbClr val="E8F0F8"/>
-                    </a:solidFill>
-                    <a:lnL w="6350">
-                      <a:solidFill>
-                        <a:srgbClr val="CCCCCC"/>
-                      </a:solidFill>
-                    </a:lnL>
-                    <a:lnR w="6350">
-                      <a:solidFill>
-                        <a:srgbClr val="CCCCCC"/>
-                      </a:solidFill>
-                    </a:lnR>
-                    <a:lnT w="6350">
-                      <a:solidFill>
-                        <a:srgbClr val="CCCCCC"/>
-                      </a:solidFill>
-                    </a:lnT>
-                    <a:lnB w="6350">
-                      <a:solidFill>
-                        <a:srgbClr val="CCCCCC"/>
-                      </a:solidFill>
-                    </a:lnB>
-                  </a:tcPr>
-                </a:tc>
-                <a:tc>
-                  <a:txBody>
-                    <a:bodyPr/>
-                    <a:lstStyle/>
-                    <a:p>
-                      <a:pPr>
-                        <a:defRPr sz="1000">
-                          <a:solidFill>
-                            <a:srgbClr val="333333"/>
-                          </a:solidFill>
-                        </a:defRPr>
-                      </a:pPr>
-                      <a:r>
-                        <a:t>48400</a:t>
-                      </a:r>
-                    </a:p>
-                  </a:txBody>
-                  <a:tcPr anchor="ctr">
-                    <a:solidFill>
-                      <a:srgbClr val="E8F0F8"/>
-                    </a:solidFill>
-                    <a:lnL w="6350">
-                      <a:solidFill>
-                        <a:srgbClr val="CCCCCC"/>
-                      </a:solidFill>
-                    </a:lnL>
-                    <a:lnR w="6350">
-                      <a:solidFill>
-                        <a:srgbClr val="CCCCCC"/>
-                      </a:solidFill>
-                    </a:lnR>
-                    <a:lnT w="6350">
-                      <a:solidFill>
-                        <a:srgbClr val="CCCCCC"/>
-                      </a:solidFill>
-                    </a:lnT>
-                    <a:lnB w="6350">
-                      <a:solidFill>
-                        <a:srgbClr val="CCCCCC"/>
-                      </a:solidFill>
-                    </a:lnB>
-                  </a:tcPr>
-                </a:tc>
-                <a:tc>
-                  <a:txBody>
-                    <a:bodyPr/>
-                    <a:lstStyle/>
-                    <a:p>
-                      <a:pPr>
-                        <a:defRPr sz="1000">
-                          <a:solidFill>
-                            <a:srgbClr val="333333"/>
-                          </a:solidFill>
-                        </a:defRPr>
-                      </a:pPr>
-                      <a:r>
-                        <a:t>11.07</a:t>
-                      </a:r>
-                    </a:p>
-                  </a:txBody>
-                  <a:tcPr anchor="ctr">
-                    <a:solidFill>
-                      <a:srgbClr val="E8F0F8"/>
-                    </a:solidFill>
-                    <a:lnL w="6350">
-                      <a:solidFill>
-                        <a:srgbClr val="CCCCCC"/>
-                      </a:solidFill>
-                    </a:lnL>
-                    <a:lnR w="6350">
-                      <a:solidFill>
-                        <a:srgbClr val="CCCCCC"/>
-                      </a:solidFill>
-                    </a:lnR>
-                    <a:lnT w="6350">
-                      <a:solidFill>
-                        <a:srgbClr val="CCCCCC"/>
-                      </a:solidFill>
-                    </a:lnT>
-                    <a:lnB w="6350">
-                      <a:solidFill>
-                        <a:srgbClr val="CCCCCC"/>
-                      </a:solidFill>
-                    </a:lnB>
-                  </a:tcPr>
-                </a:tc>
-              </a:tr>
-              <a:tr h="360000">
-                <a:tc>
-                  <a:txBody>
-                    <a:bodyPr/>
-                    <a:lstStyle/>
-                    <a:p>
-                      <a:pPr>
-                        <a:defRPr sz="1000">
-                          <a:solidFill>
-                            <a:srgbClr val="333333"/>
-                          </a:solidFill>
-                        </a:defRPr>
-                      </a:pPr>
-                      <a:r>
-                        <a:t>星展(台灣)商業銀行</a:t>
-                      </a:r>
-                    </a:p>
-                  </a:txBody>
-                  <a:tcPr anchor="ctr">
-                    <a:solidFill>
-                      <a:srgbClr val="FFFFFF"/>
-                    </a:solidFill>
-                    <a:lnL w="6350">
-                      <a:solidFill>
-                        <a:srgbClr val="CCCCCC"/>
-                      </a:solidFill>
-                    </a:lnL>
-                    <a:lnR w="6350">
-                      <a:solidFill>
-                        <a:srgbClr val="CCCCCC"/>
-                      </a:solidFill>
-                    </a:lnR>
-                    <a:lnT w="6350">
-                      <a:solidFill>
-                        <a:srgbClr val="CCCCCC"/>
-                      </a:solidFill>
-                    </a:lnT>
-                    <a:lnB w="6350">
-                      <a:solidFill>
-                        <a:srgbClr val="CCCCCC"/>
-                      </a:solidFill>
-                    </a:lnB>
-                  </a:tcPr>
-                </a:tc>
-                <a:tc>
-                  <a:txBody>
-                    <a:bodyPr/>
-                    <a:lstStyle/>
-                    <a:p>
-                      <a:pPr>
-                        <a:defRPr sz="1000">
-                          <a:solidFill>
-                            <a:srgbClr val="333333"/>
-                          </a:solidFill>
-                        </a:defRPr>
-                      </a:pPr>
-                      <a:r>
-                        <a:t>332.5</a:t>
-                      </a:r>
-                    </a:p>
-                  </a:txBody>
-                  <a:tcPr anchor="ctr">
-                    <a:solidFill>
-                      <a:srgbClr val="FFFFFF"/>
-                    </a:solidFill>
-                    <a:lnL w="6350">
-                      <a:solidFill>
-                        <a:srgbClr val="CCCCCC"/>
-                      </a:solidFill>
-                    </a:lnL>
-                    <a:lnR w="6350">
-                      <a:solidFill>
-                        <a:srgbClr val="CCCCCC"/>
-                      </a:solidFill>
-                    </a:lnR>
-                    <a:lnT w="6350">
-                      <a:solidFill>
-                        <a:srgbClr val="CCCCCC"/>
-                      </a:solidFill>
-                    </a:lnT>
-                    <a:lnB w="6350">
-                      <a:solidFill>
-                        <a:srgbClr val="CCCCCC"/>
-                      </a:solidFill>
-                    </a:lnB>
-                  </a:tcPr>
-                </a:tc>
-                <a:tc>
-                  <a:txBody>
-                    <a:bodyPr/>
-                    <a:lstStyle/>
-                    <a:p>
-                      <a:pPr>
-                        <a:defRPr sz="1000">
-                          <a:solidFill>
-                            <a:srgbClr val="333333"/>
-                          </a:solidFill>
-                        </a:defRPr>
-                      </a:pPr>
-                      <a:r>
-                        <a:t>23991</a:t>
-                      </a:r>
-                    </a:p>
-                  </a:txBody>
-                  <a:tcPr anchor="ctr">
-                    <a:solidFill>
-                      <a:srgbClr val="FFFFFF"/>
-                    </a:solidFill>
-                    <a:lnL w="6350">
-                      <a:solidFill>
-                        <a:srgbClr val="CCCCCC"/>
-                      </a:solidFill>
-                    </a:lnL>
-                    <a:lnR w="6350">
-                      <a:solidFill>
-                        <a:srgbClr val="CCCCCC"/>
-                      </a:solidFill>
-                    </a:lnR>
-                    <a:lnT w="6350">
-                      <a:solidFill>
-                        <a:srgbClr val="CCCCCC"/>
-                      </a:solidFill>
-                    </a:lnT>
-                    <a:lnB w="6350">
-                      <a:solidFill>
-                        <a:srgbClr val="CCCCCC"/>
-                      </a:solidFill>
-                    </a:lnB>
-                  </a:tcPr>
-                </a:tc>
-                <a:tc>
-                  <a:txBody>
-                    <a:bodyPr/>
-                    <a:lstStyle/>
-                    <a:p>
-                      <a:pPr>
-                        <a:defRPr sz="1000">
-                          <a:solidFill>
-                            <a:srgbClr val="333333"/>
-                          </a:solidFill>
-                        </a:defRPr>
-                      </a:pPr>
-                      <a:r>
-                        <a:t>5.54</a:t>
-                      </a:r>
-                    </a:p>
-                  </a:txBody>
-                  <a:tcPr anchor="ctr">
-                    <a:solidFill>
-                      <a:srgbClr val="FFFFFF"/>
-                    </a:solidFill>
-                    <a:lnL w="6350">
-                      <a:solidFill>
-                        <a:srgbClr val="CCCCCC"/>
-                      </a:solidFill>
-                    </a:lnL>
-                    <a:lnR w="6350">
-                      <a:solidFill>
-                        <a:srgbClr val="CCCCCC"/>
-                      </a:solidFill>
-                    </a:lnR>
-                    <a:lnT w="6350">
-                      <a:solidFill>
-                        <a:srgbClr val="CCCCCC"/>
-                      </a:solidFill>
-                    </a:lnT>
-                    <a:lnB w="6350">
-                      <a:solidFill>
-                        <a:srgbClr val="CCCCCC"/>
-                      </a:solidFill>
-                    </a:lnB>
-                  </a:tcPr>
-                </a:tc>
-              </a:tr>
-              <a:tr h="360000">
-                <a:tc>
-                  <a:txBody>
-                    <a:bodyPr/>
-                    <a:lstStyle/>
-                    <a:p>
-                      <a:pPr>
-                        <a:defRPr sz="1000">
-                          <a:solidFill>
-                            <a:srgbClr val="333333"/>
-                          </a:solidFill>
-                        </a:defRPr>
-                      </a:pPr>
-                      <a:r>
-                        <a:t>聯邦商業銀行</a:t>
-                      </a:r>
-                    </a:p>
-                  </a:txBody>
-                  <a:tcPr anchor="ctr">
-                    <a:solidFill>
-                      <a:srgbClr val="E8F0F8"/>
-                    </a:solidFill>
-                    <a:lnL w="6350">
-                      <a:solidFill>
-                        <a:srgbClr val="CCCCCC"/>
-                      </a:solidFill>
-                    </a:lnL>
-                    <a:lnR w="6350">
-                      <a:solidFill>
-                        <a:srgbClr val="CCCCCC"/>
-                      </a:solidFill>
-                    </a:lnR>
-                    <a:lnT w="6350">
-                      <a:solidFill>
-                        <a:srgbClr val="CCCCCC"/>
-                      </a:solidFill>
-                    </a:lnT>
-                    <a:lnB w="6350">
-                      <a:solidFill>
-                        <a:srgbClr val="CCCCCC"/>
-                      </a:solidFill>
-                    </a:lnB>
-                  </a:tcPr>
-                </a:tc>
-                <a:tc>
-                  <a:txBody>
-                    <a:bodyPr/>
-                    <a:lstStyle/>
-                    <a:p>
-                      <a:pPr>
-                        <a:defRPr sz="1000">
-                          <a:solidFill>
-                            <a:srgbClr val="333333"/>
-                          </a:solidFill>
-                        </a:defRPr>
-                      </a:pPr>
-                      <a:r>
-                        <a:t>273.2</a:t>
-                      </a:r>
-                    </a:p>
-                  </a:txBody>
-                  <a:tcPr anchor="ctr">
-                    <a:solidFill>
-                      <a:srgbClr val="E8F0F8"/>
-                    </a:solidFill>
-                    <a:lnL w="6350">
-                      <a:solidFill>
-                        <a:srgbClr val="CCCCCC"/>
-                      </a:solidFill>
-                    </a:lnL>
-                    <a:lnR w="6350">
-                      <a:solidFill>
-                        <a:srgbClr val="CCCCCC"/>
-                      </a:solidFill>
-                    </a:lnR>
-                    <a:lnT w="6350">
-                      <a:solidFill>
-                        <a:srgbClr val="CCCCCC"/>
-                      </a:solidFill>
-                    </a:lnT>
-                    <a:lnB w="6350">
-                      <a:solidFill>
-                        <a:srgbClr val="CCCCCC"/>
-                      </a:solidFill>
-                    </a:lnB>
-                  </a:tcPr>
-                </a:tc>
-                <a:tc>
-                  <a:txBody>
-                    <a:bodyPr/>
-                    <a:lstStyle/>
-                    <a:p>
-                      <a:pPr>
-                        <a:defRPr sz="1000">
-                          <a:solidFill>
-                            <a:srgbClr val="333333"/>
-                          </a:solidFill>
-                        </a:defRPr>
-                      </a:pPr>
-                      <a:r>
-                        <a:t>15001</a:t>
-                      </a:r>
-                    </a:p>
-                  </a:txBody>
-                  <a:tcPr anchor="ctr">
-                    <a:solidFill>
-                      <a:srgbClr val="E8F0F8"/>
-                    </a:solidFill>
-                    <a:lnL w="6350">
-                      <a:solidFill>
-                        <a:srgbClr val="CCCCCC"/>
-                      </a:solidFill>
-                    </a:lnL>
-                    <a:lnR w="6350">
-                      <a:solidFill>
-                        <a:srgbClr val="CCCCCC"/>
-                      </a:solidFill>
-                    </a:lnR>
-                    <a:lnT w="6350">
-                      <a:solidFill>
-                        <a:srgbClr val="CCCCCC"/>
-                      </a:solidFill>
-                    </a:lnT>
-                    <a:lnB w="6350">
-                      <a:solidFill>
-                        <a:srgbClr val="CCCCCC"/>
-                      </a:solidFill>
-                    </a:lnB>
-                  </a:tcPr>
-                </a:tc>
-                <a:tc>
-                  <a:txBody>
-                    <a:bodyPr/>
-                    <a:lstStyle/>
-                    <a:p>
-                      <a:pPr>
-                        <a:defRPr sz="1000">
-                          <a:solidFill>
-                            <a:srgbClr val="333333"/>
-                          </a:solidFill>
-                        </a:defRPr>
-                      </a:pPr>
-                      <a:r>
-                        <a:t>4.60</a:t>
-                      </a:r>
-                    </a:p>
-                  </a:txBody>
-                  <a:tcPr anchor="ctr">
-                    <a:solidFill>
-                      <a:srgbClr val="E8F0F8"/>
-                    </a:solidFill>
-                    <a:lnL w="6350">
-                      <a:solidFill>
-                        <a:srgbClr val="CCCCCC"/>
-                      </a:solidFill>
-                    </a:lnL>
-                    <a:lnR w="6350">
-                      <a:solidFill>
-                        <a:srgbClr val="CCCCCC"/>
-                      </a:solidFill>
-                    </a:lnR>
-                    <a:lnT w="6350">
-                      <a:solidFill>
-                        <a:srgbClr val="CCCCCC"/>
-                      </a:solidFill>
-                    </a:lnT>
-                    <a:lnB w="6350">
-                      <a:solidFill>
-                        <a:srgbClr val="CCCCCC"/>
-                      </a:solidFill>
-                    </a:lnB>
-                  </a:tcPr>
-                </a:tc>
-              </a:tr>
-              <a:tr h="360000">
-                <a:tc>
-                  <a:txBody>
-                    <a:bodyPr/>
-                    <a:lstStyle/>
-                    <a:p>
-                      <a:pPr>
-                        <a:defRPr sz="1000">
-                          <a:solidFill>
-                            <a:srgbClr val="333333"/>
-                          </a:solidFill>
-                        </a:defRPr>
-                      </a:pPr>
-                      <a:r>
-                        <a:t>永豐商業銀行</a:t>
-                      </a:r>
-                    </a:p>
-                  </a:txBody>
-                  <a:tcPr anchor="ctr">
-                    <a:solidFill>
-                      <a:srgbClr val="FFFFFF"/>
-                    </a:solidFill>
-                    <a:lnL w="6350">
-                      <a:solidFill>
-                        <a:srgbClr val="CCCCCC"/>
-                      </a:solidFill>
-                    </a:lnL>
-                    <a:lnR w="6350">
-                      <a:solidFill>
-                        <a:srgbClr val="CCCCCC"/>
-                      </a:solidFill>
-                    </a:lnR>
-                    <a:lnT w="6350">
-                      <a:solidFill>
-                        <a:srgbClr val="CCCCCC"/>
-                      </a:solidFill>
-                    </a:lnT>
-                    <a:lnB w="6350">
-                      <a:solidFill>
-                        <a:srgbClr val="CCCCCC"/>
-                      </a:solidFill>
-                    </a:lnB>
-                  </a:tcPr>
-                </a:tc>
-                <a:tc>
-                  <a:txBody>
-                    <a:bodyPr/>
-                    <a:lstStyle/>
-                    <a:p>
-                      <a:pPr>
-                        <a:defRPr sz="1000">
-                          <a:solidFill>
-                            <a:srgbClr val="333333"/>
-                          </a:solidFill>
-                        </a:defRPr>
-                      </a:pPr>
-                      <a:r>
-                        <a:t>247.9</a:t>
-                      </a:r>
-                    </a:p>
-                  </a:txBody>
-                  <a:tcPr anchor="ctr">
-                    <a:solidFill>
-                      <a:srgbClr val="FFFFFF"/>
-                    </a:solidFill>
-                    <a:lnL w="6350">
-                      <a:solidFill>
-                        <a:srgbClr val="CCCCCC"/>
-                      </a:solidFill>
-                    </a:lnL>
-                    <a:lnR w="6350">
-                      <a:solidFill>
-                        <a:srgbClr val="CCCCCC"/>
-                      </a:solidFill>
-                    </a:lnR>
-                    <a:lnT w="6350">
-                      <a:solidFill>
-                        <a:srgbClr val="CCCCCC"/>
-                      </a:solidFill>
-                    </a:lnT>
-                    <a:lnB w="6350">
-                      <a:solidFill>
-                        <a:srgbClr val="CCCCCC"/>
-                      </a:solidFill>
-                    </a:lnB>
-                  </a:tcPr>
-                </a:tc>
-                <a:tc>
-                  <a:txBody>
-                    <a:bodyPr/>
-                    <a:lstStyle/>
-                    <a:p>
-                      <a:pPr>
-                        <a:defRPr sz="1000">
-                          <a:solidFill>
-                            <a:srgbClr val="333333"/>
-                          </a:solidFill>
-                        </a:defRPr>
-                      </a:pPr>
-                      <a:r>
-                        <a:t>15838</a:t>
-                      </a:r>
-                    </a:p>
-                  </a:txBody>
-                  <a:tcPr anchor="ctr">
-                    <a:solidFill>
-                      <a:srgbClr val="FFFFFF"/>
-                    </a:solidFill>
-                    <a:lnL w="6350">
-                      <a:solidFill>
-                        <a:srgbClr val="CCCCCC"/>
-                      </a:solidFill>
-                    </a:lnL>
-                    <a:lnR w="6350">
-                      <a:solidFill>
-                        <a:srgbClr val="CCCCCC"/>
-                      </a:solidFill>
-                    </a:lnR>
-                    <a:lnT w="6350">
-                      <a:solidFill>
-                        <a:srgbClr val="CCCCCC"/>
-                      </a:solidFill>
-                    </a:lnT>
-                    <a:lnB w="6350">
-                      <a:solidFill>
-                        <a:srgbClr val="CCCCCC"/>
-                      </a:solidFill>
-                    </a:lnB>
-                  </a:tcPr>
-                </a:tc>
-                <a:tc>
-                  <a:txBody>
-                    <a:bodyPr/>
-                    <a:lstStyle/>
-                    <a:p>
-                      <a:pPr>
-                        <a:defRPr sz="1000">
-                          <a:solidFill>
-                            <a:srgbClr val="333333"/>
-                          </a:solidFill>
-                        </a:defRPr>
-                      </a:pPr>
-                      <a:r>
-                        <a:t>4.02</a:t>
-                      </a:r>
-                    </a:p>
-                  </a:txBody>
-                  <a:tcPr anchor="ctr">
-                    <a:solidFill>
-                      <a:srgbClr val="FFFFFF"/>
-                    </a:solidFill>
-                    <a:lnL w="6350">
-                      <a:solidFill>
-                        <a:srgbClr val="CCCCCC"/>
-                      </a:solidFill>
-                    </a:lnL>
-                    <a:lnR w="6350">
-                      <a:solidFill>
-                        <a:srgbClr val="CCCCCC"/>
-                      </a:solidFill>
-                    </a:lnR>
-                    <a:lnT w="6350">
-                      <a:solidFill>
-                        <a:srgbClr val="CCCCCC"/>
-                      </a:solidFill>
-                    </a:lnT>
-                    <a:lnB w="6350">
-                      <a:solidFill>
-                        <a:srgbClr val="CCCCCC"/>
-                      </a:solidFill>
-                    </a:lnB>
-                  </a:tcPr>
-                </a:tc>
-              </a:tr>
-              <a:tr h="360000">
-                <a:tc>
-                  <a:txBody>
-                    <a:bodyPr/>
-                    <a:lstStyle/>
-                    <a:p>
-                      <a:pPr>
-                        <a:defRPr sz="1000">
-                          <a:solidFill>
-                            <a:srgbClr val="333333"/>
-                          </a:solidFill>
-                        </a:defRPr>
-                      </a:pPr>
-                      <a:r>
-                        <a:t>第一商業銀行</a:t>
-                      </a:r>
-                    </a:p>
-                  </a:txBody>
-                  <a:tcPr anchor="ctr">
-                    <a:solidFill>
-                      <a:srgbClr val="E8F0F8"/>
-                    </a:solidFill>
-                    <a:lnL w="6350">
-                      <a:solidFill>
-                        <a:srgbClr val="CCCCCC"/>
-                      </a:solidFill>
-                    </a:lnL>
-                    <a:lnR w="6350">
-                      <a:solidFill>
-                        <a:srgbClr val="CCCCCC"/>
-                      </a:solidFill>
-                    </a:lnR>
-                    <a:lnT w="6350">
-                      <a:solidFill>
-                        <a:srgbClr val="CCCCCC"/>
-                      </a:solidFill>
-                    </a:lnT>
-                    <a:lnB w="6350">
-                      <a:solidFill>
-                        <a:srgbClr val="CCCCCC"/>
-                      </a:solidFill>
-                    </a:lnB>
-                  </a:tcPr>
-                </a:tc>
-                <a:tc>
-                  <a:txBody>
-                    <a:bodyPr/>
-                    <a:lstStyle/>
-                    <a:p>
-                      <a:pPr>
-                        <a:defRPr sz="1000">
-                          <a:solidFill>
-                            <a:srgbClr val="333333"/>
-                          </a:solidFill>
-                        </a:defRPr>
-                      </a:pPr>
-                      <a:r>
-                        <a:t>153.1</a:t>
-                      </a:r>
-                    </a:p>
-                  </a:txBody>
-                  <a:tcPr anchor="ctr">
-                    <a:solidFill>
-                      <a:srgbClr val="E8F0F8"/>
-                    </a:solidFill>
-                    <a:lnL w="6350">
-                      <a:solidFill>
-                        <a:srgbClr val="CCCCCC"/>
-                      </a:solidFill>
-                    </a:lnL>
-                    <a:lnR w="6350">
-                      <a:solidFill>
-                        <a:srgbClr val="CCCCCC"/>
-                      </a:solidFill>
-                    </a:lnR>
-                    <a:lnT w="6350">
-                      <a:solidFill>
-                        <a:srgbClr val="CCCCCC"/>
-                      </a:solidFill>
-                    </a:lnT>
-                    <a:lnB w="6350">
-                      <a:solidFill>
-                        <a:srgbClr val="CCCCCC"/>
-                      </a:solidFill>
-                    </a:lnB>
-                  </a:tcPr>
-                </a:tc>
-                <a:tc>
-                  <a:txBody>
-                    <a:bodyPr/>
-                    <a:lstStyle/>
-                    <a:p>
-                      <a:pPr>
-                        <a:defRPr sz="1000">
-                          <a:solidFill>
-                            <a:srgbClr val="333333"/>
-                          </a:solidFill>
-                        </a:defRPr>
-                      </a:pPr>
-                      <a:r>
-                        <a:t>7583</a:t>
-                      </a:r>
-                    </a:p>
-                  </a:txBody>
-                  <a:tcPr anchor="ctr">
-                    <a:solidFill>
-                      <a:srgbClr val="E8F0F8"/>
-                    </a:solidFill>
-                    <a:lnL w="6350">
-                      <a:solidFill>
-                        <a:srgbClr val="CCCCCC"/>
-                      </a:solidFill>
-                    </a:lnL>
-                    <a:lnR w="6350">
-                      <a:solidFill>
-                        <a:srgbClr val="CCCCCC"/>
-                      </a:solidFill>
-                    </a:lnR>
-                    <a:lnT w="6350">
-                      <a:solidFill>
-                        <a:srgbClr val="CCCCCC"/>
-                      </a:solidFill>
-                    </a:lnT>
-                    <a:lnB w="6350">
-                      <a:solidFill>
-                        <a:srgbClr val="CCCCCC"/>
-                      </a:solidFill>
-                    </a:lnB>
-                  </a:tcPr>
-                </a:tc>
-                <a:tc>
-                  <a:txBody>
-                    <a:bodyPr/>
-                    <a:lstStyle/>
-                    <a:p>
-                      <a:pPr>
-                        <a:defRPr sz="1000">
-                          <a:solidFill>
-                            <a:srgbClr val="333333"/>
-                          </a:solidFill>
-                        </a:defRPr>
-                      </a:pPr>
-                      <a:r>
-                        <a:t>2.52</a:t>
-                      </a:r>
-                    </a:p>
-                  </a:txBody>
-                  <a:tcPr anchor="ctr">
-                    <a:solidFill>
-                      <a:srgbClr val="E8F0F8"/>
-                    </a:solidFill>
-                    <a:lnL w="6350">
-                      <a:solidFill>
-                        <a:srgbClr val="CCCCCC"/>
-                      </a:solidFill>
-                    </a:lnL>
-                    <a:lnR w="6350">
-                      <a:solidFill>
-                        <a:srgbClr val="CCCCCC"/>
-                      </a:solidFill>
-                    </a:lnR>
-                    <a:lnT w="6350">
-                      <a:solidFill>
-                        <a:srgbClr val="CCCCCC"/>
-                      </a:solidFill>
-                    </a:lnT>
-                    <a:lnB w="6350">
-                      <a:solidFill>
-                        <a:srgbClr val="CCCCCC"/>
-                      </a:solidFill>
-                    </a:lnB>
-                  </a:tcPr>
-                </a:tc>
-              </a:tr>
-              <a:tr h="360000">
-                <a:tc>
-                  <a:txBody>
-                    <a:bodyPr/>
-                    <a:lstStyle/>
-                    <a:p>
-                      <a:pPr>
-                        <a:defRPr sz="1000">
-                          <a:solidFill>
-                            <a:srgbClr val="333333"/>
-                          </a:solidFill>
-                        </a:defRPr>
-                      </a:pPr>
-                      <a:r>
-                        <a:t>遠東國際商業銀行</a:t>
-                      </a:r>
-                    </a:p>
-                  </a:txBody>
-                  <a:tcPr anchor="ctr">
-                    <a:solidFill>
-                      <a:srgbClr val="FFFFFF"/>
-                    </a:solidFill>
-                    <a:lnL w="6350">
-                      <a:solidFill>
-                        <a:srgbClr val="CCCCCC"/>
-                      </a:solidFill>
-                    </a:lnL>
-                    <a:lnR w="6350">
-                      <a:solidFill>
-                        <a:srgbClr val="CCCCCC"/>
-                      </a:solidFill>
-                    </a:lnR>
-                    <a:lnT w="6350">
-                      <a:solidFill>
-                        <a:srgbClr val="CCCCCC"/>
-                      </a:solidFill>
-                    </a:lnT>
-                    <a:lnB w="6350">
-                      <a:solidFill>
-                        <a:srgbClr val="CCCCCC"/>
-                      </a:solidFill>
-                    </a:lnB>
-                  </a:tcPr>
-                </a:tc>
-                <a:tc>
-                  <a:txBody>
-                    <a:bodyPr/>
-                    <a:lstStyle/>
-                    <a:p>
-                      <a:pPr>
-                        <a:defRPr sz="1000">
-                          <a:solidFill>
-                            <a:srgbClr val="333333"/>
-                          </a:solidFill>
-                        </a:defRPr>
-                      </a:pPr>
-                      <a:r>
-                        <a:t>129.0</a:t>
-                      </a:r>
-                    </a:p>
-                  </a:txBody>
-                  <a:tcPr anchor="ctr">
-                    <a:solidFill>
-                      <a:srgbClr val="FFFFFF"/>
-                    </a:solidFill>
-                    <a:lnL w="6350">
-                      <a:solidFill>
-                        <a:srgbClr val="CCCCCC"/>
-                      </a:solidFill>
-                    </a:lnL>
-                    <a:lnR w="6350">
-                      <a:solidFill>
-                        <a:srgbClr val="CCCCCC"/>
-                      </a:solidFill>
-                    </a:lnR>
-                    <a:lnT w="6350">
-                      <a:solidFill>
-                        <a:srgbClr val="CCCCCC"/>
-                      </a:solidFill>
-                    </a:lnT>
-                    <a:lnB w="6350">
-                      <a:solidFill>
-                        <a:srgbClr val="CCCCCC"/>
-                      </a:solidFill>
-                    </a:lnB>
-                  </a:tcPr>
-                </a:tc>
-                <a:tc>
-                  <a:txBody>
-                    <a:bodyPr/>
-                    <a:lstStyle/>
-                    <a:p>
-                      <a:pPr>
-                        <a:defRPr sz="1000">
-                          <a:solidFill>
-                            <a:srgbClr val="333333"/>
-                          </a:solidFill>
-                        </a:defRPr>
-                      </a:pPr>
-                      <a:r>
-                        <a:t>4517</a:t>
-                      </a:r>
-                    </a:p>
-                  </a:txBody>
-                  <a:tcPr anchor="ctr">
-                    <a:solidFill>
-                      <a:srgbClr val="FFFFFF"/>
-                    </a:solidFill>
-                    <a:lnL w="6350">
-                      <a:solidFill>
-                        <a:srgbClr val="CCCCCC"/>
-                      </a:solidFill>
-                    </a:lnL>
-                    <a:lnR w="6350">
-                      <a:solidFill>
-                        <a:srgbClr val="CCCCCC"/>
-                      </a:solidFill>
-                    </a:lnR>
-                    <a:lnT w="6350">
-                      <a:solidFill>
-                        <a:srgbClr val="CCCCCC"/>
-                      </a:solidFill>
-                    </a:lnT>
-                    <a:lnB w="6350">
-                      <a:solidFill>
-                        <a:srgbClr val="CCCCCC"/>
-                      </a:solidFill>
-                    </a:lnB>
-                  </a:tcPr>
-                </a:tc>
-                <a:tc>
-                  <a:txBody>
-                    <a:bodyPr/>
-                    <a:lstStyle/>
-                    <a:p>
-                      <a:pPr>
-                        <a:defRPr sz="1000">
-                          <a:solidFill>
-                            <a:srgbClr val="333333"/>
-                          </a:solidFill>
-                        </a:defRPr>
-                      </a:pPr>
-                      <a:r>
-                        <a:t>2.23</a:t>
-                      </a:r>
-                    </a:p>
-                  </a:txBody>
-                  <a:tcPr anchor="ctr">
-                    <a:solidFill>
-                      <a:srgbClr val="FFFFFF"/>
-                    </a:solidFill>
-                    <a:lnL w="6350">
-                      <a:solidFill>
-                        <a:srgbClr val="CCCCCC"/>
-                      </a:solidFill>
-                    </a:lnL>
-                    <a:lnR w="6350">
-                      <a:solidFill>
-                        <a:srgbClr val="CCCCCC"/>
-                      </a:solidFill>
-                    </a:lnR>
-                    <a:lnT w="6350">
-                      <a:solidFill>
-                        <a:srgbClr val="CCCCCC"/>
-                      </a:solidFill>
-                    </a:lnT>
-                    <a:lnB w="6350">
-                      <a:solidFill>
-                        <a:srgbClr val="CCCCCC"/>
-                      </a:solidFill>
-                    </a:lnB>
-                  </a:tcPr>
-                </a:tc>
-              </a:tr>
-            </a:tbl>
+          <a:graphicData uri="http://schemas.openxmlformats.org/drawingml/2006/chart">
+            <c:chart xmlns:c="http://schemas.openxmlformats.org/drawingml/2006/chart" r:id="rId3"/>
           </a:graphicData>
         </a:graphic>
       </p:graphicFrame>
+      <p:sp>
+        <p:nvSpPr>
+          <p:cNvPr id="7" name="TextBox 6"/>
+          <p:cNvSpPr txBox="1"/>
+          <p:nvPr/>
+        </p:nvSpPr>
+        <p:spPr>
+          <a:xfrm>
+            <a:off x="540000" y="5400000"/>
+            <a:ext cx="10800000" cy="432000"/>
+          </a:xfrm>
+          <a:prstGeom prst="rect">
+            <a:avLst/>
+          </a:prstGeom>
+          <a:noFill/>
+        </p:spPr>
+        <p:txBody>
+          <a:bodyPr wrap="square">
+            <a:spAutoFit/>
+          </a:bodyPr>
+          <a:lstStyle/>
+          <a:p>
+            <a:pPr>
+              <a:defRPr sz="1100">
+                <a:solidFill>
+                  <a:srgbClr val="333333"/>
+                </a:solidFill>
+              </a:defRPr>
+            </a:pPr>
+            <a:r>
+              <a:t>◆ 本頁標題為「流通卡數月增率」，但計算引擎回傳空陣列，表示資料來源缺少必要的時間序列數據或計算失敗。在無數據支撐的情況下，無法判斷各銀行流通卡數的成長動能、市場擴張速度或競爭態勢。建議行動：(1) 確認原始資料是否包含至少連續兩期的流通卡數，以計算月增率；(2) 檢查資料欄位命名是否符合計算引擎的辨識規則；(3) 若資料確實缺失，考慮改用「流通卡數絕對值」或「市占率」等替代指標呈現銀行規模與競爭地位。</a:t>
+            </a:r>
+          </a:p>
+        </p:txBody>
+      </p:sp>
     </p:spTree>
   </p:cSld>
   <p:clrMapOvr>
@@ -9333,7 +8014,7 @@
               </a:defRPr>
             </a:pPr>
             <a:r>
-              <a:t>◆ 台新信用卡業務策略建議</a:t>
+              <a:t>◆ 缺乏數據支撐，無法產出策略建議</a:t>
             </a:r>
           </a:p>
         </p:txBody>
@@ -9403,7 +8084,7 @@
               </a:defRPr>
             </a:pPr>
             <a:r>
-              <a:t>提升有效卡率至 75% 以上</a:t>
+              <a:t>重新檢視簡報架構與數據流</a:t>
             </a:r>
           </a:p>
         </p:txBody>
@@ -9438,7 +8119,7 @@
               </a:defRPr>
             </a:pPr>
             <a:r>
-              <a:t>根據流通卡數與簽帳金額比較，台新有提升空間</a:t>
+              <a:t>策略建議頁應為前述分析的總結與行動方案。若無數據可引用，可能原因包括：(1) 前面章節未產生可供決策的關鍵指標，(2) 數據傳遞流程中斷，(3) 簡報結構設計未將發現轉化為可引用的 metrics。建議回顧第 1-14 頁的分析重點，確保每個章節都有明確的數據發現，並將這些發現的 metric_ids 彙整至本頁。</a:t>
             </a:r>
           </a:p>
         </p:txBody>
@@ -9508,7 +8189,7 @@
               </a:defRPr>
             </a:pPr>
             <a:r>
-              <a:t>拓展高消費力客群</a:t>
+              <a:t>建立「發現→策略→行動」的邏輯鏈</a:t>
             </a:r>
           </a:p>
         </p:txBody>
@@ -9543,112 +8224,7 @@
               </a:defRPr>
             </a:pPr>
             <a:r>
-              <a:t>提升每卡簽帳金額以追趕同業</a:t>
-            </a:r>
-          </a:p>
-        </p:txBody>
-      </p:sp>
-      <p:sp>
-        <p:nvSpPr>
-          <p:cNvPr id="12" name="TextBox 11"/>
-          <p:cNvSpPr txBox="1"/>
-          <p:nvPr/>
-        </p:nvSpPr>
-        <p:spPr>
-          <a:xfrm>
-            <a:off x="540000" y="3600000"/>
-            <a:ext cx="720000" cy="540000"/>
-          </a:xfrm>
-          <a:prstGeom prst="rect">
-            <a:avLst/>
-          </a:prstGeom>
-          <a:noFill/>
-        </p:spPr>
-        <p:txBody>
-          <a:bodyPr wrap="none">
-            <a:spAutoFit/>
-          </a:bodyPr>
-          <a:lstStyle/>
-          <a:p>
-            <a:pPr>
-              <a:defRPr sz="2600" b="1">
-                <a:solidFill>
-                  <a:srgbClr val="0066CC"/>
-                </a:solidFill>
-              </a:defRPr>
-            </a:pPr>
-            <a:r>
-              <a:t>03</a:t>
-            </a:r>
-          </a:p>
-        </p:txBody>
-      </p:sp>
-      <p:sp>
-        <p:nvSpPr>
-          <p:cNvPr id="13" name="TextBox 12"/>
-          <p:cNvSpPr txBox="1"/>
-          <p:nvPr/>
-        </p:nvSpPr>
-        <p:spPr>
-          <a:xfrm>
-            <a:off x="1440000" y="3600000"/>
-            <a:ext cx="9720000" cy="288000"/>
-          </a:xfrm>
-          <a:prstGeom prst="rect">
-            <a:avLst/>
-          </a:prstGeom>
-          <a:noFill/>
-        </p:spPr>
-        <p:txBody>
-          <a:bodyPr wrap="none">
-            <a:spAutoFit/>
-          </a:bodyPr>
-          <a:lstStyle/>
-          <a:p>
-            <a:pPr>
-              <a:defRPr sz="1400" b="1">
-                <a:solidFill>
-                  <a:srgbClr val="003366"/>
-                </a:solidFill>
-              </a:defRPr>
-            </a:pPr>
-            <a:r>
-              <a:t>優化分期產品組合</a:t>
-            </a:r>
-          </a:p>
-        </p:txBody>
-      </p:sp>
-      <p:sp>
-        <p:nvSpPr>
-          <p:cNvPr id="14" name="TextBox 13"/>
-          <p:cNvSpPr txBox="1"/>
-          <p:nvPr/>
-        </p:nvSpPr>
-        <p:spPr>
-          <a:xfrm>
-            <a:off x="1440000" y="3924000"/>
-            <a:ext cx="9720000" cy="540000"/>
-          </a:xfrm>
-          <a:prstGeom prst="rect">
-            <a:avLst/>
-          </a:prstGeom>
-          <a:noFill/>
-        </p:spPr>
-        <p:txBody>
-          <a:bodyPr wrap="square">
-            <a:spAutoFit/>
-          </a:bodyPr>
-          <a:lstStyle/>
-          <a:p>
-            <a:pPr>
-              <a:defRPr sz="1200">
-                <a:solidFill>
-                  <a:srgbClr val="333333"/>
-                </a:solidFill>
-              </a:defRPr>
-            </a:pPr>
-            <a:r>
-              <a:t>把握分期消費趨勢，增加中間業務收入</a:t>
+              <a:t>有效的策略頁必須展現清晰的因果邏輯：從數據發現（What）→管理意涵（So What）→行動方案（Now What）。目前缺少數據層，無法建立此邏輯鏈。建議在前述章節中標記 3-5 個最關鍵的發現（如市占變化、成長落差、風險指標），並在本頁引用這些數據作為策略建議的證據基礎。</a:t>
             </a:r>
           </a:p>
         </p:txBody>
@@ -9877,6 +8453,41 @@
         </p:nvSpPr>
         <p:spPr>
           <a:xfrm>
+            <a:off x="360000" y="1044000"/>
+            <a:ext cx="11232000" cy="360000"/>
+          </a:xfrm>
+          <a:prstGeom prst="rect">
+            <a:avLst/>
+          </a:prstGeom>
+          <a:noFill/>
+        </p:spPr>
+        <p:txBody>
+          <a:bodyPr wrap="square">
+            <a:spAutoFit/>
+          </a:bodyPr>
+          <a:lstStyle/>
+          <a:p>
+            <a:pPr>
+              <a:defRPr sz="1200" b="1">
+                <a:solidFill>
+                  <a:srgbClr val="333333"/>
+                </a:solidFill>
+              </a:defRPr>
+            </a:pPr>
+            <a:r>
+              <a:t>◆ 本簡報涵蓋資料概覽、趨勢分析、結構解析與策略建議四大面向</a:t>
+            </a:r>
+          </a:p>
+        </p:txBody>
+      </p:sp>
+      <p:sp>
+        <p:nvSpPr>
+          <p:cNvPr id="6" name="TextBox 5"/>
+          <p:cNvSpPr txBox="1"/>
+          <p:nvPr/>
+        </p:nvSpPr>
+        <p:spPr>
+          <a:xfrm>
             <a:off x="1080000" y="1620000"/>
             <a:ext cx="9000000" cy="540000"/>
           </a:xfrm>
@@ -9906,7 +8517,7 @@
       </p:sp>
       <p:sp>
         <p:nvSpPr>
-          <p:cNvPr id="6" name="TextBox 5"/>
+          <p:cNvPr id="7" name="TextBox 6"/>
           <p:cNvSpPr txBox="1"/>
           <p:nvPr/>
         </p:nvSpPr>
@@ -9941,7 +8552,7 @@
       </p:sp>
       <p:sp>
         <p:nvSpPr>
-          <p:cNvPr id="7" name="TextBox 6"/>
+          <p:cNvPr id="8" name="TextBox 7"/>
           <p:cNvSpPr txBox="1"/>
           <p:nvPr/>
         </p:nvSpPr>
@@ -9976,7 +8587,7 @@
       </p:sp>
       <p:sp>
         <p:nvSpPr>
-          <p:cNvPr id="8" name="TextBox 7"/>
+          <p:cNvPr id="9" name="TextBox 8"/>
           <p:cNvSpPr txBox="1"/>
           <p:nvPr/>
         </p:nvSpPr>
@@ -10011,7 +8622,7 @@
       </p:sp>
       <p:sp>
         <p:nvSpPr>
-          <p:cNvPr id="9" name="TextBox 8"/>
+          <p:cNvPr id="10" name="TextBox 9"/>
           <p:cNvSpPr txBox="1"/>
           <p:nvPr/>
         </p:nvSpPr>
@@ -10155,7 +8766,7 @@
               </a:defRPr>
             </a:pPr>
             <a:r>
-              <a:t>◆ 市場關鍵指標摘要</a:t>
+              <a:t>◆ 資料尚未載入，無法產生執行摘要</a:t>
             </a:r>
           </a:p>
         </p:txBody>
@@ -10225,7 +8836,7 @@
               </a:defRPr>
             </a:pPr>
             <a:r>
-              <a:t>6049 萬張</a:t>
+              <a:t>6,049 萬</a:t>
             </a:r>
           </a:p>
         </p:txBody>
@@ -10260,7 +8871,7 @@
               </a:defRPr>
             </a:pPr>
             <a:r>
-              <a:t>台新流通卡數</a:t>
+              <a:t>市場簽帳金額(月)</a:t>
             </a:r>
           </a:p>
         </p:txBody>
@@ -10295,7 +8906,7 @@
               </a:defRPr>
             </a:pPr>
             <a:r>
-              <a:t>663 萬張</a:t>
+              <a:t>454 億</a:t>
             </a:r>
           </a:p>
         </p:txBody>
@@ -10330,7 +8941,7 @@
               </a:defRPr>
             </a:pPr>
             <a:r>
-              <a:t>台新市佔率</a:t>
+              <a:t>三信商業銀行市占率</a:t>
             </a:r>
           </a:p>
         </p:txBody>
@@ -10365,7 +8976,7 @@
               </a:defRPr>
             </a:pPr>
             <a:r>
-              <a:t>11.1%</a:t>
+              <a:t>0.0%</a:t>
             </a:r>
           </a:p>
         </p:txBody>
@@ -10373,6 +8984,41 @@
       <p:sp>
         <p:nvSpPr>
           <p:cNvPr id="12" name="TextBox 11"/>
+          <p:cNvSpPr txBox="1"/>
+          <p:nvPr/>
+        </p:nvSpPr>
+        <p:spPr>
+          <a:xfrm>
+            <a:off x="5976000" y="2340000"/>
+            <a:ext cx="2700000" cy="251999"/>
+          </a:xfrm>
+          <a:prstGeom prst="rect">
+            <a:avLst/>
+          </a:prstGeom>
+          <a:noFill/>
+        </p:spPr>
+        <p:txBody>
+          <a:bodyPr wrap="none">
+            <a:spAutoFit/>
+          </a:bodyPr>
+          <a:lstStyle/>
+          <a:p>
+            <a:pPr>
+              <a:defRPr sz="1100">
+                <a:solidFill>
+                  <a:srgbClr val="666666"/>
+                </a:solidFill>
+              </a:defRPr>
+            </a:pPr>
+            <a:r>
+              <a:t>排名第五</a:t>
+            </a:r>
+          </a:p>
+        </p:txBody>
+      </p:sp>
+      <p:sp>
+        <p:nvSpPr>
+          <p:cNvPr id="13" name="TextBox 12"/>
           <p:cNvSpPr txBox="1"/>
           <p:nvPr/>
         </p:nvSpPr>
@@ -10400,14 +9046,14 @@
               </a:defRPr>
             </a:pPr>
             <a:r>
-              <a:t>台新當月簽帳金額</a:t>
+              <a:t>三信商業銀行簽帳市占</a:t>
             </a:r>
           </a:p>
         </p:txBody>
       </p:sp>
       <p:sp>
         <p:nvSpPr>
-          <p:cNvPr id="13" name="TextBox 12"/>
+          <p:cNvPr id="14" name="TextBox 13"/>
           <p:cNvSpPr txBox="1"/>
           <p:nvPr/>
         </p:nvSpPr>
@@ -10435,7 +9081,73 @@
               </a:defRPr>
             </a:pPr>
             <a:r>
-              <a:t>48400 百萬元</a:t>
+              <a:t>0.0%</a:t>
+            </a:r>
+          </a:p>
+        </p:txBody>
+      </p:sp>
+      <p:sp>
+        <p:nvSpPr>
+          <p:cNvPr id="15" name="TextBox 14"/>
+          <p:cNvSpPr txBox="1"/>
+          <p:nvPr/>
+        </p:nvSpPr>
+        <p:spPr>
+          <a:xfrm>
+            <a:off x="360000" y="2880000"/>
+            <a:ext cx="11232000" cy="288000"/>
+          </a:xfrm>
+          <a:prstGeom prst="rect">
+            <a:avLst/>
+          </a:prstGeom>
+          <a:noFill/>
+        </p:spPr>
+        <p:txBody>
+          <a:bodyPr wrap="none">
+            <a:spAutoFit/>
+          </a:bodyPr>
+          <a:lstStyle/>
+          <a:p>
+            <a:pPr>
+              <a:defRPr sz="1400" b="1">
+                <a:solidFill>
+                  <a:srgbClr val="003366"/>
+                </a:solidFill>
+              </a:defRPr>
+            </a:pPr>
+            <a:r>
+              <a:t>關鍵洞察</a:t>
+            </a:r>
+          </a:p>
+        </p:txBody>
+      </p:sp>
+      <p:sp>
+        <p:nvSpPr>
+          <p:cNvPr id="16" name="TextBox 15"/>
+          <p:cNvSpPr txBox="1"/>
+          <p:nvPr/>
+        </p:nvSpPr>
+        <p:spPr>
+          <a:xfrm>
+            <a:off x="540000" y="3240000"/>
+            <a:ext cx="10800000" cy="540000"/>
+          </a:xfrm>
+          <a:prstGeom prst="rect">
+            <a:avLst/>
+          </a:prstGeom>
+          <a:noFill/>
+        </p:spPr>
+        <p:txBody>
+          <a:bodyPr wrap="square">
+            <a:spAutoFit/>
+          </a:bodyPr>
+          <a:lstStyle/>
+          <a:p>
+            <a:pPr>
+              <a:defRPr sz="1200"/>
+            </a:pPr>
+            <a:r>
+              <a:t>• 目前計算引擎未提供任何指標數據，無法進行分析。執行摘要頁面需要關鍵績效指標、趨勢數據或比較基準才能產出策略洞察。建議確認資料來源是否正確載入，或檢視後續頁面是否包含可供摘要的分析內容。</a:t>
             </a:r>
           </a:p>
         </p:txBody>
@@ -10632,7 +9344,7 @@
               </a:defRPr>
             </a:pPr>
             <a:r>
-              <a:t>◆ 市場卡數與簽帳金額走勢</a:t>
+              <a:t>◆ 無法產生洞察：缺少計量數據支撐</a:t>
             </a:r>
           </a:p>
         </p:txBody>
@@ -10655,6 +9367,41 @@
           </a:graphicData>
         </a:graphic>
       </p:graphicFrame>
+      <p:sp>
+        <p:nvSpPr>
+          <p:cNvPr id="7" name="TextBox 6"/>
+          <p:cNvSpPr txBox="1"/>
+          <p:nvPr/>
+        </p:nvSpPr>
+        <p:spPr>
+          <a:xfrm>
+            <a:off x="540000" y="5400000"/>
+            <a:ext cx="10800000" cy="432000"/>
+          </a:xfrm>
+          <a:prstGeom prst="rect">
+            <a:avLst/>
+          </a:prstGeom>
+          <a:noFill/>
+        </p:spPr>
+        <p:txBody>
+          <a:bodyPr wrap="square">
+            <a:spAutoFit/>
+          </a:bodyPr>
+          <a:lstStyle/>
+          <a:p>
+            <a:pPr>
+              <a:defRPr sz="1100">
+                <a:solidFill>
+                  <a:srgbClr val="333333"/>
+                </a:solidFill>
+              </a:defRPr>
+            </a:pPr>
+            <a:r>
+              <a:t>◆ 本頁標示為「市場規模趨勢」，但計算引擎未提供任何可引用的指標數據（metric_id 清單為空）。在缺乏數值證據的情況下，無法判斷市場規模的實際表現、變化方向或業務意涵。建議行動：請檢查資料來源是否完整上傳，或確認此頁是否應調整為其他有數據支撐的分析主題。</a:t>
+            </a:r>
+          </a:p>
+        </p:txBody>
+      </p:sp>
     </p:spTree>
   </p:cSld>
   <p:clrMapOvr>
@@ -10766,7 +9513,7 @@
               </a:defRPr>
             </a:pPr>
             <a:r>
-              <a:t>◆ 各銀行流通卡數市占率</a:t>
+              <a:t>◆ 無法產生洞察：計算引擎未提供任何市占率數據</a:t>
             </a:r>
           </a:p>
         </p:txBody>
@@ -10789,6 +9536,76 @@
           </a:graphicData>
         </a:graphic>
       </p:graphicFrame>
+      <p:sp>
+        <p:nvSpPr>
+          <p:cNvPr id="7" name="TextBox 6"/>
+          <p:cNvSpPr txBox="1"/>
+          <p:nvPr/>
+        </p:nvSpPr>
+        <p:spPr>
+          <a:xfrm>
+            <a:off x="540000" y="5400000"/>
+            <a:ext cx="10800000" cy="432000"/>
+          </a:xfrm>
+          <a:prstGeom prst="rect">
+            <a:avLst/>
+          </a:prstGeom>
+          <a:noFill/>
+        </p:spPr>
+        <p:txBody>
+          <a:bodyPr wrap="square">
+            <a:spAutoFit/>
+          </a:bodyPr>
+          <a:lstStyle/>
+          <a:p>
+            <a:pPr>
+              <a:defRPr sz="1100">
+                <a:solidFill>
+                  <a:srgbClr val="333333"/>
+                </a:solidFill>
+              </a:defRPr>
+            </a:pPr>
+            <a:r>
+              <a:t>◆ 本頁面規劃為「市占率排名」分析，但計算引擎回傳空白結果集（metric_ids 為空陣列）。這可能反映三種情況：(1) 原始資料中缺少市占率相關欄位，(2) 資料處理流程中市占率計算邏輯尚未執行，或 (3) 資料範圍設定導致無符合條件的記錄。**建議行動**：請檢查原始資料是否包含各銀行的交易量或金額數據，並確認計算引擎已正確執行市占率計算邏輯（分子：各銀行數值 ÷ 分母：總體市場數值）。若資料確實存在但未被處理，需回溯資料載入與轉換步驟。</a:t>
+            </a:r>
+          </a:p>
+        </p:txBody>
+      </p:sp>
+      <p:sp>
+        <p:nvSpPr>
+          <p:cNvPr id="8" name="TextBox 7"/>
+          <p:cNvSpPr txBox="1"/>
+          <p:nvPr/>
+        </p:nvSpPr>
+        <p:spPr>
+          <a:xfrm>
+            <a:off x="540000" y="5868000"/>
+            <a:ext cx="10800000" cy="432000"/>
+          </a:xfrm>
+          <a:prstGeom prst="rect">
+            <a:avLst/>
+          </a:prstGeom>
+          <a:noFill/>
+        </p:spPr>
+        <p:txBody>
+          <a:bodyPr wrap="square">
+            <a:spAutoFit/>
+          </a:bodyPr>
+          <a:lstStyle/>
+          <a:p>
+            <a:pPr>
+              <a:defRPr sz="1100">
+                <a:solidFill>
+                  <a:srgbClr val="333333"/>
+                </a:solidFill>
+              </a:defRPr>
+            </a:pPr>
+            <a:r>
+              <a:t>◆ 儘管頁面已預設六家銀行類別（中國信託、玉山、台北富邦、國泰世華、台新、星展），但無對應數值可供排名比較。**管理意涵**：無法執行競爭定位分析，無法識別市場領導者或落後者，策略規劃將缺乏量化依據。**可能原因**：推測資料來源可能僅包含單一機構數據，或市場總量基準值缺失導致市占率無法計算。**建議行動**：若目標是進行跨行比較，需補充同業數據；若僅有自身數據，應調整簡報架構為「自身績效趨勢」而非「市占率排名」。</a:t>
+            </a:r>
+          </a:p>
+        </p:txBody>
+      </p:sp>
     </p:spTree>
   </p:cSld>
   <p:clrMapOvr>
@@ -10981,7 +9798,7 @@
               </a:defRPr>
             </a:pPr>
             <a:r>
-              <a:t>◆ 規模與成長象限分析</a:t>
+              <a:t>◆ 無可用數據，無法進行規模與成長關係分析</a:t>
             </a:r>
           </a:p>
         </p:txBody>
@@ -11004,6 +9821,41 @@
           </a:graphicData>
         </a:graphic>
       </p:graphicFrame>
+      <p:sp>
+        <p:nvSpPr>
+          <p:cNvPr id="7" name="TextBox 6"/>
+          <p:cNvSpPr txBox="1"/>
+          <p:nvPr/>
+        </p:nvSpPr>
+        <p:spPr>
+          <a:xfrm>
+            <a:off x="540000" y="5400000"/>
+            <a:ext cx="10800000" cy="432000"/>
+          </a:xfrm>
+          <a:prstGeom prst="rect">
+            <a:avLst/>
+          </a:prstGeom>
+          <a:noFill/>
+        </p:spPr>
+        <p:txBody>
+          <a:bodyPr wrap="square">
+            <a:spAutoFit/>
+          </a:bodyPr>
+          <a:lstStyle/>
+          <a:p>
+            <a:pPr>
+              <a:defRPr sz="1100">
+                <a:solidFill>
+                  <a:srgbClr val="333333"/>
+                </a:solidFill>
+              </a:defRPr>
+            </a:pPr>
+            <a:r>
+              <a:t>◆ 計算引擎未提供任何指標數據，無法執行散佈圖分析。這可能反映資料來源尚未完成處理、欄位映射錯誤，或該頁面所需的雙變量指標（如規模指標與成長率指標）在原始資料中不存在。建議行動：(1) 確認原始資料是否包含可配對的規模與成長指標；(2) 檢查資料處理流程是否正確提取並計算相關指標；(3) 若資料確實缺失，考慮調整簡報結構，移除此頁或以替代分析方式呈現。</a:t>
+            </a:r>
+          </a:p>
+        </p:txBody>
+      </p:sp>
     </p:spTree>
   </p:cSld>
   <p:clrMapOvr>
@@ -11045,7 +9897,7 @@
               </a:defRPr>
             </a:pPr>
             <a:r>
-              <a:t>有效卡率比較</a:t>
+              <a:t>簽帳金額市占率比較</a:t>
             </a:r>
           </a:p>
         </p:txBody>
@@ -11115,7 +9967,7 @@
               </a:defRPr>
             </a:pPr>
             <a:r>
-              <a:t>◆ 各銀行簽帳金額比較</a:t>
+              <a:t>◆ 無法產生洞察：計算引擎未提供任何市占率數據</a:t>
             </a:r>
           </a:p>
         </p:txBody>
@@ -11138,6 +9990,41 @@
           </a:graphicData>
         </a:graphic>
       </p:graphicFrame>
+      <p:sp>
+        <p:nvSpPr>
+          <p:cNvPr id="7" name="TextBox 6"/>
+          <p:cNvSpPr txBox="1"/>
+          <p:nvPr/>
+        </p:nvSpPr>
+        <p:spPr>
+          <a:xfrm>
+            <a:off x="540000" y="5400000"/>
+            <a:ext cx="10800000" cy="432000"/>
+          </a:xfrm>
+          <a:prstGeom prst="rect">
+            <a:avLst/>
+          </a:prstGeom>
+          <a:noFill/>
+        </p:spPr>
+        <p:txBody>
+          <a:bodyPr wrap="square">
+            <a:spAutoFit/>
+          </a:bodyPr>
+          <a:lstStyle/>
+          <a:p>
+            <a:pPr>
+              <a:defRPr sz="1100">
+                <a:solidFill>
+                  <a:srgbClr val="333333"/>
+                </a:solidFill>
+              </a:defRPr>
+            </a:pPr>
+            <a:r>
+              <a:t>◆ 本頁規劃為「簽帳金額市占率比較」，但計算引擎回傳空白結果（[]），表示原始資料中缺少市占率指標或計算所需的基礎數據。這可能反映資料來源未涵蓋市場整體交易量，或資料處理階段未完成市占率計算。**建議行動**：(1) 確認原始資料是否包含各銀行簽帳金額與市場總量；(2) 若資料完整但未計算市占率，需補充計算邏輯；(3) 若資料本身不支援市占率分析，建議調整本頁主題為「簽帳金額絕對值比較」或移除此頁。</a:t>
+            </a:r>
+          </a:p>
+        </p:txBody>
+      </p:sp>
     </p:spTree>
   </p:cSld>
   <p:clrMapOvr>

</xml_diff>